<commit_message>
chore: gitignore PROGRESS.md + 更新用户指南/技术设计 PPT
- .gitignore: 新增 PROGRESS.md 规则（运行时进度文件不入库）
- flow-kit-用户指南.pptx: Slide 5 + /flow model 命令, Slide 16 + correction 类型收割
- flow-kit-技术设计.pptx: Slide 15 + correction 收割策略

Co-Authored-By: Claude <noreply@anthropic.com>
</commit_message>
<xml_diff>
--- a/flow-kit-用户指南.pptx
+++ b/flow-kit-用户指南.pptx
@@ -18,6 +18,7 @@
     <p:sldId id="266" r:id="rId17"/>
     <p:sldId id="267" r:id="rId18"/>
     <p:sldId id="268" r:id="rId19"/>
+    <p:sldId id="274" r:id="rId25"/>
     <p:sldId id="269" r:id="rId20"/>
     <p:sldId id="270" r:id="rId21"/>
     <p:sldId id="271" r:id="rId22"/>
@@ -3256,7 +3257,7 @@
                 <a:latin typeface="Times New Roman"/>
                 <a:ea typeface="宋体"/>
               </a:rPr>
-              <a:t>2026-07-13  |  github.com/hellrabb/flow-kit</a:t>
+              <a:t>2026-07-24  |  github.com/hellrabb/flow-kit</a:t>
             </a:r>
           </a:p>
         </p:txBody>
@@ -4987,18 +4988,19 @@
         </p:nvSpPr>
         <p:spPr>
           <a:xfrm>
-            <a:off x="731520" y="320040"/>
-            <a:ext cx="54864" cy="365760"/>
+            <a:off x="-45720" y="-45720"/>
+            <a:ext cx="12283135" cy="6949440"/>
           </a:xfrm>
           <a:prstGeom prst="rect">
             <a:avLst/>
           </a:prstGeom>
           <a:solidFill>
-            <a:srgbClr val="2563EB"/>
+            <a:srgbClr val="FFFFFF"/>
           </a:solidFill>
           <a:ln>
             <a:noFill/>
           </a:ln>
+          <a:effectLst/>
         </p:spPr>
         <p:style>
           <a:lnRef idx="1">
@@ -5024,61 +5026,25 @@
       </p:sp>
       <p:sp>
         <p:nvSpPr>
-          <p:cNvPr id="3" name="TextBox 2"/>
-          <p:cNvSpPr txBox="1"/>
-          <p:nvPr/>
-        </p:nvSpPr>
-        <p:spPr>
-          <a:xfrm>
-            <a:off x="914400" y="274320"/>
-            <a:ext cx="10515600" cy="502920"/>
-          </a:xfrm>
-          <a:prstGeom prst="rect">
-            <a:avLst/>
-          </a:prstGeom>
-          <a:noFill/>
-        </p:spPr>
-        <p:txBody>
-          <a:bodyPr wrap="square">
-            <a:spAutoFit/>
-          </a:bodyPr>
-          <a:lstStyle/>
-          <a:p>
-            <a:r>
-              <a:rPr sz="2400" b="1" i="0">
-                <a:solidFill>
-                  <a:srgbClr val="1E293B"/>
-                </a:solidFill>
-                <a:latin typeface="Times New Roman"/>
-                <a:ea typeface="宋体"/>
-              </a:rPr>
-              <a:t>横向命令（独立于流水线）</a:t>
-            </a:r>
-          </a:p>
-        </p:txBody>
-      </p:sp>
-      <p:sp>
-        <p:nvSpPr>
-          <p:cNvPr id="4" name="Rectangle 3"/>
+          <p:cNvPr id="3" name="Rectangle 2"/>
           <p:cNvSpPr/>
           <p:nvPr/>
         </p:nvSpPr>
         <p:spPr>
           <a:xfrm>
-            <a:off x="731520" y="1234440"/>
-            <a:ext cx="3291840" cy="2103120"/>
+            <a:off x="0" y="0"/>
+            <a:ext cx="12191695" cy="1051560"/>
           </a:xfrm>
           <a:prstGeom prst="rect">
             <a:avLst/>
           </a:prstGeom>
           <a:solidFill>
-            <a:srgbClr val="FFFFFF"/>
+            <a:srgbClr val="1F3A5F"/>
           </a:solidFill>
-          <a:ln w="12700">
-            <a:solidFill>
-              <a:srgbClr val="E2E8F0"/>
-            </a:solidFill>
+          <a:ln>
+            <a:noFill/>
           </a:ln>
+          <a:effectLst/>
         </p:spPr>
         <p:style>
           <a:lnRef idx="1">
@@ -5104,14 +5070,73 @@
       </p:sp>
       <p:sp>
         <p:nvSpPr>
+          <p:cNvPr id="4" name="TextBox 3"/>
+          <p:cNvSpPr txBox="1"/>
+          <p:nvPr/>
+        </p:nvSpPr>
+        <p:spPr>
+          <a:xfrm>
+            <a:off x="457200" y="137160"/>
+            <a:ext cx="11277295" cy="822960"/>
+          </a:xfrm>
+          <a:prstGeom prst="rect">
+            <a:avLst/>
+          </a:prstGeom>
+          <a:noFill/>
+        </p:spPr>
+        <p:txBody>
+          <a:bodyPr wrap="square" anchor="ctr">
+            <a:spAutoFit/>
+          </a:bodyPr>
+          <a:lstStyle/>
+          <a:p>
+            <a:pPr>
+              <a:spcAft>
+                <a:spcPts val="400"/>
+              </a:spcAft>
+            </a:pPr>
+            <a:r>
+              <a:rPr sz="2600" b="1">
+                <a:solidFill>
+                  <a:srgbClr val="FFFFFF"/>
+                </a:solidFill>
+                <a:latin typeface="Times New Roman"/>
+                <a:ea typeface="宋体"/>
+                <a:cs typeface="宋体"/>
+              </a:rPr>
+              <a:t>L2/L3 模型配置三级优先级链</a:t>
+            </a:r>
+          </a:p>
+          <a:p>
+            <a:pPr>
+              <a:spcAft>
+                <a:spcPts val="400"/>
+              </a:spcAft>
+            </a:pPr>
+            <a:r>
+              <a:rPr sz="1200" b="0">
+                <a:solidFill>
+                  <a:srgbClr val="A8C4E0"/>
+                </a:solidFill>
+                <a:latin typeface="Times New Roman"/>
+                <a:ea typeface="宋体"/>
+                <a:cs typeface="宋体"/>
+              </a:rPr>
+              <a:t>ADR-012 / ADR-013 · fk_resolve_model · 2026-07-24</a:t>
+            </a:r>
+          </a:p>
+        </p:txBody>
+      </p:sp>
+      <p:sp>
+        <p:nvSpPr>
           <p:cNvPr id="5" name="TextBox 4"/>
           <p:cNvSpPr txBox="1"/>
           <p:nvPr/>
         </p:nvSpPr>
         <p:spPr>
           <a:xfrm>
-            <a:off x="914400" y="1371600"/>
-            <a:ext cx="2926080" cy="365760"/>
+            <a:off x="548640" y="1280160"/>
+            <a:ext cx="11094415" cy="5212080"/>
           </a:xfrm>
           <a:prstGeom prst="rect">
             <a:avLst/>
@@ -5124,525 +5149,147 @@
           </a:bodyPr>
           <a:lstStyle/>
           <a:p>
-            <a:r>
-              <a:rPr sz="1400" b="1" i="0">
-                <a:solidFill>
-                  <a:srgbClr val="2563EB"/>
-                </a:solidFill>
-                <a:latin typeface="Times New Roman"/>
-                <a:ea typeface="宋体"/>
-              </a:rPr>
-              <a:t>I-intel · 入场扫描</a:t>
-            </a:r>
-          </a:p>
-        </p:txBody>
-      </p:sp>
-      <p:sp>
-        <p:nvSpPr>
-          <p:cNvPr id="6" name="TextBox 5"/>
-          <p:cNvSpPr txBox="1"/>
-          <p:nvPr/>
-        </p:nvSpPr>
-        <p:spPr>
-          <a:xfrm>
-            <a:off x="914400" y="1783080"/>
-            <a:ext cx="2926080" cy="1371600"/>
-          </a:xfrm>
-          <a:prstGeom prst="rect">
-            <a:avLst/>
-          </a:prstGeom>
-          <a:noFill/>
-        </p:spPr>
-        <p:txBody>
-          <a:bodyPr wrap="square">
-            <a:spAutoFit/>
-          </a:bodyPr>
-          <a:lstStyle/>
-          <a:p>
-            <a:r>
-              <a:rPr sz="1000" b="0" i="0">
-                <a:solidFill>
-                  <a:srgbClr val="475569"/>
-                </a:solidFill>
-                <a:latin typeface="Times New Roman"/>
-                <a:ea typeface="宋体"/>
-              </a:rPr>
-              <a:t>生成 CONTEXT.md
-术语表 + 既有抽象索引
-+ 禁动清单 + 命名约定
-首次使用 flow-kit 必跑</a:t>
-            </a:r>
-          </a:p>
-        </p:txBody>
-      </p:sp>
-      <p:sp>
-        <p:nvSpPr>
-          <p:cNvPr id="7" name="Rectangle 6"/>
-          <p:cNvSpPr/>
-          <p:nvPr/>
-        </p:nvSpPr>
-        <p:spPr>
-          <a:xfrm>
-            <a:off x="4251960" y="1234440"/>
-            <a:ext cx="3291840" cy="2103120"/>
-          </a:xfrm>
-          <a:prstGeom prst="rect">
-            <a:avLst/>
-          </a:prstGeom>
-          <a:solidFill>
-            <a:srgbClr val="FFFFFF"/>
-          </a:solidFill>
-          <a:ln w="12700">
-            <a:solidFill>
-              <a:srgbClr val="E2E8F0"/>
-            </a:solidFill>
-          </a:ln>
-        </p:spPr>
-        <p:style>
-          <a:lnRef idx="1">
-            <a:schemeClr val="accent1"/>
-          </a:lnRef>
-          <a:fillRef idx="3">
-            <a:schemeClr val="accent1"/>
-          </a:fillRef>
-          <a:effectRef idx="2">
-            <a:schemeClr val="accent1"/>
-          </a:effectRef>
-          <a:fontRef idx="minor">
-            <a:schemeClr val="lt1"/>
-          </a:fontRef>
-        </p:style>
-        <p:txBody>
-          <a:bodyPr rtlCol="0" anchor="ctr"/>
-          <a:lstStyle/>
-          <a:p>
-            <a:pPr algn="ctr"/>
-          </a:p>
-        </p:txBody>
-      </p:sp>
-      <p:sp>
-        <p:nvSpPr>
-          <p:cNvPr id="8" name="TextBox 7"/>
-          <p:cNvSpPr txBox="1"/>
-          <p:nvPr/>
-        </p:nvSpPr>
-        <p:spPr>
-          <a:xfrm>
-            <a:off x="4434840" y="1371600"/>
-            <a:ext cx="2926080" cy="365760"/>
-          </a:xfrm>
-          <a:prstGeom prst="rect">
-            <a:avLst/>
-          </a:prstGeom>
-          <a:noFill/>
-        </p:spPr>
-        <p:txBody>
-          <a:bodyPr wrap="square">
-            <a:spAutoFit/>
-          </a:bodyPr>
-          <a:lstStyle/>
-          <a:p>
-            <a:r>
-              <a:rPr sz="1400" b="1" i="0">
-                <a:solidFill>
-                  <a:srgbClr val="2563EB"/>
-                </a:solidFill>
-                <a:latin typeface="Times New Roman"/>
-                <a:ea typeface="宋体"/>
-              </a:rPr>
-              <a:t>M-health · 健康巡检</a:t>
-            </a:r>
-          </a:p>
-        </p:txBody>
-      </p:sp>
-      <p:sp>
-        <p:nvSpPr>
-          <p:cNvPr id="9" name="TextBox 8"/>
-          <p:cNvSpPr txBox="1"/>
-          <p:nvPr/>
-        </p:nvSpPr>
-        <p:spPr>
-          <a:xfrm>
-            <a:off x="4434840" y="1783080"/>
-            <a:ext cx="2926080" cy="1371600"/>
-          </a:xfrm>
-          <a:prstGeom prst="rect">
-            <a:avLst/>
-          </a:prstGeom>
-          <a:noFill/>
-        </p:spPr>
-        <p:txBody>
-          <a:bodyPr wrap="square">
-            <a:spAutoFit/>
-          </a:bodyPr>
-          <a:lstStyle/>
-          <a:p>
-            <a:r>
-              <a:rPr sz="1000" b="0" i="0">
-                <a:solidFill>
-                  <a:srgbClr val="475569"/>
-                </a:solidFill>
-                <a:latin typeface="Times New Roman"/>
-                <a:ea typeface="宋体"/>
-              </a:rPr>
-              <a:t>代码库健康诊断 + 技术债盘点
-快速/标准/深度三种模式
-brooks-lint 优先，AI 内置回退
-冗余扫描：jscpd/knip/depcheck</a:t>
-            </a:r>
-          </a:p>
-        </p:txBody>
-      </p:sp>
-      <p:sp>
-        <p:nvSpPr>
-          <p:cNvPr id="10" name="Rectangle 9"/>
-          <p:cNvSpPr/>
-          <p:nvPr/>
-        </p:nvSpPr>
-        <p:spPr>
-          <a:xfrm>
-            <a:off x="7772400" y="1234440"/>
-            <a:ext cx="3291840" cy="2103120"/>
-          </a:xfrm>
-          <a:prstGeom prst="rect">
-            <a:avLst/>
-          </a:prstGeom>
-          <a:solidFill>
-            <a:srgbClr val="FFFFFF"/>
-          </a:solidFill>
-          <a:ln w="12700">
-            <a:solidFill>
-              <a:srgbClr val="E2E8F0"/>
-            </a:solidFill>
-          </a:ln>
-        </p:spPr>
-        <p:style>
-          <a:lnRef idx="1">
-            <a:schemeClr val="accent1"/>
-          </a:lnRef>
-          <a:fillRef idx="3">
-            <a:schemeClr val="accent1"/>
-          </a:fillRef>
-          <a:effectRef idx="2">
-            <a:schemeClr val="accent1"/>
-          </a:effectRef>
-          <a:fontRef idx="minor">
-            <a:schemeClr val="lt1"/>
-          </a:fontRef>
-        </p:style>
-        <p:txBody>
-          <a:bodyPr rtlCol="0" anchor="ctr"/>
-          <a:lstStyle/>
-          <a:p>
-            <a:pPr algn="ctr"/>
-          </a:p>
-        </p:txBody>
-      </p:sp>
-      <p:sp>
-        <p:nvSpPr>
-          <p:cNvPr id="11" name="TextBox 10"/>
-          <p:cNvSpPr txBox="1"/>
-          <p:nvPr/>
-        </p:nvSpPr>
-        <p:spPr>
-          <a:xfrm>
-            <a:off x="7955280" y="1371600"/>
-            <a:ext cx="2926080" cy="365760"/>
-          </a:xfrm>
-          <a:prstGeom prst="rect">
-            <a:avLst/>
-          </a:prstGeom>
-          <a:noFill/>
-        </p:spPr>
-        <p:txBody>
-          <a:bodyPr wrap="square">
-            <a:spAutoFit/>
-          </a:bodyPr>
-          <a:lstStyle/>
-          <a:p>
-            <a:r>
-              <a:rPr sz="1400" b="1" i="0">
-                <a:solidFill>
-                  <a:srgbClr val="2563EB"/>
-                </a:solidFill>
-                <a:latin typeface="Times New Roman"/>
-                <a:ea typeface="宋体"/>
-              </a:rPr>
-              <a:t>A-architect · 架构文档</a:t>
-            </a:r>
-          </a:p>
-        </p:txBody>
-      </p:sp>
-      <p:sp>
-        <p:nvSpPr>
-          <p:cNvPr id="12" name="TextBox 11"/>
-          <p:cNvSpPr txBox="1"/>
-          <p:nvPr/>
-        </p:nvSpPr>
-        <p:spPr>
-          <a:xfrm>
-            <a:off x="7955280" y="1783080"/>
-            <a:ext cx="2926080" cy="1371600"/>
-          </a:xfrm>
-          <a:prstGeom prst="rect">
-            <a:avLst/>
-          </a:prstGeom>
-          <a:noFill/>
-        </p:spPr>
-        <p:txBody>
-          <a:bodyPr wrap="square">
-            <a:spAutoFit/>
-          </a:bodyPr>
-          <a:lstStyle/>
-          <a:p>
-            <a:r>
-              <a:rPr sz="1000" b="0" i="0">
-                <a:solidFill>
-                  <a:srgbClr val="475569"/>
-                </a:solidFill>
-                <a:latin typeface="Times New Roman"/>
-                <a:ea typeface="宋体"/>
-              </a:rPr>
-              <a:t>生成 ARCHITECTURE.md + ADR
-系统概览 + 模块清单
-+ 跨模块契约 + 容量边界
-首次/重构时建立</a:t>
-            </a:r>
-          </a:p>
-        </p:txBody>
-      </p:sp>
-      <p:sp>
-        <p:nvSpPr>
-          <p:cNvPr id="13" name="Rectangle 12"/>
-          <p:cNvSpPr/>
-          <p:nvPr/>
-        </p:nvSpPr>
-        <p:spPr>
-          <a:xfrm>
-            <a:off x="731520" y="3566160"/>
-            <a:ext cx="3291840" cy="2103120"/>
-          </a:xfrm>
-          <a:prstGeom prst="rect">
-            <a:avLst/>
-          </a:prstGeom>
-          <a:solidFill>
-            <a:srgbClr val="FFFFFF"/>
-          </a:solidFill>
-          <a:ln w="12700">
-            <a:solidFill>
-              <a:srgbClr val="E2E8F0"/>
-            </a:solidFill>
-          </a:ln>
-        </p:spPr>
-        <p:style>
-          <a:lnRef idx="1">
-            <a:schemeClr val="accent1"/>
-          </a:lnRef>
-          <a:fillRef idx="3">
-            <a:schemeClr val="accent1"/>
-          </a:fillRef>
-          <a:effectRef idx="2">
-            <a:schemeClr val="accent1"/>
-          </a:effectRef>
-          <a:fontRef idx="minor">
-            <a:schemeClr val="lt1"/>
-          </a:fontRef>
-        </p:style>
-        <p:txBody>
-          <a:bodyPr rtlCol="0" anchor="ctr"/>
-          <a:lstStyle/>
-          <a:p>
-            <a:pPr algn="ctr"/>
-          </a:p>
-        </p:txBody>
-      </p:sp>
-      <p:sp>
-        <p:nvSpPr>
-          <p:cNvPr id="14" name="TextBox 13"/>
-          <p:cNvSpPr txBox="1"/>
-          <p:nvPr/>
-        </p:nvSpPr>
-        <p:spPr>
-          <a:xfrm>
-            <a:off x="914400" y="3703320"/>
-            <a:ext cx="2926080" cy="365760"/>
-          </a:xfrm>
-          <a:prstGeom prst="rect">
-            <a:avLst/>
-          </a:prstGeom>
-          <a:noFill/>
-        </p:spPr>
-        <p:txBody>
-          <a:bodyPr wrap="square">
-            <a:spAutoFit/>
-          </a:bodyPr>
-          <a:lstStyle/>
-          <a:p>
-            <a:r>
-              <a:rPr sz="1400" b="1" i="0">
-                <a:solidFill>
-                  <a:srgbClr val="2563EB"/>
-                </a:solidFill>
-                <a:latin typeface="Times New Roman"/>
-                <a:ea typeface="宋体"/>
-              </a:rPr>
-              <a:t>A-evolve · 架构沉淀</a:t>
-            </a:r>
-          </a:p>
-        </p:txBody>
-      </p:sp>
-      <p:sp>
-        <p:nvSpPr>
-          <p:cNvPr id="15" name="TextBox 14"/>
-          <p:cNvSpPr txBox="1"/>
-          <p:nvPr/>
-        </p:nvSpPr>
-        <p:spPr>
-          <a:xfrm>
-            <a:off x="914400" y="4114800"/>
-            <a:ext cx="2926080" cy="1371600"/>
-          </a:xfrm>
-          <a:prstGeom prst="rect">
-            <a:avLst/>
-          </a:prstGeom>
-          <a:noFill/>
-        </p:spPr>
-        <p:txBody>
-          <a:bodyPr wrap="square">
-            <a:spAutoFit/>
-          </a:bodyPr>
-          <a:lstStyle/>
-          <a:p>
-            <a:r>
-              <a:rPr sz="1000" b="0" i="0">
-                <a:solidFill>
-                  <a:srgbClr val="475569"/>
-                </a:solidFill>
-                <a:latin typeface="Times New Roman"/>
-                <a:ea typeface="宋体"/>
-              </a:rPr>
-              <a:t>扫描已归档 DESIGN.md §9
-聚合分类 → 用户 review
-→ patch CONTEXT.md
-+ ARCHITECTURE.md</a:t>
-            </a:r>
-          </a:p>
-        </p:txBody>
-      </p:sp>
-      <p:sp>
-        <p:nvSpPr>
-          <p:cNvPr id="16" name="Rectangle 15"/>
-          <p:cNvSpPr/>
-          <p:nvPr/>
-        </p:nvSpPr>
-        <p:spPr>
-          <a:xfrm>
-            <a:off x="4251960" y="3566160"/>
-            <a:ext cx="3291840" cy="2103120"/>
-          </a:xfrm>
-          <a:prstGeom prst="rect">
-            <a:avLst/>
-          </a:prstGeom>
-          <a:solidFill>
-            <a:srgbClr val="FFFFFF"/>
-          </a:solidFill>
-          <a:ln w="12700">
-            <a:solidFill>
-              <a:srgbClr val="E2E8F0"/>
-            </a:solidFill>
-          </a:ln>
-        </p:spPr>
-        <p:style>
-          <a:lnRef idx="1">
-            <a:schemeClr val="accent1"/>
-          </a:lnRef>
-          <a:fillRef idx="3">
-            <a:schemeClr val="accent1"/>
-          </a:fillRef>
-          <a:effectRef idx="2">
-            <a:schemeClr val="accent1"/>
-          </a:effectRef>
-          <a:fontRef idx="minor">
-            <a:schemeClr val="lt1"/>
-          </a:fontRef>
-        </p:style>
-        <p:txBody>
-          <a:bodyPr rtlCol="0" anchor="ctr"/>
-          <a:lstStyle/>
-          <a:p>
-            <a:pPr algn="ctr"/>
-          </a:p>
-        </p:txBody>
-      </p:sp>
-      <p:sp>
-        <p:nvSpPr>
-          <p:cNvPr id="17" name="TextBox 16"/>
-          <p:cNvSpPr txBox="1"/>
-          <p:nvPr/>
-        </p:nvSpPr>
-        <p:spPr>
-          <a:xfrm>
-            <a:off x="4434840" y="3703320"/>
-            <a:ext cx="2926080" cy="365760"/>
-          </a:xfrm>
-          <a:prstGeom prst="rect">
-            <a:avLst/>
-          </a:prstGeom>
-          <a:noFill/>
-        </p:spPr>
-        <p:txBody>
-          <a:bodyPr wrap="square">
-            <a:spAutoFit/>
-          </a:bodyPr>
-          <a:lstStyle/>
-          <a:p>
-            <a:r>
-              <a:rPr sz="1400" b="1" i="0">
-                <a:solidFill>
-                  <a:srgbClr val="2563EB"/>
-                </a:solidFill>
-                <a:latin typeface="Times New Roman"/>
-                <a:ea typeface="宋体"/>
-              </a:rPr>
-              <a:t>L-restyle · 视觉重构</a:t>
-            </a:r>
-          </a:p>
-        </p:txBody>
-      </p:sp>
-      <p:sp>
-        <p:nvSpPr>
-          <p:cNvPr id="18" name="TextBox 17"/>
-          <p:cNvSpPr txBox="1"/>
-          <p:nvPr/>
-        </p:nvSpPr>
-        <p:spPr>
-          <a:xfrm>
-            <a:off x="4434840" y="4114800"/>
-            <a:ext cx="2926080" cy="1371600"/>
-          </a:xfrm>
-          <a:prstGeom prst="rect">
-            <a:avLst/>
-          </a:prstGeom>
-          <a:noFill/>
-        </p:spPr>
-        <p:txBody>
-          <a:bodyPr wrap="square">
-            <a:spAutoFit/>
-          </a:bodyPr>
-          <a:lstStyle/>
-          <a:p>
-            <a:r>
-              <a:rPr sz="1000" b="0" i="0">
-                <a:solidFill>
-                  <a:srgbClr val="475569"/>
-                </a:solidFill>
-                <a:latin typeface="Times New Roman"/>
-                <a:ea typeface="宋体"/>
-              </a:rPr>
-              <a:t>保留功能，重做 UI 视觉
-自动生成 change-id
-v1→v2 视觉对照表
-组件库迁移/品牌升级适用</a:t>
+            <a:pPr>
+              <a:spcAft>
+                <a:spcPts val="800"/>
+              </a:spcAft>
+            </a:pPr>
+            <a:r>
+              <a:rPr sz="1500" b="0">
+                <a:solidFill>
+                  <a:srgbClr val="1F3A5F"/>
+                </a:solidFill>
+                <a:latin typeface="Times New Roman"/>
+                <a:ea typeface="宋体"/>
+                <a:cs typeface="宋体"/>
+              </a:rPr>
+              <a:t>公共函数 fk_resolve_model &lt;layer&gt;（hooks/stop/lib/common.sh）按三级优先级链解析——每级取非空值即停，全空优雅降级（不崩溃、不阻塞 session）。</a:t>
+            </a:r>
+          </a:p>
+          <a:p>
+            <a:pPr lvl="1">
+              <a:spcAft>
+                <a:spcPts val="300"/>
+              </a:spcAft>
+            </a:pPr>
+            <a:r>
+              <a:rPr sz="1300" b="0">
+                <a:solidFill>
+                  <a:srgbClr val="2E86AB"/>
+                </a:solidFill>
+                <a:latin typeface="Times New Roman"/>
+                <a:ea typeface="宋体"/>
+                <a:cs typeface="宋体"/>
+              </a:rPr>
+              <a:t>优先级 1 · ANTHROPIC_DEFAULT_HAIKU_MODEL (L3) / ANTHROPIC_L2_MODEL (L2) — CC 原生 env，CC 用户优先命中</a:t>
+            </a:r>
+          </a:p>
+          <a:p>
+            <a:pPr lvl="1">
+              <a:spcAft>
+                <a:spcPts val="300"/>
+              </a:spcAft>
+            </a:pPr>
+            <a:r>
+              <a:rPr sz="1300" b="0">
+                <a:solidFill>
+                  <a:srgbClr val="2E86AB"/>
+                </a:solidFill>
+                <a:latin typeface="Times New Roman"/>
+                <a:ea typeface="宋体"/>
+                <a:cs typeface="宋体"/>
+              </a:rPr>
+              <a:t>优先级 2 · FLOW_KIT_L3_MODEL / FLOW_KIT_L2_MODEL — 新增，临时覆盖（export 即生效）</a:t>
+            </a:r>
+          </a:p>
+          <a:p>
+            <a:pPr lvl="1">
+              <a:spcAft>
+                <a:spcPts val="300"/>
+              </a:spcAft>
+            </a:pPr>
+            <a:r>
+              <a:rPr sz="1300" b="0">
+                <a:solidFill>
+                  <a:srgbClr val="2E86AB"/>
+                </a:solidFill>
+                <a:latin typeface="Times New Roman"/>
+                <a:ea typeface="宋体"/>
+                <a:cs typeface="宋体"/>
+              </a:rPr>
+              <a:t>优先级 3 · .flow-active.goal.l3_model / l2_model — 持久化，由 /flow model l*=&lt;模型&gt; 写入</a:t>
+            </a:r>
+          </a:p>
+          <a:p>
+            <a:pPr lvl="1">
+              <a:spcAft>
+                <a:spcPts val="800"/>
+              </a:spcAft>
+            </a:pPr>
+            <a:r>
+              <a:rPr sz="1300" b="0">
+                <a:solidFill>
+                  <a:srgbClr val="C7463B"/>
+                </a:solidFill>
+                <a:latin typeface="Times New Roman"/>
+                <a:ea typeface="宋体"/>
+                <a:cs typeface="宋体"/>
+              </a:rPr>
+              <a:t>全空 → 优雅降级：写 .flow-active.correction（l3/l2-model-missing）+ stderr 提示，29 顶层 exit 3 不阻塞 gate 链</a:t>
+            </a:r>
+          </a:p>
+          <a:p>
+            <a:pPr>
+              <a:spcAft>
+                <a:spcPts val="400"/>
+              </a:spcAft>
+            </a:pPr>
+            <a:r>
+              <a:rPr sz="1300" b="0">
+                <a:solidFill>
+                  <a:srgbClr val="1F3A5F"/>
+                </a:solidFill>
+                <a:latin typeface="Times New Roman"/>
+                <a:ea typeface="宋体"/>
+                <a:cs typeface="宋体"/>
+              </a:rPr>
+              <a:t>ADR-013 覆盖写策略：compliance &gt; model-missing — 当前 correction 若为 compliance 且 violations 非空则不覆盖（保安全信息）；否则覆盖为 model-missing。</a:t>
+            </a:r>
+          </a:p>
+          <a:p>
+            <a:pPr>
+              <a:spcAft>
+                <a:spcPts val="400"/>
+              </a:spcAft>
+            </a:pPr>
+            <a:r>
+              <a:rPr sz="1300" b="0">
+                <a:solidFill>
+                  <a:srgbClr val="6C757D"/>
+                </a:solidFill>
+                <a:latin typeface="Times New Roman"/>
+                <a:ea typeface="宋体"/>
+                <a:cs typeface="宋体"/>
+              </a:rPr>
+              <a:t>SessionStart 收割：flow-kit-resume.sh 按 type 分类型——compliance/未知删；l3/l2-model-missing 持续提示（由 write_model_missing_clear 退场）。</a:t>
+            </a:r>
+          </a:p>
+          <a:p>
+            <a:pPr>
+              <a:spcAft>
+                <a:spcPts val="400"/>
+              </a:spcAft>
+            </a:pPr>
+            <a:r>
+              <a:rPr sz="1200" b="0">
+                <a:solidFill>
+                  <a:srgbClr val="6C757D"/>
+                </a:solidFill>
+                <a:latin typeface="Times New Roman"/>
+                <a:ea typeface="宋体"/>
+                <a:cs typeface="宋体"/>
+              </a:rPr>
+              <a:t>L2 已移除 claude-sonnet-5 fallback（纯跨平台）；未设 env 的 CC 用户升级后 L2 将降级，CHANGELOG 标注。</a:t>
             </a:r>
           </a:p>
         </p:txBody>
@@ -5738,21 +5385,66 @@
                 <a:latin typeface="Times New Roman"/>
                 <a:ea typeface="宋体"/>
               </a:rPr>
-              <a:t>Stop Hook 系统（17 模块）</a:t>
-            </a:r>
-          </a:p>
-        </p:txBody>
-      </p:sp>
-      <p:sp>
-        <p:nvSpPr>
-          <p:cNvPr id="4" name="TextBox 3"/>
+              <a:t>横向命令（独立于流水线）</a:t>
+            </a:r>
+          </a:p>
+        </p:txBody>
+      </p:sp>
+      <p:sp>
+        <p:nvSpPr>
+          <p:cNvPr id="4" name="Rectangle 3"/>
+          <p:cNvSpPr/>
+          <p:nvPr/>
+        </p:nvSpPr>
+        <p:spPr>
+          <a:xfrm>
+            <a:off x="731520" y="1234440"/>
+            <a:ext cx="3291840" cy="2103120"/>
+          </a:xfrm>
+          <a:prstGeom prst="rect">
+            <a:avLst/>
+          </a:prstGeom>
+          <a:solidFill>
+            <a:srgbClr val="FFFFFF"/>
+          </a:solidFill>
+          <a:ln w="12700">
+            <a:solidFill>
+              <a:srgbClr val="E2E8F0"/>
+            </a:solidFill>
+          </a:ln>
+        </p:spPr>
+        <p:style>
+          <a:lnRef idx="1">
+            <a:schemeClr val="accent1"/>
+          </a:lnRef>
+          <a:fillRef idx="3">
+            <a:schemeClr val="accent1"/>
+          </a:fillRef>
+          <a:effectRef idx="2">
+            <a:schemeClr val="accent1"/>
+          </a:effectRef>
+          <a:fontRef idx="minor">
+            <a:schemeClr val="lt1"/>
+          </a:fontRef>
+        </p:style>
+        <p:txBody>
+          <a:bodyPr rtlCol="0" anchor="ctr"/>
+          <a:lstStyle/>
+          <a:p>
+            <a:pPr algn="ctr"/>
+          </a:p>
+        </p:txBody>
+      </p:sp>
+      <p:sp>
+        <p:nvSpPr>
+          <p:cNvPr id="5" name="TextBox 4"/>
           <p:cNvSpPr txBox="1"/>
           <p:nvPr/>
         </p:nvSpPr>
         <p:spPr>
           <a:xfrm>
-            <a:off x="731520" y="1280160"/>
-            <a:ext cx="10698480" cy="4754880"/>
+            <a:off x="914400" y="1371600"/>
+            <a:ext cx="2926080" cy="365760"/>
           </a:xfrm>
           <a:prstGeom prst="rect">
             <a:avLst/>
@@ -5766,269 +5458,524 @@
           <a:lstStyle/>
           <a:p>
             <a:r>
-              <a:rPr sz="1400" b="0" i="0">
-                <a:solidFill>
-                  <a:srgbClr val="475569"/>
-                </a:solidFill>
-                <a:latin typeface="Times New Roman"/>
-                <a:ea typeface="宋体"/>
-              </a:rPr>
-              <a:t>每次 Claude Code 会话结束时自动运行的模块化后处理脚本链：</a:t>
-            </a:r>
-          </a:p>
-          <a:p>
-            <a:pPr>
-              <a:spcBef>
-                <a:spcPts val="600"/>
-              </a:spcBef>
-            </a:pPr>
-            <a:r>
-              <a:rPr sz="600" b="0" i="0">
-                <a:solidFill>
-                  <a:srgbClr val="475569"/>
-                </a:solidFill>
-                <a:latin typeface="Times New Roman"/>
-                <a:ea typeface="宋体"/>
-              </a:rPr>
-              <a:t/>
-            </a:r>
-          </a:p>
-          <a:p>
-            <a:pPr>
-              <a:spcBef>
-                <a:spcPts val="600"/>
-              </a:spcBef>
-            </a:pPr>
-            <a:r>
-              <a:rPr sz="1200" b="0" i="0">
-                <a:solidFill>
-                  <a:srgbClr val="475569"/>
-                </a:solidFill>
-                <a:latin typeface="Times New Roman"/>
-                <a:ea typeface="宋体"/>
-              </a:rPr>
-              <a:t>🔹 基础设施：00-gate（入口门禁）| 01-transcript-parse（转录解析）</a:t>
-            </a:r>
-          </a:p>
-          <a:p>
-            <a:pPr>
-              <a:spcBef>
-                <a:spcPts val="600"/>
-              </a:spcBef>
-            </a:pPr>
-            <a:r>
-              <a:rPr sz="1200" b="0" i="0">
-                <a:solidFill>
-                  <a:srgbClr val="475569"/>
-                </a:solidFill>
-                <a:latin typeface="Times New Roman"/>
-                <a:ea typeface="宋体"/>
-              </a:rPr>
-              <a:t>🔹 文件质量：20-claude-md | 21-memory | 22-git | 23-quality | 24-session | 25-project</a:t>
-            </a:r>
-          </a:p>
-          <a:p>
-            <a:pPr>
-              <a:spcBef>
-                <a:spcPts val="600"/>
-              </a:spcBef>
-            </a:pPr>
-            <a:r>
-              <a:rPr sz="1200" b="0" i="0">
-                <a:solidFill>
-                  <a:srgbClr val="475569"/>
-                </a:solidFill>
-                <a:latin typeface="Times New Roman"/>
-                <a:ea typeface="宋体"/>
-              </a:rPr>
-              <a:t>🔹 工作流：26-workflow（阶段门禁 + 产物完整性 + 未完成 task + checkpoint 断层）</a:t>
-            </a:r>
-          </a:p>
-          <a:p>
-            <a:pPr>
-              <a:spcBef>
-                <a:spcPts val="600"/>
-              </a:spcBef>
-            </a:pPr>
-            <a:r>
-              <a:rPr sz="1200" b="0" i="0">
-                <a:solidFill>
-                  <a:srgbClr val="475569"/>
-                </a:solidFill>
-                <a:latin typeface="Times New Roman"/>
-                <a:ea typeface="宋体"/>
-              </a:rPr>
-              <a:t>🔹 弱模型护栏：27-interactive-ui-check（检测跳过交互 gate → 矫正文件）</a:t>
-            </a:r>
-          </a:p>
-          <a:p>
-            <a:pPr>
-              <a:spcBef>
-                <a:spcPts val="600"/>
-              </a:spcBef>
-            </a:pPr>
-            <a:r>
-              <a:rPr sz="1200" b="0" i="0">
-                <a:solidFill>
-                  <a:srgbClr val="475569"/>
-                </a:solidFill>
-                <a:latin typeface="Times New Roman"/>
-                <a:ea typeface="宋体"/>
-              </a:rPr>
-              <a:t>🔹 弱模型合规：28-weak-model-compliance（L1 规则 + L2 自检 + L3 证据链 → 矫正文件）</a:t>
-            </a:r>
-          </a:p>
-          <a:p>
-            <a:pPr>
-              <a:spcBef>
-                <a:spcPts val="600"/>
-              </a:spcBef>
-            </a:pPr>
-            <a:r>
-              <a:rPr sz="1200" b="0" i="0">
-                <a:solidFill>
-                  <a:srgbClr val="475569"/>
-                </a:solidFill>
-                <a:latin typeface="Times New Roman"/>
-                <a:ea typeface="宋体"/>
-              </a:rPr>
-              <a:t>🔹 独立审查：29-independent-review（L3 外部模型盲审，异步调度）</a:t>
-            </a:r>
-          </a:p>
-          <a:p>
-            <a:pPr>
-              <a:spcBef>
-                <a:spcPts val="600"/>
-              </a:spcBef>
-            </a:pPr>
-            <a:r>
-              <a:rPr sz="1200" b="0" i="0">
-                <a:solidFill>
-                  <a:srgbClr val="475569"/>
-                </a:solidFill>
-                <a:latin typeface="Times New Roman"/>
-                <a:ea typeface="宋体"/>
-              </a:rPr>
-              <a:t>🔹 AI 分析：30-ai-analyze（提交结构化数据给 AI 深度分析）</a:t>
-            </a:r>
-          </a:p>
-          <a:p>
-            <a:pPr>
-              <a:spcBef>
-                <a:spcPts val="600"/>
-              </a:spcBef>
-            </a:pPr>
-            <a:r>
-              <a:rPr sz="1200" b="0" i="0">
-                <a:solidFill>
-                  <a:srgbClr val="475569"/>
-                </a:solidFill>
-                <a:latin typeface="Times New Roman"/>
-                <a:ea typeface="宋体"/>
-              </a:rPr>
-              <a:t>🔹 自动推进：31-auto-advance（auto_advance=true 时自动 transition）</a:t>
-            </a:r>
-          </a:p>
-          <a:p>
-            <a:pPr>
-              <a:spcBef>
-                <a:spcPts val="600"/>
-              </a:spcBef>
-            </a:pPr>
-            <a:r>
-              <a:rPr sz="1200" b="0" i="0">
-                <a:solidFill>
-                  <a:srgbClr val="475569"/>
-                </a:solidFill>
-                <a:latin typeface="Times New Roman"/>
-                <a:ea typeface="宋体"/>
-              </a:rPr>
-              <a:t>🔹 回退兜底：32-fallback-guard（mode=fallback 时自动标记 goal.status=done）</a:t>
-            </a:r>
-          </a:p>
-          <a:p>
-            <a:pPr>
-              <a:spcBef>
-                <a:spcPts val="600"/>
-              </a:spcBef>
-            </a:pPr>
-            <a:r>
-              <a:rPr sz="1200" b="0" i="0">
-                <a:solidFill>
-                  <a:srgbClr val="475569"/>
-                </a:solidFill>
-                <a:latin typeface="Times New Roman"/>
-                <a:ea typeface="宋体"/>
-              </a:rPr>
-              <a:t>🔹 状态完整性：33-flow-active-integrity（.flow-active ↔ 磁盘产物交叉验证 + 时效性检测）</a:t>
-            </a:r>
-          </a:p>
-          <a:p>
-            <a:pPr>
-              <a:spcBef>
-                <a:spcPts val="600"/>
-              </a:spcBef>
-            </a:pPr>
-            <a:r>
-              <a:rPr sz="1200" b="0" i="0">
-                <a:solidFill>
-                  <a:srgbClr val="475569"/>
-                </a:solidFill>
-                <a:latin typeface="Times New Roman"/>
-                <a:ea typeface="宋体"/>
-              </a:rPr>
-              <a:t>🔹 报告：99-report（生成 stop-hook-report.md + token 用量展示）</a:t>
-            </a:r>
-          </a:p>
-          <a:p>
-            <a:pPr>
-              <a:spcBef>
-                <a:spcPts val="600"/>
-              </a:spcBef>
-            </a:pPr>
-            <a:r>
-              <a:rPr sz="600" b="0" i="0">
-                <a:solidFill>
-                  <a:srgbClr val="475569"/>
-                </a:solidFill>
-                <a:latin typeface="Times New Roman"/>
-                <a:ea typeface="宋体"/>
-              </a:rPr>
-              <a:t/>
-            </a:r>
-          </a:p>
-          <a:p>
-            <a:pPr>
-              <a:spcBef>
-                <a:spcPts val="600"/>
-              </a:spcBef>
-            </a:pPr>
-            <a:r>
-              <a:rPr sz="1200" b="1" i="0">
-                <a:solidFill>
-                  <a:srgbClr val="1E293B"/>
-                </a:solidFill>
-                <a:latin typeface="Times New Roman"/>
-                <a:ea typeface="宋体"/>
-              </a:rPr>
-              <a:t>PreToolUse Hook（2 模块）：independent-review-gate（硬拦截 commit/PR/切阶段）+ auto-checkpoint（Write/Edit 前自动写 interrupt）</a:t>
-            </a:r>
-          </a:p>
-          <a:p>
-            <a:pPr>
-              <a:spcBef>
-                <a:spcPts val="600"/>
-              </a:spcBef>
-            </a:pPr>
-            <a:r>
-              <a:rPr sz="1200" b="1" i="0">
-                <a:solidFill>
-                  <a:srgbClr val="1E293B"/>
-                </a:solidFill>
-                <a:latin typeface="Times New Roman"/>
-                <a:ea typeface="宋体"/>
-              </a:rPr>
-              <a:t>SessionStart Hook（2 模块）：flow-kit-resume（中断恢复 + 矫正注入）+ stop-report-reminder（报告提醒）</a:t>
+              <a:rPr sz="1400" b="1" i="0">
+                <a:solidFill>
+                  <a:srgbClr val="2563EB"/>
+                </a:solidFill>
+                <a:latin typeface="Times New Roman"/>
+                <a:ea typeface="宋体"/>
+              </a:rPr>
+              <a:t>I-intel · 入场扫描</a:t>
+            </a:r>
+          </a:p>
+        </p:txBody>
+      </p:sp>
+      <p:sp>
+        <p:nvSpPr>
+          <p:cNvPr id="6" name="TextBox 5"/>
+          <p:cNvSpPr txBox="1"/>
+          <p:nvPr/>
+        </p:nvSpPr>
+        <p:spPr>
+          <a:xfrm>
+            <a:off x="914400" y="1783080"/>
+            <a:ext cx="2926080" cy="1371600"/>
+          </a:xfrm>
+          <a:prstGeom prst="rect">
+            <a:avLst/>
+          </a:prstGeom>
+          <a:noFill/>
+        </p:spPr>
+        <p:txBody>
+          <a:bodyPr wrap="square">
+            <a:spAutoFit/>
+          </a:bodyPr>
+          <a:lstStyle/>
+          <a:p>
+            <a:r>
+              <a:rPr sz="1000" b="0" i="0">
+                <a:solidFill>
+                  <a:srgbClr val="475569"/>
+                </a:solidFill>
+                <a:latin typeface="Times New Roman"/>
+                <a:ea typeface="宋体"/>
+              </a:rPr>
+              <a:t>生成 CONTEXT.md
+术语表 + 既有抽象索引
++ 禁动清单 + 命名约定
+首次使用 flow-kit 必跑</a:t>
+            </a:r>
+          </a:p>
+        </p:txBody>
+      </p:sp>
+      <p:sp>
+        <p:nvSpPr>
+          <p:cNvPr id="7" name="Rectangle 6"/>
+          <p:cNvSpPr/>
+          <p:nvPr/>
+        </p:nvSpPr>
+        <p:spPr>
+          <a:xfrm>
+            <a:off x="4251960" y="1234440"/>
+            <a:ext cx="3291840" cy="2103120"/>
+          </a:xfrm>
+          <a:prstGeom prst="rect">
+            <a:avLst/>
+          </a:prstGeom>
+          <a:solidFill>
+            <a:srgbClr val="FFFFFF"/>
+          </a:solidFill>
+          <a:ln w="12700">
+            <a:solidFill>
+              <a:srgbClr val="E2E8F0"/>
+            </a:solidFill>
+          </a:ln>
+        </p:spPr>
+        <p:style>
+          <a:lnRef idx="1">
+            <a:schemeClr val="accent1"/>
+          </a:lnRef>
+          <a:fillRef idx="3">
+            <a:schemeClr val="accent1"/>
+          </a:fillRef>
+          <a:effectRef idx="2">
+            <a:schemeClr val="accent1"/>
+          </a:effectRef>
+          <a:fontRef idx="minor">
+            <a:schemeClr val="lt1"/>
+          </a:fontRef>
+        </p:style>
+        <p:txBody>
+          <a:bodyPr rtlCol="0" anchor="ctr"/>
+          <a:lstStyle/>
+          <a:p>
+            <a:pPr algn="ctr"/>
+          </a:p>
+        </p:txBody>
+      </p:sp>
+      <p:sp>
+        <p:nvSpPr>
+          <p:cNvPr id="8" name="TextBox 7"/>
+          <p:cNvSpPr txBox="1"/>
+          <p:nvPr/>
+        </p:nvSpPr>
+        <p:spPr>
+          <a:xfrm>
+            <a:off x="4434840" y="1371600"/>
+            <a:ext cx="2926080" cy="365760"/>
+          </a:xfrm>
+          <a:prstGeom prst="rect">
+            <a:avLst/>
+          </a:prstGeom>
+          <a:noFill/>
+        </p:spPr>
+        <p:txBody>
+          <a:bodyPr wrap="square">
+            <a:spAutoFit/>
+          </a:bodyPr>
+          <a:lstStyle/>
+          <a:p>
+            <a:r>
+              <a:rPr sz="1400" b="1" i="0">
+                <a:solidFill>
+                  <a:srgbClr val="2563EB"/>
+                </a:solidFill>
+                <a:latin typeface="Times New Roman"/>
+                <a:ea typeface="宋体"/>
+              </a:rPr>
+              <a:t>M-health · 健康巡检</a:t>
+            </a:r>
+          </a:p>
+        </p:txBody>
+      </p:sp>
+      <p:sp>
+        <p:nvSpPr>
+          <p:cNvPr id="9" name="TextBox 8"/>
+          <p:cNvSpPr txBox="1"/>
+          <p:nvPr/>
+        </p:nvSpPr>
+        <p:spPr>
+          <a:xfrm>
+            <a:off x="4434840" y="1783080"/>
+            <a:ext cx="2926080" cy="1371600"/>
+          </a:xfrm>
+          <a:prstGeom prst="rect">
+            <a:avLst/>
+          </a:prstGeom>
+          <a:noFill/>
+        </p:spPr>
+        <p:txBody>
+          <a:bodyPr wrap="square">
+            <a:spAutoFit/>
+          </a:bodyPr>
+          <a:lstStyle/>
+          <a:p>
+            <a:r>
+              <a:rPr sz="1000" b="0" i="0">
+                <a:solidFill>
+                  <a:srgbClr val="475569"/>
+                </a:solidFill>
+                <a:latin typeface="Times New Roman"/>
+                <a:ea typeface="宋体"/>
+              </a:rPr>
+              <a:t>代码库健康诊断 + 技术债盘点
+快速/标准/深度三种模式
+brooks-lint 优先，AI 内置回退
+冗余扫描：jscpd/knip/depcheck</a:t>
+            </a:r>
+          </a:p>
+        </p:txBody>
+      </p:sp>
+      <p:sp>
+        <p:nvSpPr>
+          <p:cNvPr id="10" name="Rectangle 9"/>
+          <p:cNvSpPr/>
+          <p:nvPr/>
+        </p:nvSpPr>
+        <p:spPr>
+          <a:xfrm>
+            <a:off x="7772400" y="1234440"/>
+            <a:ext cx="3291840" cy="2103120"/>
+          </a:xfrm>
+          <a:prstGeom prst="rect">
+            <a:avLst/>
+          </a:prstGeom>
+          <a:solidFill>
+            <a:srgbClr val="FFFFFF"/>
+          </a:solidFill>
+          <a:ln w="12700">
+            <a:solidFill>
+              <a:srgbClr val="E2E8F0"/>
+            </a:solidFill>
+          </a:ln>
+        </p:spPr>
+        <p:style>
+          <a:lnRef idx="1">
+            <a:schemeClr val="accent1"/>
+          </a:lnRef>
+          <a:fillRef idx="3">
+            <a:schemeClr val="accent1"/>
+          </a:fillRef>
+          <a:effectRef idx="2">
+            <a:schemeClr val="accent1"/>
+          </a:effectRef>
+          <a:fontRef idx="minor">
+            <a:schemeClr val="lt1"/>
+          </a:fontRef>
+        </p:style>
+        <p:txBody>
+          <a:bodyPr rtlCol="0" anchor="ctr"/>
+          <a:lstStyle/>
+          <a:p>
+            <a:pPr algn="ctr"/>
+          </a:p>
+        </p:txBody>
+      </p:sp>
+      <p:sp>
+        <p:nvSpPr>
+          <p:cNvPr id="11" name="TextBox 10"/>
+          <p:cNvSpPr txBox="1"/>
+          <p:nvPr/>
+        </p:nvSpPr>
+        <p:spPr>
+          <a:xfrm>
+            <a:off x="7955280" y="1371600"/>
+            <a:ext cx="2926080" cy="365760"/>
+          </a:xfrm>
+          <a:prstGeom prst="rect">
+            <a:avLst/>
+          </a:prstGeom>
+          <a:noFill/>
+        </p:spPr>
+        <p:txBody>
+          <a:bodyPr wrap="square">
+            <a:spAutoFit/>
+          </a:bodyPr>
+          <a:lstStyle/>
+          <a:p>
+            <a:r>
+              <a:rPr sz="1400" b="1" i="0">
+                <a:solidFill>
+                  <a:srgbClr val="2563EB"/>
+                </a:solidFill>
+                <a:latin typeface="Times New Roman"/>
+                <a:ea typeface="宋体"/>
+              </a:rPr>
+              <a:t>A-architect · 架构文档</a:t>
+            </a:r>
+          </a:p>
+        </p:txBody>
+      </p:sp>
+      <p:sp>
+        <p:nvSpPr>
+          <p:cNvPr id="12" name="TextBox 11"/>
+          <p:cNvSpPr txBox="1"/>
+          <p:nvPr/>
+        </p:nvSpPr>
+        <p:spPr>
+          <a:xfrm>
+            <a:off x="7955280" y="1783080"/>
+            <a:ext cx="2926080" cy="1371600"/>
+          </a:xfrm>
+          <a:prstGeom prst="rect">
+            <a:avLst/>
+          </a:prstGeom>
+          <a:noFill/>
+        </p:spPr>
+        <p:txBody>
+          <a:bodyPr wrap="square">
+            <a:spAutoFit/>
+          </a:bodyPr>
+          <a:lstStyle/>
+          <a:p>
+            <a:r>
+              <a:rPr sz="1000" b="0" i="0">
+                <a:solidFill>
+                  <a:srgbClr val="475569"/>
+                </a:solidFill>
+                <a:latin typeface="Times New Roman"/>
+                <a:ea typeface="宋体"/>
+              </a:rPr>
+              <a:t>生成 ARCHITECTURE.md + ADR
+系统概览 + 模块清单
++ 跨模块契约 + 容量边界
+首次/重构时建立</a:t>
+            </a:r>
+          </a:p>
+        </p:txBody>
+      </p:sp>
+      <p:sp>
+        <p:nvSpPr>
+          <p:cNvPr id="13" name="Rectangle 12"/>
+          <p:cNvSpPr/>
+          <p:nvPr/>
+        </p:nvSpPr>
+        <p:spPr>
+          <a:xfrm>
+            <a:off x="731520" y="3566160"/>
+            <a:ext cx="3291840" cy="2103120"/>
+          </a:xfrm>
+          <a:prstGeom prst="rect">
+            <a:avLst/>
+          </a:prstGeom>
+          <a:solidFill>
+            <a:srgbClr val="FFFFFF"/>
+          </a:solidFill>
+          <a:ln w="12700">
+            <a:solidFill>
+              <a:srgbClr val="E2E8F0"/>
+            </a:solidFill>
+          </a:ln>
+        </p:spPr>
+        <p:style>
+          <a:lnRef idx="1">
+            <a:schemeClr val="accent1"/>
+          </a:lnRef>
+          <a:fillRef idx="3">
+            <a:schemeClr val="accent1"/>
+          </a:fillRef>
+          <a:effectRef idx="2">
+            <a:schemeClr val="accent1"/>
+          </a:effectRef>
+          <a:fontRef idx="minor">
+            <a:schemeClr val="lt1"/>
+          </a:fontRef>
+        </p:style>
+        <p:txBody>
+          <a:bodyPr rtlCol="0" anchor="ctr"/>
+          <a:lstStyle/>
+          <a:p>
+            <a:pPr algn="ctr"/>
+          </a:p>
+        </p:txBody>
+      </p:sp>
+      <p:sp>
+        <p:nvSpPr>
+          <p:cNvPr id="14" name="TextBox 13"/>
+          <p:cNvSpPr txBox="1"/>
+          <p:nvPr/>
+        </p:nvSpPr>
+        <p:spPr>
+          <a:xfrm>
+            <a:off x="914400" y="3703320"/>
+            <a:ext cx="2926080" cy="365760"/>
+          </a:xfrm>
+          <a:prstGeom prst="rect">
+            <a:avLst/>
+          </a:prstGeom>
+          <a:noFill/>
+        </p:spPr>
+        <p:txBody>
+          <a:bodyPr wrap="square">
+            <a:spAutoFit/>
+          </a:bodyPr>
+          <a:lstStyle/>
+          <a:p>
+            <a:r>
+              <a:rPr sz="1400" b="1" i="0">
+                <a:solidFill>
+                  <a:srgbClr val="2563EB"/>
+                </a:solidFill>
+                <a:latin typeface="Times New Roman"/>
+                <a:ea typeface="宋体"/>
+              </a:rPr>
+              <a:t>A-evolve · 架构沉淀</a:t>
+            </a:r>
+          </a:p>
+        </p:txBody>
+      </p:sp>
+      <p:sp>
+        <p:nvSpPr>
+          <p:cNvPr id="15" name="TextBox 14"/>
+          <p:cNvSpPr txBox="1"/>
+          <p:nvPr/>
+        </p:nvSpPr>
+        <p:spPr>
+          <a:xfrm>
+            <a:off x="914400" y="4114800"/>
+            <a:ext cx="2926080" cy="1371600"/>
+          </a:xfrm>
+          <a:prstGeom prst="rect">
+            <a:avLst/>
+          </a:prstGeom>
+          <a:noFill/>
+        </p:spPr>
+        <p:txBody>
+          <a:bodyPr wrap="square">
+            <a:spAutoFit/>
+          </a:bodyPr>
+          <a:lstStyle/>
+          <a:p>
+            <a:r>
+              <a:rPr sz="1000" b="0" i="0">
+                <a:solidFill>
+                  <a:srgbClr val="475569"/>
+                </a:solidFill>
+                <a:latin typeface="Times New Roman"/>
+                <a:ea typeface="宋体"/>
+              </a:rPr>
+              <a:t>扫描已归档 DESIGN.md §9
+聚合分类 → 用户 review
+→ patch CONTEXT.md
++ ARCHITECTURE.md</a:t>
+            </a:r>
+          </a:p>
+        </p:txBody>
+      </p:sp>
+      <p:sp>
+        <p:nvSpPr>
+          <p:cNvPr id="16" name="Rectangle 15"/>
+          <p:cNvSpPr/>
+          <p:nvPr/>
+        </p:nvSpPr>
+        <p:spPr>
+          <a:xfrm>
+            <a:off x="4251960" y="3566160"/>
+            <a:ext cx="3291840" cy="2103120"/>
+          </a:xfrm>
+          <a:prstGeom prst="rect">
+            <a:avLst/>
+          </a:prstGeom>
+          <a:solidFill>
+            <a:srgbClr val="FFFFFF"/>
+          </a:solidFill>
+          <a:ln w="12700">
+            <a:solidFill>
+              <a:srgbClr val="E2E8F0"/>
+            </a:solidFill>
+          </a:ln>
+        </p:spPr>
+        <p:style>
+          <a:lnRef idx="1">
+            <a:schemeClr val="accent1"/>
+          </a:lnRef>
+          <a:fillRef idx="3">
+            <a:schemeClr val="accent1"/>
+          </a:fillRef>
+          <a:effectRef idx="2">
+            <a:schemeClr val="accent1"/>
+          </a:effectRef>
+          <a:fontRef idx="minor">
+            <a:schemeClr val="lt1"/>
+          </a:fontRef>
+        </p:style>
+        <p:txBody>
+          <a:bodyPr rtlCol="0" anchor="ctr"/>
+          <a:lstStyle/>
+          <a:p>
+            <a:pPr algn="ctr"/>
+          </a:p>
+        </p:txBody>
+      </p:sp>
+      <p:sp>
+        <p:nvSpPr>
+          <p:cNvPr id="17" name="TextBox 16"/>
+          <p:cNvSpPr txBox="1"/>
+          <p:nvPr/>
+        </p:nvSpPr>
+        <p:spPr>
+          <a:xfrm>
+            <a:off x="4434840" y="3703320"/>
+            <a:ext cx="2926080" cy="365760"/>
+          </a:xfrm>
+          <a:prstGeom prst="rect">
+            <a:avLst/>
+          </a:prstGeom>
+          <a:noFill/>
+        </p:spPr>
+        <p:txBody>
+          <a:bodyPr wrap="square">
+            <a:spAutoFit/>
+          </a:bodyPr>
+          <a:lstStyle/>
+          <a:p>
+            <a:r>
+              <a:rPr sz="1400" b="1" i="0">
+                <a:solidFill>
+                  <a:srgbClr val="2563EB"/>
+                </a:solidFill>
+                <a:latin typeface="Times New Roman"/>
+                <a:ea typeface="宋体"/>
+              </a:rPr>
+              <a:t>L-restyle · 视觉重构</a:t>
+            </a:r>
+          </a:p>
+        </p:txBody>
+      </p:sp>
+      <p:sp>
+        <p:nvSpPr>
+          <p:cNvPr id="18" name="TextBox 17"/>
+          <p:cNvSpPr txBox="1"/>
+          <p:nvPr/>
+        </p:nvSpPr>
+        <p:spPr>
+          <a:xfrm>
+            <a:off x="4434840" y="4114800"/>
+            <a:ext cx="2926080" cy="1371600"/>
+          </a:xfrm>
+          <a:prstGeom prst="rect">
+            <a:avLst/>
+          </a:prstGeom>
+          <a:noFill/>
+        </p:spPr>
+        <p:txBody>
+          <a:bodyPr wrap="square">
+            <a:spAutoFit/>
+          </a:bodyPr>
+          <a:lstStyle/>
+          <a:p>
+            <a:r>
+              <a:rPr sz="1000" b="0" i="0">
+                <a:solidFill>
+                  <a:srgbClr val="475569"/>
+                </a:solidFill>
+                <a:latin typeface="Times New Roman"/>
+                <a:ea typeface="宋体"/>
+              </a:rPr>
+              <a:t>保留功能，重做 UI 视觉
+自动生成 change-id
+v1→v2 视觉对照表
+组件库迁移/品牌升级适用</a:t>
             </a:r>
           </a:p>
         </p:txBody>
@@ -6124,66 +6071,21 @@
                 <a:latin typeface="Times New Roman"/>
                 <a:ea typeface="宋体"/>
               </a:rPr>
-              <a:t>brooks-lint 代码审查插件</a:t>
-            </a:r>
-          </a:p>
-        </p:txBody>
-      </p:sp>
-      <p:sp>
-        <p:nvSpPr>
-          <p:cNvPr id="4" name="Rectangle 3"/>
-          <p:cNvSpPr/>
-          <p:nvPr/>
-        </p:nvSpPr>
-        <p:spPr>
-          <a:xfrm>
-            <a:off x="731520" y="1234440"/>
-            <a:ext cx="3291840" cy="2103120"/>
-          </a:xfrm>
-          <a:prstGeom prst="rect">
-            <a:avLst/>
-          </a:prstGeom>
-          <a:solidFill>
-            <a:srgbClr val="FFFFFF"/>
-          </a:solidFill>
-          <a:ln w="12700">
-            <a:solidFill>
-              <a:srgbClr val="E2E8F0"/>
-            </a:solidFill>
-          </a:ln>
-        </p:spPr>
-        <p:style>
-          <a:lnRef idx="1">
-            <a:schemeClr val="accent1"/>
-          </a:lnRef>
-          <a:fillRef idx="3">
-            <a:schemeClr val="accent1"/>
-          </a:fillRef>
-          <a:effectRef idx="2">
-            <a:schemeClr val="accent1"/>
-          </a:effectRef>
-          <a:fontRef idx="minor">
-            <a:schemeClr val="lt1"/>
-          </a:fontRef>
-        </p:style>
-        <p:txBody>
-          <a:bodyPr rtlCol="0" anchor="ctr"/>
-          <a:lstStyle/>
-          <a:p>
-            <a:pPr algn="ctr"/>
-          </a:p>
-        </p:txBody>
-      </p:sp>
-      <p:sp>
-        <p:nvSpPr>
-          <p:cNvPr id="5" name="TextBox 4"/>
+              <a:t>Stop Hook 系统（17 模块）</a:t>
+            </a:r>
+          </a:p>
+        </p:txBody>
+      </p:sp>
+      <p:sp>
+        <p:nvSpPr>
+          <p:cNvPr id="4" name="TextBox 3"/>
           <p:cNvSpPr txBox="1"/>
           <p:nvPr/>
         </p:nvSpPr>
         <p:spPr>
           <a:xfrm>
-            <a:off x="914400" y="1371600"/>
-            <a:ext cx="2926080" cy="365760"/>
+            <a:off x="731520" y="1280160"/>
+            <a:ext cx="10698480" cy="4754880"/>
           </a:xfrm>
           <a:prstGeom prst="rect">
             <a:avLst/>
@@ -6197,28 +6099,283 @@
           <a:lstStyle/>
           <a:p>
             <a:r>
-              <a:rPr sz="1400" b="1" i="0">
-                <a:solidFill>
-                  <a:srgbClr val="2563EB"/>
-                </a:solidFill>
-                <a:latin typeface="Times New Roman"/>
-                <a:ea typeface="宋体"/>
-              </a:rPr>
-              <a:t>/brooks-review</a:t>
-            </a:r>
-          </a:p>
-        </p:txBody>
-      </p:sp>
-      <p:sp>
-        <p:nvSpPr>
-          <p:cNvPr id="6" name="TextBox 5"/>
+              <a:rPr sz="1400" b="0" i="0">
+                <a:solidFill>
+                  <a:srgbClr val="475569"/>
+                </a:solidFill>
+                <a:latin typeface="Times New Roman"/>
+                <a:ea typeface="宋体"/>
+              </a:rPr>
+              <a:t>每次 Claude Code 会话结束时自动运行的模块化后处理脚本链：</a:t>
+            </a:r>
+          </a:p>
+          <a:p>
+            <a:pPr>
+              <a:spcBef>
+                <a:spcPts val="600"/>
+              </a:spcBef>
+            </a:pPr>
+            <a:r>
+              <a:rPr sz="600" b="0" i="0">
+                <a:solidFill>
+                  <a:srgbClr val="475569"/>
+                </a:solidFill>
+                <a:latin typeface="Times New Roman"/>
+                <a:ea typeface="宋体"/>
+              </a:rPr>
+              <a:t/>
+            </a:r>
+          </a:p>
+          <a:p>
+            <a:pPr>
+              <a:spcBef>
+                <a:spcPts val="600"/>
+              </a:spcBef>
+            </a:pPr>
+            <a:r>
+              <a:rPr sz="1200" b="0" i="0">
+                <a:solidFill>
+                  <a:srgbClr val="475569"/>
+                </a:solidFill>
+                <a:latin typeface="Times New Roman"/>
+                <a:ea typeface="宋体"/>
+              </a:rPr>
+              <a:t>🔹 基础设施：00-gate（入口门禁）| 01-transcript-parse（转录解析）</a:t>
+            </a:r>
+          </a:p>
+          <a:p>
+            <a:pPr>
+              <a:spcBef>
+                <a:spcPts val="600"/>
+              </a:spcBef>
+            </a:pPr>
+            <a:r>
+              <a:rPr sz="1200" b="0" i="0">
+                <a:solidFill>
+                  <a:srgbClr val="475569"/>
+                </a:solidFill>
+                <a:latin typeface="Times New Roman"/>
+                <a:ea typeface="宋体"/>
+              </a:rPr>
+              <a:t>🔹 文件质量：20-claude-md | 21-memory | 22-git | 23-quality | 24-session | 25-project</a:t>
+            </a:r>
+          </a:p>
+          <a:p>
+            <a:pPr>
+              <a:spcBef>
+                <a:spcPts val="600"/>
+              </a:spcBef>
+            </a:pPr>
+            <a:r>
+              <a:rPr sz="1200" b="0" i="0">
+                <a:solidFill>
+                  <a:srgbClr val="475569"/>
+                </a:solidFill>
+                <a:latin typeface="Times New Roman"/>
+                <a:ea typeface="宋体"/>
+              </a:rPr>
+              <a:t>🔹 工作流：26-workflow（阶段门禁 + 产物完整性 + 未完成 task + checkpoint 断层）</a:t>
+            </a:r>
+          </a:p>
+          <a:p>
+            <a:pPr>
+              <a:spcBef>
+                <a:spcPts val="600"/>
+              </a:spcBef>
+            </a:pPr>
+            <a:r>
+              <a:rPr sz="1200" b="0" i="0">
+                <a:solidFill>
+                  <a:srgbClr val="475569"/>
+                </a:solidFill>
+                <a:latin typeface="Times New Roman"/>
+                <a:ea typeface="宋体"/>
+              </a:rPr>
+              <a:t>🔹 弱模型护栏：27-interactive-ui-check（检测跳过交互 gate → 矫正文件）</a:t>
+            </a:r>
+          </a:p>
+          <a:p>
+            <a:pPr>
+              <a:spcBef>
+                <a:spcPts val="600"/>
+              </a:spcBef>
+            </a:pPr>
+            <a:r>
+              <a:rPr sz="1200" b="0" i="0">
+                <a:solidFill>
+                  <a:srgbClr val="475569"/>
+                </a:solidFill>
+                <a:latin typeface="Times New Roman"/>
+                <a:ea typeface="宋体"/>
+              </a:rPr>
+              <a:t>🔹 弱模型合规：28-weak-model-compliance（L1 规则 + L2 自检 + L3 证据链 → 矫正文件）</a:t>
+            </a:r>
+          </a:p>
+          <a:p>
+            <a:pPr>
+              <a:spcBef>
+                <a:spcPts val="600"/>
+              </a:spcBef>
+            </a:pPr>
+            <a:r>
+              <a:rPr sz="1200" b="0" i="0">
+                <a:solidFill>
+                  <a:srgbClr val="475569"/>
+                </a:solidFill>
+                <a:latin typeface="Times New Roman"/>
+                <a:ea typeface="宋体"/>
+              </a:rPr>
+              <a:t>🔹 独立审查：29-independent-review（L3 外部模型盲审，异步调度）</a:t>
+            </a:r>
+          </a:p>
+          <a:p>
+            <a:pPr>
+              <a:spcBef>
+                <a:spcPts val="600"/>
+              </a:spcBef>
+            </a:pPr>
+            <a:r>
+              <a:rPr sz="1200" b="0" i="0">
+                <a:solidFill>
+                  <a:srgbClr val="475569"/>
+                </a:solidFill>
+                <a:latin typeface="Times New Roman"/>
+                <a:ea typeface="宋体"/>
+              </a:rPr>
+              <a:t>🔹 AI 分析：30-ai-analyze（提交结构化数据给 AI 深度分析）</a:t>
+            </a:r>
+          </a:p>
+          <a:p>
+            <a:pPr>
+              <a:spcBef>
+                <a:spcPts val="600"/>
+              </a:spcBef>
+            </a:pPr>
+            <a:r>
+              <a:rPr sz="1200" b="0" i="0">
+                <a:solidFill>
+                  <a:srgbClr val="475569"/>
+                </a:solidFill>
+                <a:latin typeface="Times New Roman"/>
+                <a:ea typeface="宋体"/>
+              </a:rPr>
+              <a:t>🔹 自动推进：31-auto-advance（auto_advance=true 时自动 transition）</a:t>
+            </a:r>
+          </a:p>
+          <a:p>
+            <a:pPr>
+              <a:spcBef>
+                <a:spcPts val="600"/>
+              </a:spcBef>
+            </a:pPr>
+            <a:r>
+              <a:rPr sz="1200" b="0" i="0">
+                <a:solidFill>
+                  <a:srgbClr val="475569"/>
+                </a:solidFill>
+                <a:latin typeface="Times New Roman"/>
+                <a:ea typeface="宋体"/>
+              </a:rPr>
+              <a:t>🔹 回退兜底：32-fallback-guard（mode=fallback 时自动标记 goal.status=done）</a:t>
+            </a:r>
+          </a:p>
+          <a:p>
+            <a:pPr>
+              <a:spcBef>
+                <a:spcPts val="600"/>
+              </a:spcBef>
+            </a:pPr>
+            <a:r>
+              <a:rPr sz="1200" b="0" i="0">
+                <a:solidFill>
+                  <a:srgbClr val="475569"/>
+                </a:solidFill>
+                <a:latin typeface="Times New Roman"/>
+                <a:ea typeface="宋体"/>
+              </a:rPr>
+              <a:t>🔹 状态完整性：33-flow-active-integrity（.flow-active ↔ 磁盘产物交叉验证 + 时效性检测）</a:t>
+            </a:r>
+          </a:p>
+          <a:p>
+            <a:pPr>
+              <a:spcBef>
+                <a:spcPts val="600"/>
+              </a:spcBef>
+            </a:pPr>
+            <a:r>
+              <a:rPr sz="1200" b="0" i="0">
+                <a:solidFill>
+                  <a:srgbClr val="475569"/>
+                </a:solidFill>
+                <a:latin typeface="Times New Roman"/>
+                <a:ea typeface="宋体"/>
+              </a:rPr>
+              <a:t>🔹 报告：99-report（生成 stop-hook-report.md + token 用量展示）</a:t>
+            </a:r>
+          </a:p>
+          <a:p>
+            <a:pPr>
+              <a:spcBef>
+                <a:spcPts val="600"/>
+              </a:spcBef>
+            </a:pPr>
+            <a:r>
+              <a:rPr sz="600" b="0" i="0">
+                <a:solidFill>
+                  <a:srgbClr val="475569"/>
+                </a:solidFill>
+                <a:latin typeface="Times New Roman"/>
+                <a:ea typeface="宋体"/>
+              </a:rPr>
+              <a:t/>
+            </a:r>
+          </a:p>
+          <a:p>
+            <a:pPr>
+              <a:spcBef>
+                <a:spcPts val="600"/>
+              </a:spcBef>
+            </a:pPr>
+            <a:r>
+              <a:rPr sz="1200" b="1" i="0">
+                <a:solidFill>
+                  <a:srgbClr val="1E293B"/>
+                </a:solidFill>
+                <a:latin typeface="Times New Roman"/>
+                <a:ea typeface="宋体"/>
+              </a:rPr>
+              <a:t>PreToolUse Hook（2 模块）：independent-review-gate（硬拦截 commit/PR/切阶段）+ auto-checkpoint（Write/Edit 前自动写 interrupt）</a:t>
+            </a:r>
+          </a:p>
+          <a:p>
+            <a:pPr>
+              <a:spcBef>
+                <a:spcPts val="600"/>
+              </a:spcBef>
+            </a:pPr>
+            <a:r>
+              <a:rPr sz="1200" b="1" i="0">
+                <a:solidFill>
+                  <a:srgbClr val="1E293B"/>
+                </a:solidFill>
+                <a:latin typeface="Times New Roman"/>
+                <a:ea typeface="宋体"/>
+              </a:rPr>
+              <a:t>SessionStart Hook（2 模块）：flow-kit-resume（中断恢复 + 矫正注入）+ stop-report-reminder（报告提醒）</a:t>
+            </a:r>
+          </a:p>
+        </p:txBody>
+      </p:sp>
+      <p:sp>
+        <p:nvSpPr>
+          <p:cNvPr id="5" name="TextBox 4"/>
           <p:cNvSpPr txBox="1"/>
           <p:nvPr/>
         </p:nvSpPr>
         <p:spPr>
           <a:xfrm>
-            <a:off x="914400" y="1783080"/>
-            <a:ext cx="2926080" cy="1371600"/>
+            <a:off x="914400" y="5669280"/>
+            <a:ext cx="7315200" cy="548640"/>
           </a:xfrm>
           <a:prstGeom prst="rect">
             <a:avLst/>
@@ -6232,601 +6389,22 @@
           <a:lstStyle/>
           <a:p>
             <a:r>
-              <a:rPr sz="1000" b="0" i="0">
-                <a:solidFill>
-                  <a:srgbClr val="475569"/>
-                </a:solidFill>
-                <a:latin typeface="Times New Roman"/>
-                <a:ea typeface="宋体"/>
-              </a:rPr>
-              <a:t>PR 代码审查
-发现衰退风险和设计坏味
-Symptom→Source→Consequence→Remedy</a:t>
-            </a:r>
-          </a:p>
-        </p:txBody>
-      </p:sp>
-      <p:sp>
-        <p:nvSpPr>
-          <p:cNvPr id="7" name="Rectangle 6"/>
-          <p:cNvSpPr/>
-          <p:nvPr/>
-        </p:nvSpPr>
-        <p:spPr>
-          <a:xfrm>
-            <a:off x="4251960" y="1234440"/>
-            <a:ext cx="3291840" cy="2103120"/>
-          </a:xfrm>
-          <a:prstGeom prst="rect">
-            <a:avLst/>
-          </a:prstGeom>
-          <a:solidFill>
-            <a:srgbClr val="FFFFFF"/>
-          </a:solidFill>
-          <a:ln w="12700">
-            <a:solidFill>
-              <a:srgbClr val="E2E8F0"/>
-            </a:solidFill>
-          </a:ln>
-        </p:spPr>
-        <p:style>
-          <a:lnRef idx="1">
-            <a:schemeClr val="accent1"/>
-          </a:lnRef>
-          <a:fillRef idx="3">
-            <a:schemeClr val="accent1"/>
-          </a:fillRef>
-          <a:effectRef idx="2">
-            <a:schemeClr val="accent1"/>
-          </a:effectRef>
-          <a:fontRef idx="minor">
-            <a:schemeClr val="lt1"/>
-          </a:fontRef>
-        </p:style>
-        <p:txBody>
-          <a:bodyPr rtlCol="0" anchor="ctr"/>
-          <a:lstStyle/>
-          <a:p>
-            <a:pPr algn="ctr"/>
-          </a:p>
-        </p:txBody>
-      </p:sp>
-      <p:sp>
-        <p:nvSpPr>
-          <p:cNvPr id="8" name="TextBox 7"/>
-          <p:cNvSpPr txBox="1"/>
-          <p:nvPr/>
-        </p:nvSpPr>
-        <p:spPr>
-          <a:xfrm>
-            <a:off x="4434840" y="1371600"/>
-            <a:ext cx="2926080" cy="365760"/>
-          </a:xfrm>
-          <a:prstGeom prst="rect">
-            <a:avLst/>
-          </a:prstGeom>
-          <a:noFill/>
-        </p:spPr>
-        <p:txBody>
-          <a:bodyPr wrap="square">
-            <a:spAutoFit/>
-          </a:bodyPr>
-          <a:lstStyle/>
-          <a:p>
-            <a:r>
-              <a:rPr sz="1400" b="1" i="0">
-                <a:solidFill>
-                  <a:srgbClr val="2563EB"/>
-                </a:solidFill>
-                <a:latin typeface="Times New Roman"/>
-                <a:ea typeface="宋体"/>
-              </a:rPr>
-              <a:t>/brooks-audit</a:t>
-            </a:r>
-          </a:p>
-        </p:txBody>
-      </p:sp>
-      <p:sp>
-        <p:nvSpPr>
-          <p:cNvPr id="9" name="TextBox 8"/>
-          <p:cNvSpPr txBox="1"/>
-          <p:nvPr/>
-        </p:nvSpPr>
-        <p:spPr>
-          <a:xfrm>
-            <a:off x="4434840" y="1783080"/>
-            <a:ext cx="2926080" cy="1371600"/>
-          </a:xfrm>
-          <a:prstGeom prst="rect">
-            <a:avLst/>
-          </a:prstGeom>
-          <a:noFill/>
-        </p:spPr>
-        <p:txBody>
-          <a:bodyPr wrap="square">
-            <a:spAutoFit/>
-          </a:bodyPr>
-          <a:lstStyle/>
-          <a:p>
-            <a:r>
-              <a:rPr sz="1000" b="0" i="0">
-                <a:solidFill>
-                  <a:srgbClr val="475569"/>
-                </a:solidFill>
-                <a:latin typeface="Times New Roman"/>
-                <a:ea typeface="宋体"/>
-              </a:rPr>
-              <a:t>架构审计
-模块依赖图 + 分层完整性
-+ 循环依赖检测</a:t>
-            </a:r>
-          </a:p>
-        </p:txBody>
-      </p:sp>
-      <p:sp>
-        <p:nvSpPr>
-          <p:cNvPr id="10" name="Rectangle 9"/>
-          <p:cNvSpPr/>
-          <p:nvPr/>
-        </p:nvSpPr>
-        <p:spPr>
-          <a:xfrm>
-            <a:off x="7772400" y="1234440"/>
-            <a:ext cx="3291840" cy="2103120"/>
-          </a:xfrm>
-          <a:prstGeom prst="rect">
-            <a:avLst/>
-          </a:prstGeom>
-          <a:solidFill>
-            <a:srgbClr val="FFFFFF"/>
-          </a:solidFill>
-          <a:ln w="12700">
-            <a:solidFill>
-              <a:srgbClr val="E2E8F0"/>
-            </a:solidFill>
-          </a:ln>
-        </p:spPr>
-        <p:style>
-          <a:lnRef idx="1">
-            <a:schemeClr val="accent1"/>
-          </a:lnRef>
-          <a:fillRef idx="3">
-            <a:schemeClr val="accent1"/>
-          </a:fillRef>
-          <a:effectRef idx="2">
-            <a:schemeClr val="accent1"/>
-          </a:effectRef>
-          <a:fontRef idx="minor">
-            <a:schemeClr val="lt1"/>
-          </a:fontRef>
-        </p:style>
-        <p:txBody>
-          <a:bodyPr rtlCol="0" anchor="ctr"/>
-          <a:lstStyle/>
-          <a:p>
-            <a:pPr algn="ctr"/>
-          </a:p>
-        </p:txBody>
-      </p:sp>
-      <p:sp>
-        <p:nvSpPr>
-          <p:cNvPr id="11" name="TextBox 10"/>
-          <p:cNvSpPr txBox="1"/>
-          <p:nvPr/>
-        </p:nvSpPr>
-        <p:spPr>
-          <a:xfrm>
-            <a:off x="7955280" y="1371600"/>
-            <a:ext cx="2926080" cy="365760"/>
-          </a:xfrm>
-          <a:prstGeom prst="rect">
-            <a:avLst/>
-          </a:prstGeom>
-          <a:noFill/>
-        </p:spPr>
-        <p:txBody>
-          <a:bodyPr wrap="square">
-            <a:spAutoFit/>
-          </a:bodyPr>
-          <a:lstStyle/>
-          <a:p>
-            <a:r>
-              <a:rPr sz="1400" b="1" i="0">
-                <a:solidFill>
-                  <a:srgbClr val="2563EB"/>
-                </a:solidFill>
-                <a:latin typeface="Times New Roman"/>
-                <a:ea typeface="宋体"/>
-              </a:rPr>
-              <a:t>/brooks-debt</a:t>
-            </a:r>
-          </a:p>
-        </p:txBody>
-      </p:sp>
-      <p:sp>
-        <p:nvSpPr>
-          <p:cNvPr id="12" name="TextBox 11"/>
-          <p:cNvSpPr txBox="1"/>
-          <p:nvPr/>
-        </p:nvSpPr>
-        <p:spPr>
-          <a:xfrm>
-            <a:off x="7955280" y="1783080"/>
-            <a:ext cx="2926080" cy="1371600"/>
-          </a:xfrm>
-          <a:prstGeom prst="rect">
-            <a:avLst/>
-          </a:prstGeom>
-          <a:noFill/>
-        </p:spPr>
-        <p:txBody>
-          <a:bodyPr wrap="square">
-            <a:spAutoFit/>
-          </a:bodyPr>
-          <a:lstStyle/>
-          <a:p>
-            <a:r>
-              <a:rPr sz="1000" b="0" i="0">
-                <a:solidFill>
-                  <a:srgbClr val="475569"/>
-                </a:solidFill>
-                <a:latin typeface="Times New Roman"/>
-                <a:ea typeface="宋体"/>
-              </a:rPr>
-              <a:t>技术债评估
-分类 + 优先级排序
-构建重构路线图</a:t>
-            </a:r>
-          </a:p>
-        </p:txBody>
-      </p:sp>
-      <p:sp>
-        <p:nvSpPr>
-          <p:cNvPr id="13" name="Rectangle 12"/>
-          <p:cNvSpPr/>
-          <p:nvPr/>
-        </p:nvSpPr>
-        <p:spPr>
-          <a:xfrm>
-            <a:off x="731520" y="3566160"/>
-            <a:ext cx="3291840" cy="2103120"/>
-          </a:xfrm>
-          <a:prstGeom prst="rect">
-            <a:avLst/>
-          </a:prstGeom>
-          <a:solidFill>
-            <a:srgbClr val="FFFFFF"/>
-          </a:solidFill>
-          <a:ln w="12700">
-            <a:solidFill>
-              <a:srgbClr val="E2E8F0"/>
-            </a:solidFill>
-          </a:ln>
-        </p:spPr>
-        <p:style>
-          <a:lnRef idx="1">
-            <a:schemeClr val="accent1"/>
-          </a:lnRef>
-          <a:fillRef idx="3">
-            <a:schemeClr val="accent1"/>
-          </a:fillRef>
-          <a:effectRef idx="2">
-            <a:schemeClr val="accent1"/>
-          </a:effectRef>
-          <a:fontRef idx="minor">
-            <a:schemeClr val="lt1"/>
-          </a:fontRef>
-        </p:style>
-        <p:txBody>
-          <a:bodyPr rtlCol="0" anchor="ctr"/>
-          <a:lstStyle/>
-          <a:p>
-            <a:pPr algn="ctr"/>
-          </a:p>
-        </p:txBody>
-      </p:sp>
-      <p:sp>
-        <p:nvSpPr>
-          <p:cNvPr id="14" name="TextBox 13"/>
-          <p:cNvSpPr txBox="1"/>
-          <p:nvPr/>
-        </p:nvSpPr>
-        <p:spPr>
-          <a:xfrm>
-            <a:off x="914400" y="3703320"/>
-            <a:ext cx="2926080" cy="365760"/>
-          </a:xfrm>
-          <a:prstGeom prst="rect">
-            <a:avLst/>
-          </a:prstGeom>
-          <a:noFill/>
-        </p:spPr>
-        <p:txBody>
-          <a:bodyPr wrap="square">
-            <a:spAutoFit/>
-          </a:bodyPr>
-          <a:lstStyle/>
-          <a:p>
-            <a:r>
-              <a:rPr sz="1400" b="1" i="0">
-                <a:solidFill>
-                  <a:srgbClr val="2563EB"/>
-                </a:solidFill>
-                <a:latin typeface="Times New Roman"/>
-                <a:ea typeface="宋体"/>
-              </a:rPr>
-              <a:t>/brooks-test</a:t>
-            </a:r>
-          </a:p>
-        </p:txBody>
-      </p:sp>
-      <p:sp>
-        <p:nvSpPr>
-          <p:cNvPr id="15" name="TextBox 14"/>
-          <p:cNvSpPr txBox="1"/>
-          <p:nvPr/>
-        </p:nvSpPr>
-        <p:spPr>
-          <a:xfrm>
-            <a:off x="914400" y="4114800"/>
-            <a:ext cx="2926080" cy="1371600"/>
-          </a:xfrm>
-          <a:prstGeom prst="rect">
-            <a:avLst/>
-          </a:prstGeom>
-          <a:noFill/>
-        </p:spPr>
-        <p:txBody>
-          <a:bodyPr wrap="square">
-            <a:spAutoFit/>
-          </a:bodyPr>
-          <a:lstStyle/>
-          <a:p>
-            <a:r>
-              <a:rPr sz="1000" b="0" i="0">
-                <a:solidFill>
-                  <a:srgbClr val="475569"/>
-                </a:solidFill>
-                <a:latin typeface="Times New Roman"/>
-                <a:ea typeface="宋体"/>
-              </a:rPr>
-              <a:t>测试质量审查
-脆性测试 / mock 滥用
-/ 覆盖率幻觉诊断</a:t>
-            </a:r>
-          </a:p>
-        </p:txBody>
-      </p:sp>
-      <p:sp>
-        <p:nvSpPr>
-          <p:cNvPr id="16" name="Rectangle 15"/>
-          <p:cNvSpPr/>
-          <p:nvPr/>
-        </p:nvSpPr>
-        <p:spPr>
-          <a:xfrm>
-            <a:off x="4251960" y="3566160"/>
-            <a:ext cx="3291840" cy="2103120"/>
-          </a:xfrm>
-          <a:prstGeom prst="rect">
-            <a:avLst/>
-          </a:prstGeom>
-          <a:solidFill>
-            <a:srgbClr val="FFFFFF"/>
-          </a:solidFill>
-          <a:ln w="12700">
-            <a:solidFill>
-              <a:srgbClr val="E2E8F0"/>
-            </a:solidFill>
-          </a:ln>
-        </p:spPr>
-        <p:style>
-          <a:lnRef idx="1">
-            <a:schemeClr val="accent1"/>
-          </a:lnRef>
-          <a:fillRef idx="3">
-            <a:schemeClr val="accent1"/>
-          </a:fillRef>
-          <a:effectRef idx="2">
-            <a:schemeClr val="accent1"/>
-          </a:effectRef>
-          <a:fontRef idx="minor">
-            <a:schemeClr val="lt1"/>
-          </a:fontRef>
-        </p:style>
-        <p:txBody>
-          <a:bodyPr rtlCol="0" anchor="ctr"/>
-          <a:lstStyle/>
-          <a:p>
-            <a:pPr algn="ctr"/>
-          </a:p>
-        </p:txBody>
-      </p:sp>
-      <p:sp>
-        <p:nvSpPr>
-          <p:cNvPr id="17" name="TextBox 16"/>
-          <p:cNvSpPr txBox="1"/>
-          <p:nvPr/>
-        </p:nvSpPr>
-        <p:spPr>
-          <a:xfrm>
-            <a:off x="4434840" y="3703320"/>
-            <a:ext cx="2926080" cy="365760"/>
-          </a:xfrm>
-          <a:prstGeom prst="rect">
-            <a:avLst/>
-          </a:prstGeom>
-          <a:noFill/>
-        </p:spPr>
-        <p:txBody>
-          <a:bodyPr wrap="square">
-            <a:spAutoFit/>
-          </a:bodyPr>
-          <a:lstStyle/>
-          <a:p>
-            <a:r>
-              <a:rPr sz="1400" b="1" i="0">
-                <a:solidFill>
-                  <a:srgbClr val="2563EB"/>
-                </a:solidFill>
-                <a:latin typeface="Times New Roman"/>
-                <a:ea typeface="宋体"/>
-              </a:rPr>
-              <a:t>/brooks-health</a:t>
-            </a:r>
-          </a:p>
-        </p:txBody>
-      </p:sp>
-      <p:sp>
-        <p:nvSpPr>
-          <p:cNvPr id="18" name="TextBox 17"/>
-          <p:cNvSpPr txBox="1"/>
-          <p:nvPr/>
-        </p:nvSpPr>
-        <p:spPr>
-          <a:xfrm>
-            <a:off x="4434840" y="4114800"/>
-            <a:ext cx="2926080" cy="1371600"/>
-          </a:xfrm>
-          <a:prstGeom prst="rect">
-            <a:avLst/>
-          </a:prstGeom>
-          <a:noFill/>
-        </p:spPr>
-        <p:txBody>
-          <a:bodyPr wrap="square">
-            <a:spAutoFit/>
-          </a:bodyPr>
-          <a:lstStyle/>
-          <a:p>
-            <a:r>
-              <a:rPr sz="1000" b="0" i="0">
-                <a:solidFill>
-                  <a:srgbClr val="475569"/>
-                </a:solidFill>
-                <a:latin typeface="Times New Roman"/>
-                <a:ea typeface="宋体"/>
-              </a:rPr>
-              <a:t>代码库健康仪表盘
-四维综合评分
-PR/架构/技术债/测试</a:t>
-            </a:r>
-          </a:p>
-        </p:txBody>
-      </p:sp>
-      <p:sp>
-        <p:nvSpPr>
-          <p:cNvPr id="19" name="Rectangle 18"/>
-          <p:cNvSpPr/>
-          <p:nvPr/>
-        </p:nvSpPr>
-        <p:spPr>
-          <a:xfrm>
-            <a:off x="7772400" y="3566160"/>
-            <a:ext cx="3291840" cy="2103120"/>
-          </a:xfrm>
-          <a:prstGeom prst="rect">
-            <a:avLst/>
-          </a:prstGeom>
-          <a:solidFill>
-            <a:srgbClr val="FFFFFF"/>
-          </a:solidFill>
-          <a:ln w="12700">
-            <a:solidFill>
-              <a:srgbClr val="E2E8F0"/>
-            </a:solidFill>
-          </a:ln>
-        </p:spPr>
-        <p:style>
-          <a:lnRef idx="1">
-            <a:schemeClr val="accent1"/>
-          </a:lnRef>
-          <a:fillRef idx="3">
-            <a:schemeClr val="accent1"/>
-          </a:fillRef>
-          <a:effectRef idx="2">
-            <a:schemeClr val="accent1"/>
-          </a:effectRef>
-          <a:fontRef idx="minor">
-            <a:schemeClr val="lt1"/>
-          </a:fontRef>
-        </p:style>
-        <p:txBody>
-          <a:bodyPr rtlCol="0" anchor="ctr"/>
-          <a:lstStyle/>
-          <a:p>
-            <a:pPr algn="ctr"/>
-          </a:p>
-        </p:txBody>
-      </p:sp>
-      <p:sp>
-        <p:nvSpPr>
-          <p:cNvPr id="20" name="TextBox 19"/>
-          <p:cNvSpPr txBox="1"/>
-          <p:nvPr/>
-        </p:nvSpPr>
-        <p:spPr>
-          <a:xfrm>
-            <a:off x="7955280" y="3703320"/>
-            <a:ext cx="2926080" cy="365760"/>
-          </a:xfrm>
-          <a:prstGeom prst="rect">
-            <a:avLst/>
-          </a:prstGeom>
-          <a:noFill/>
-        </p:spPr>
-        <p:txBody>
-          <a:bodyPr wrap="square">
-            <a:spAutoFit/>
-          </a:bodyPr>
-          <a:lstStyle/>
-          <a:p>
-            <a:r>
-              <a:rPr sz="1400" b="1" i="0">
-                <a:solidFill>
-                  <a:srgbClr val="2563EB"/>
-                </a:solidFill>
-                <a:latin typeface="Times New Roman"/>
-                <a:ea typeface="宋体"/>
-              </a:rPr>
-              <a:t>/brooks-sweep</a:t>
-            </a:r>
-          </a:p>
-        </p:txBody>
-      </p:sp>
-      <p:sp>
-        <p:nvSpPr>
-          <p:cNvPr id="21" name="TextBox 20"/>
-          <p:cNvSpPr txBox="1"/>
-          <p:nvPr/>
-        </p:nvSpPr>
-        <p:spPr>
-          <a:xfrm>
-            <a:off x="7955280" y="4114800"/>
-            <a:ext cx="2926080" cy="1371600"/>
-          </a:xfrm>
-          <a:prstGeom prst="rect">
-            <a:avLst/>
-          </a:prstGeom>
-          <a:noFill/>
-        </p:spPr>
-        <p:txBody>
-          <a:bodyPr wrap="square">
-            <a:spAutoFit/>
-          </a:bodyPr>
-          <a:lstStyle/>
-          <a:p>
-            <a:r>
-              <a:rPr sz="1000" b="0" i="0">
-                <a:solidFill>
-                  <a:srgbClr val="475569"/>
-                </a:solidFill>
-                <a:latin typeface="Times New Roman"/>
-                <a:ea typeface="宋体"/>
-              </a:rPr>
-              <a:t>全库清扫 + 自动修复
-安全变更自动应用
-风险变更确认后执行</a:t>
+              <a:rPr sz="900" b="1">
+                <a:solidFill>
+                  <a:srgbClr val="555555"/>
+                </a:solidFill>
+                <a:latin typeface="Times New Roman"/>
+              </a:rPr>
+              <a:t>🆕 correction 类型收割（ADR-012/013）：</a:t>
+            </a:r>
+            <a:r>
+              <a:rPr sz="900">
+                <a:solidFill>
+                  <a:srgbClr val="555555"/>
+                </a:solidFill>
+                <a:latin typeface="Times New Roman"/>
+              </a:rPr>
+              <a:t>SessionStart 按 correction 类型分类型收割：compliance/未知→自动清除；l3-model-missing/l2-model-missing→持续提示至模型配齐；l2-missing→持久化记录等主 agent 补 L2 段。</a:t>
             </a:r>
           </a:p>
         </p:txBody>
@@ -6922,21 +6500,66 @@
                 <a:latin typeface="Times New Roman"/>
                 <a:ea typeface="宋体"/>
               </a:rPr>
-              <a:t>典型工作流：新功能开发 10 步</a:t>
-            </a:r>
-          </a:p>
-        </p:txBody>
-      </p:sp>
-      <p:sp>
-        <p:nvSpPr>
-          <p:cNvPr id="4" name="TextBox 3"/>
+              <a:t>brooks-lint 代码审查插件</a:t>
+            </a:r>
+          </a:p>
+        </p:txBody>
+      </p:sp>
+      <p:sp>
+        <p:nvSpPr>
+          <p:cNvPr id="4" name="Rectangle 3"/>
+          <p:cNvSpPr/>
+          <p:nvPr/>
+        </p:nvSpPr>
+        <p:spPr>
+          <a:xfrm>
+            <a:off x="731520" y="1234440"/>
+            <a:ext cx="3291840" cy="2103120"/>
+          </a:xfrm>
+          <a:prstGeom prst="rect">
+            <a:avLst/>
+          </a:prstGeom>
+          <a:solidFill>
+            <a:srgbClr val="FFFFFF"/>
+          </a:solidFill>
+          <a:ln w="12700">
+            <a:solidFill>
+              <a:srgbClr val="E2E8F0"/>
+            </a:solidFill>
+          </a:ln>
+        </p:spPr>
+        <p:style>
+          <a:lnRef idx="1">
+            <a:schemeClr val="accent1"/>
+          </a:lnRef>
+          <a:fillRef idx="3">
+            <a:schemeClr val="accent1"/>
+          </a:fillRef>
+          <a:effectRef idx="2">
+            <a:schemeClr val="accent1"/>
+          </a:effectRef>
+          <a:fontRef idx="minor">
+            <a:schemeClr val="lt1"/>
+          </a:fontRef>
+        </p:style>
+        <p:txBody>
+          <a:bodyPr rtlCol="0" anchor="ctr"/>
+          <a:lstStyle/>
+          <a:p>
+            <a:pPr algn="ctr"/>
+          </a:p>
+        </p:txBody>
+      </p:sp>
+      <p:sp>
+        <p:nvSpPr>
+          <p:cNvPr id="5" name="TextBox 4"/>
           <p:cNvSpPr txBox="1"/>
           <p:nvPr/>
         </p:nvSpPr>
         <p:spPr>
           <a:xfrm>
-            <a:off x="731520" y="1280160"/>
-            <a:ext cx="10698480" cy="4754880"/>
+            <a:off x="914400" y="1371600"/>
+            <a:ext cx="2926080" cy="365760"/>
           </a:xfrm>
           <a:prstGeom prst="rect">
             <a:avLst/>
@@ -6950,235 +6573,636 @@
           <a:lstStyle/>
           <a:p>
             <a:r>
-              <a:rPr sz="1300" b="0" i="0">
-                <a:solidFill>
-                  <a:srgbClr val="475569"/>
-                </a:solidFill>
-                <a:latin typeface="Times New Roman"/>
-                <a:ea typeface="宋体"/>
-              </a:rPr>
-              <a:t>步骤 0：/flow start（仅首次，初始化 .flow-active）</a:t>
-            </a:r>
-          </a:p>
-          <a:p>
-            <a:pPr>
-              <a:spcBef>
-                <a:spcPts val="600"/>
-              </a:spcBef>
-            </a:pPr>
-            <a:r>
-              <a:rPr sz="1300" b="0" i="0">
-                <a:solidFill>
-                  <a:srgbClr val="475569"/>
-                </a:solidFill>
-                <a:latin typeface="Times New Roman"/>
-                <a:ea typeface="宋体"/>
-              </a:rPr>
-              <a:t>步骤 1：/flow-go 我想加一个通知中心 → AI 路由到阶段 0，生成 change-id + CHANGE.md</a:t>
-            </a:r>
-          </a:p>
-          <a:p>
-            <a:pPr>
-              <a:spcBef>
-                <a:spcPts val="600"/>
-              </a:spcBef>
-            </a:pPr>
-            <a:r>
-              <a:rPr sz="1300" b="0" i="0">
-                <a:solidFill>
-                  <a:srgbClr val="475569"/>
-                </a:solidFill>
-                <a:latin typeface="Times New Roman"/>
-                <a:ea typeface="宋体"/>
-              </a:rPr>
-              <a:t>步骤 2：/flow-go 写需求 → 阶段 1，REQUIREMENT.md（Given/When/Then AC）</a:t>
-            </a:r>
-          </a:p>
-          <a:p>
-            <a:pPr>
-              <a:spcBef>
-                <a:spcPts val="600"/>
-              </a:spcBef>
-            </a:pPr>
-            <a:r>
-              <a:rPr sz="1300" b="0" i="0">
-                <a:solidFill>
-                  <a:srgbClr val="475569"/>
-                </a:solidFill>
-                <a:latin typeface="Times New Roman"/>
-                <a:ea typeface="宋体"/>
-              </a:rPr>
-              <a:t>步骤 3：/flow-go 做技术设计 → 阶段 2，技术栈预选 + 既有架构对齐 + ADR</a:t>
-            </a:r>
-          </a:p>
-          <a:p>
-            <a:pPr>
-              <a:spcBef>
-                <a:spcPts val="600"/>
-              </a:spcBef>
-            </a:pPr>
-            <a:r>
-              <a:rPr sz="1300" b="0" i="0">
-                <a:solidFill>
-                  <a:srgbClr val="475569"/>
-                </a:solidFill>
-                <a:latin typeface="Times New Roman"/>
-                <a:ea typeface="宋体"/>
-              </a:rPr>
-              <a:t>步骤 4：/flow-go 确定 UI 设计 → 阶段 2a（前端项目），Design Tokens + 组件规约</a:t>
-            </a:r>
-          </a:p>
-          <a:p>
-            <a:pPr>
-              <a:spcBef>
-                <a:spcPts val="600"/>
-              </a:spcBef>
-            </a:pPr>
-            <a:r>
-              <a:rPr sz="1300" b="0" i="0">
-                <a:solidFill>
-                  <a:srgbClr val="475569"/>
-                </a:solidFill>
-                <a:latin typeface="Times New Roman"/>
-                <a:ea typeface="宋体"/>
-              </a:rPr>
-              <a:t>步骤 5：/flow-go 拆任务 → 阶段 3，TASK.md（T1, T2, T3... + 波次划分）</a:t>
-            </a:r>
-          </a:p>
-          <a:p>
-            <a:pPr>
-              <a:spcBef>
-                <a:spcPts val="600"/>
-              </a:spcBef>
-            </a:pPr>
-            <a:r>
-              <a:rPr sz="1300" b="0" i="0">
-                <a:solidFill>
-                  <a:srgbClr val="475569"/>
-                </a:solidFill>
-                <a:latin typeface="Times New Roman"/>
-                <a:ea typeface="宋体"/>
-              </a:rPr>
-              <a:t>步骤 6：/flow-go 执行 T1 → 阶段 4，TDD 驱动开发 → T1-SUMMARY.md</a:t>
-            </a:r>
-          </a:p>
-          <a:p>
-            <a:pPr>
-              <a:spcBef>
-                <a:spcPts val="600"/>
-              </a:spcBef>
-            </a:pPr>
-            <a:r>
-              <a:rPr sz="1300" b="0" i="0">
-                <a:solidFill>
-                  <a:srgbClr val="475569"/>
-                </a:solidFill>
-                <a:latin typeface="Times New Roman"/>
-                <a:ea typeface="宋体"/>
-              </a:rPr>
-              <a:t>步骤 7：/flow-go 开始测试 → 阶段 5，五轮测试金字塔 → TEST.md</a:t>
-            </a:r>
-          </a:p>
-          <a:p>
-            <a:pPr>
-              <a:spcBef>
-                <a:spcPts val="600"/>
-              </a:spcBef>
-            </a:pPr>
-            <a:r>
-              <a:rPr sz="1300" b="0" i="0">
-                <a:solidFill>
-                  <a:srgbClr val="475569"/>
-                </a:solidFill>
-                <a:latin typeface="Times New Roman"/>
-                <a:ea typeface="宋体"/>
-              </a:rPr>
-              <a:t>步骤 8：/flow-go 审查代码 → 阶段 6，三轮审查（spec + 代码质量 + UI）→ REVIEW.md</a:t>
-            </a:r>
-          </a:p>
-          <a:p>
-            <a:pPr>
-              <a:spcBef>
-                <a:spcPts val="600"/>
-              </a:spcBef>
-            </a:pPr>
-            <a:r>
-              <a:rPr sz="1300" b="0" i="0">
-                <a:solidFill>
-                  <a:srgbClr val="475569"/>
-                </a:solidFill>
-                <a:latin typeface="Times New Roman"/>
-                <a:ea typeface="宋体"/>
-              </a:rPr>
-              <a:t>步骤 9：/flow-go 集成上线 → 阶段 7，自动化验证 + UAT + 归档</a:t>
-            </a:r>
-          </a:p>
-          <a:p>
-            <a:pPr>
-              <a:spcBef>
-                <a:spcPts val="600"/>
-              </a:spcBef>
-            </a:pPr>
-            <a:r>
-              <a:rPr sz="1300" b="0" i="0">
-                <a:solidFill>
-                  <a:srgbClr val="475569"/>
-                </a:solidFill>
-                <a:latin typeface="Times New Roman"/>
-                <a:ea typeface="宋体"/>
-              </a:rPr>
-              <a:t>步骤 10：/flow stop → /flow-go 同步架构（A-evolve 沉淀本次架构变更）</a:t>
-            </a:r>
-          </a:p>
-          <a:p>
-            <a:pPr>
-              <a:spcBef>
-                <a:spcPts val="600"/>
-              </a:spcBef>
-            </a:pPr>
-            <a:r>
-              <a:rPr sz="800" b="0" i="0">
-                <a:solidFill>
-                  <a:srgbClr val="475569"/>
-                </a:solidFill>
-                <a:latin typeface="Times New Roman"/>
-                <a:ea typeface="宋体"/>
-              </a:rPr>
-              <a:t/>
-            </a:r>
-          </a:p>
-          <a:p>
-            <a:pPr>
-              <a:spcBef>
-                <a:spcPts val="600"/>
-              </a:spcBef>
-            </a:pPr>
-            <a:r>
-              <a:rPr sz="1200" b="1" i="0">
-                <a:solidFill>
-                  <a:srgbClr val="1E293B"/>
-                </a:solidFill>
-                <a:latin typeface="Times New Roman"/>
-                <a:ea typeface="宋体"/>
-              </a:rPr>
-              <a:t>提示：阶段 0→1→2→2a→3 可以在同一轮对话里连续做——每完成一个阶段 AI 会主动提示下一步，只需回复“继续”。</a:t>
-            </a:r>
-          </a:p>
-          <a:p>
-            <a:pPr>
-              <a:spcBef>
-                <a:spcPts val="600"/>
-              </a:spcBef>
-            </a:pPr>
-            <a:r>
-              <a:rPr sz="1200" b="1" i="0">
-                <a:solidFill>
-                  <a:srgbClr val="1E293B"/>
-                </a:solidFill>
-                <a:latin typeface="Times New Roman"/>
-                <a:ea typeface="宋体"/>
-              </a:rPr>
-              <a:t>小改动（&lt; 50 行）可走压缩流程：AI 判断后可跳过阶段 1/2/3，直接进入阶段 4。</a:t>
+              <a:rPr sz="1400" b="1" i="0">
+                <a:solidFill>
+                  <a:srgbClr val="2563EB"/>
+                </a:solidFill>
+                <a:latin typeface="Times New Roman"/>
+                <a:ea typeface="宋体"/>
+              </a:rPr>
+              <a:t>/brooks-review</a:t>
+            </a:r>
+          </a:p>
+        </p:txBody>
+      </p:sp>
+      <p:sp>
+        <p:nvSpPr>
+          <p:cNvPr id="6" name="TextBox 5"/>
+          <p:cNvSpPr txBox="1"/>
+          <p:nvPr/>
+        </p:nvSpPr>
+        <p:spPr>
+          <a:xfrm>
+            <a:off x="914400" y="1783080"/>
+            <a:ext cx="2926080" cy="1371600"/>
+          </a:xfrm>
+          <a:prstGeom prst="rect">
+            <a:avLst/>
+          </a:prstGeom>
+          <a:noFill/>
+        </p:spPr>
+        <p:txBody>
+          <a:bodyPr wrap="square">
+            <a:spAutoFit/>
+          </a:bodyPr>
+          <a:lstStyle/>
+          <a:p>
+            <a:r>
+              <a:rPr sz="1000" b="0" i="0">
+                <a:solidFill>
+                  <a:srgbClr val="475569"/>
+                </a:solidFill>
+                <a:latin typeface="Times New Roman"/>
+                <a:ea typeface="宋体"/>
+              </a:rPr>
+              <a:t>PR 代码审查
+发现衰退风险和设计坏味
+Symptom→Source→Consequence→Remedy</a:t>
+            </a:r>
+          </a:p>
+        </p:txBody>
+      </p:sp>
+      <p:sp>
+        <p:nvSpPr>
+          <p:cNvPr id="7" name="Rectangle 6"/>
+          <p:cNvSpPr/>
+          <p:nvPr/>
+        </p:nvSpPr>
+        <p:spPr>
+          <a:xfrm>
+            <a:off x="4251960" y="1234440"/>
+            <a:ext cx="3291840" cy="2103120"/>
+          </a:xfrm>
+          <a:prstGeom prst="rect">
+            <a:avLst/>
+          </a:prstGeom>
+          <a:solidFill>
+            <a:srgbClr val="FFFFFF"/>
+          </a:solidFill>
+          <a:ln w="12700">
+            <a:solidFill>
+              <a:srgbClr val="E2E8F0"/>
+            </a:solidFill>
+          </a:ln>
+        </p:spPr>
+        <p:style>
+          <a:lnRef idx="1">
+            <a:schemeClr val="accent1"/>
+          </a:lnRef>
+          <a:fillRef idx="3">
+            <a:schemeClr val="accent1"/>
+          </a:fillRef>
+          <a:effectRef idx="2">
+            <a:schemeClr val="accent1"/>
+          </a:effectRef>
+          <a:fontRef idx="minor">
+            <a:schemeClr val="lt1"/>
+          </a:fontRef>
+        </p:style>
+        <p:txBody>
+          <a:bodyPr rtlCol="0" anchor="ctr"/>
+          <a:lstStyle/>
+          <a:p>
+            <a:pPr algn="ctr"/>
+          </a:p>
+        </p:txBody>
+      </p:sp>
+      <p:sp>
+        <p:nvSpPr>
+          <p:cNvPr id="8" name="TextBox 7"/>
+          <p:cNvSpPr txBox="1"/>
+          <p:nvPr/>
+        </p:nvSpPr>
+        <p:spPr>
+          <a:xfrm>
+            <a:off x="4434840" y="1371600"/>
+            <a:ext cx="2926080" cy="365760"/>
+          </a:xfrm>
+          <a:prstGeom prst="rect">
+            <a:avLst/>
+          </a:prstGeom>
+          <a:noFill/>
+        </p:spPr>
+        <p:txBody>
+          <a:bodyPr wrap="square">
+            <a:spAutoFit/>
+          </a:bodyPr>
+          <a:lstStyle/>
+          <a:p>
+            <a:r>
+              <a:rPr sz="1400" b="1" i="0">
+                <a:solidFill>
+                  <a:srgbClr val="2563EB"/>
+                </a:solidFill>
+                <a:latin typeface="Times New Roman"/>
+                <a:ea typeface="宋体"/>
+              </a:rPr>
+              <a:t>/brooks-audit</a:t>
+            </a:r>
+          </a:p>
+        </p:txBody>
+      </p:sp>
+      <p:sp>
+        <p:nvSpPr>
+          <p:cNvPr id="9" name="TextBox 8"/>
+          <p:cNvSpPr txBox="1"/>
+          <p:nvPr/>
+        </p:nvSpPr>
+        <p:spPr>
+          <a:xfrm>
+            <a:off x="4434840" y="1783080"/>
+            <a:ext cx="2926080" cy="1371600"/>
+          </a:xfrm>
+          <a:prstGeom prst="rect">
+            <a:avLst/>
+          </a:prstGeom>
+          <a:noFill/>
+        </p:spPr>
+        <p:txBody>
+          <a:bodyPr wrap="square">
+            <a:spAutoFit/>
+          </a:bodyPr>
+          <a:lstStyle/>
+          <a:p>
+            <a:r>
+              <a:rPr sz="1000" b="0" i="0">
+                <a:solidFill>
+                  <a:srgbClr val="475569"/>
+                </a:solidFill>
+                <a:latin typeface="Times New Roman"/>
+                <a:ea typeface="宋体"/>
+              </a:rPr>
+              <a:t>架构审计
+模块依赖图 + 分层完整性
++ 循环依赖检测</a:t>
+            </a:r>
+          </a:p>
+        </p:txBody>
+      </p:sp>
+      <p:sp>
+        <p:nvSpPr>
+          <p:cNvPr id="10" name="Rectangle 9"/>
+          <p:cNvSpPr/>
+          <p:nvPr/>
+        </p:nvSpPr>
+        <p:spPr>
+          <a:xfrm>
+            <a:off x="7772400" y="1234440"/>
+            <a:ext cx="3291840" cy="2103120"/>
+          </a:xfrm>
+          <a:prstGeom prst="rect">
+            <a:avLst/>
+          </a:prstGeom>
+          <a:solidFill>
+            <a:srgbClr val="FFFFFF"/>
+          </a:solidFill>
+          <a:ln w="12700">
+            <a:solidFill>
+              <a:srgbClr val="E2E8F0"/>
+            </a:solidFill>
+          </a:ln>
+        </p:spPr>
+        <p:style>
+          <a:lnRef idx="1">
+            <a:schemeClr val="accent1"/>
+          </a:lnRef>
+          <a:fillRef idx="3">
+            <a:schemeClr val="accent1"/>
+          </a:fillRef>
+          <a:effectRef idx="2">
+            <a:schemeClr val="accent1"/>
+          </a:effectRef>
+          <a:fontRef idx="minor">
+            <a:schemeClr val="lt1"/>
+          </a:fontRef>
+        </p:style>
+        <p:txBody>
+          <a:bodyPr rtlCol="0" anchor="ctr"/>
+          <a:lstStyle/>
+          <a:p>
+            <a:pPr algn="ctr"/>
+          </a:p>
+        </p:txBody>
+      </p:sp>
+      <p:sp>
+        <p:nvSpPr>
+          <p:cNvPr id="11" name="TextBox 10"/>
+          <p:cNvSpPr txBox="1"/>
+          <p:nvPr/>
+        </p:nvSpPr>
+        <p:spPr>
+          <a:xfrm>
+            <a:off x="7955280" y="1371600"/>
+            <a:ext cx="2926080" cy="365760"/>
+          </a:xfrm>
+          <a:prstGeom prst="rect">
+            <a:avLst/>
+          </a:prstGeom>
+          <a:noFill/>
+        </p:spPr>
+        <p:txBody>
+          <a:bodyPr wrap="square">
+            <a:spAutoFit/>
+          </a:bodyPr>
+          <a:lstStyle/>
+          <a:p>
+            <a:r>
+              <a:rPr sz="1400" b="1" i="0">
+                <a:solidFill>
+                  <a:srgbClr val="2563EB"/>
+                </a:solidFill>
+                <a:latin typeface="Times New Roman"/>
+                <a:ea typeface="宋体"/>
+              </a:rPr>
+              <a:t>/brooks-debt</a:t>
+            </a:r>
+          </a:p>
+        </p:txBody>
+      </p:sp>
+      <p:sp>
+        <p:nvSpPr>
+          <p:cNvPr id="12" name="TextBox 11"/>
+          <p:cNvSpPr txBox="1"/>
+          <p:nvPr/>
+        </p:nvSpPr>
+        <p:spPr>
+          <a:xfrm>
+            <a:off x="7955280" y="1783080"/>
+            <a:ext cx="2926080" cy="1371600"/>
+          </a:xfrm>
+          <a:prstGeom prst="rect">
+            <a:avLst/>
+          </a:prstGeom>
+          <a:noFill/>
+        </p:spPr>
+        <p:txBody>
+          <a:bodyPr wrap="square">
+            <a:spAutoFit/>
+          </a:bodyPr>
+          <a:lstStyle/>
+          <a:p>
+            <a:r>
+              <a:rPr sz="1000" b="0" i="0">
+                <a:solidFill>
+                  <a:srgbClr val="475569"/>
+                </a:solidFill>
+                <a:latin typeface="Times New Roman"/>
+                <a:ea typeface="宋体"/>
+              </a:rPr>
+              <a:t>技术债评估
+分类 + 优先级排序
+构建重构路线图</a:t>
+            </a:r>
+          </a:p>
+        </p:txBody>
+      </p:sp>
+      <p:sp>
+        <p:nvSpPr>
+          <p:cNvPr id="13" name="Rectangle 12"/>
+          <p:cNvSpPr/>
+          <p:nvPr/>
+        </p:nvSpPr>
+        <p:spPr>
+          <a:xfrm>
+            <a:off x="731520" y="3566160"/>
+            <a:ext cx="3291840" cy="2103120"/>
+          </a:xfrm>
+          <a:prstGeom prst="rect">
+            <a:avLst/>
+          </a:prstGeom>
+          <a:solidFill>
+            <a:srgbClr val="FFFFFF"/>
+          </a:solidFill>
+          <a:ln w="12700">
+            <a:solidFill>
+              <a:srgbClr val="E2E8F0"/>
+            </a:solidFill>
+          </a:ln>
+        </p:spPr>
+        <p:style>
+          <a:lnRef idx="1">
+            <a:schemeClr val="accent1"/>
+          </a:lnRef>
+          <a:fillRef idx="3">
+            <a:schemeClr val="accent1"/>
+          </a:fillRef>
+          <a:effectRef idx="2">
+            <a:schemeClr val="accent1"/>
+          </a:effectRef>
+          <a:fontRef idx="minor">
+            <a:schemeClr val="lt1"/>
+          </a:fontRef>
+        </p:style>
+        <p:txBody>
+          <a:bodyPr rtlCol="0" anchor="ctr"/>
+          <a:lstStyle/>
+          <a:p>
+            <a:pPr algn="ctr"/>
+          </a:p>
+        </p:txBody>
+      </p:sp>
+      <p:sp>
+        <p:nvSpPr>
+          <p:cNvPr id="14" name="TextBox 13"/>
+          <p:cNvSpPr txBox="1"/>
+          <p:nvPr/>
+        </p:nvSpPr>
+        <p:spPr>
+          <a:xfrm>
+            <a:off x="914400" y="3703320"/>
+            <a:ext cx="2926080" cy="365760"/>
+          </a:xfrm>
+          <a:prstGeom prst="rect">
+            <a:avLst/>
+          </a:prstGeom>
+          <a:noFill/>
+        </p:spPr>
+        <p:txBody>
+          <a:bodyPr wrap="square">
+            <a:spAutoFit/>
+          </a:bodyPr>
+          <a:lstStyle/>
+          <a:p>
+            <a:r>
+              <a:rPr sz="1400" b="1" i="0">
+                <a:solidFill>
+                  <a:srgbClr val="2563EB"/>
+                </a:solidFill>
+                <a:latin typeface="Times New Roman"/>
+                <a:ea typeface="宋体"/>
+              </a:rPr>
+              <a:t>/brooks-test</a:t>
+            </a:r>
+          </a:p>
+        </p:txBody>
+      </p:sp>
+      <p:sp>
+        <p:nvSpPr>
+          <p:cNvPr id="15" name="TextBox 14"/>
+          <p:cNvSpPr txBox="1"/>
+          <p:nvPr/>
+        </p:nvSpPr>
+        <p:spPr>
+          <a:xfrm>
+            <a:off x="914400" y="4114800"/>
+            <a:ext cx="2926080" cy="1371600"/>
+          </a:xfrm>
+          <a:prstGeom prst="rect">
+            <a:avLst/>
+          </a:prstGeom>
+          <a:noFill/>
+        </p:spPr>
+        <p:txBody>
+          <a:bodyPr wrap="square">
+            <a:spAutoFit/>
+          </a:bodyPr>
+          <a:lstStyle/>
+          <a:p>
+            <a:r>
+              <a:rPr sz="1000" b="0" i="0">
+                <a:solidFill>
+                  <a:srgbClr val="475569"/>
+                </a:solidFill>
+                <a:latin typeface="Times New Roman"/>
+                <a:ea typeface="宋体"/>
+              </a:rPr>
+              <a:t>测试质量审查
+脆性测试 / mock 滥用
+/ 覆盖率幻觉诊断</a:t>
+            </a:r>
+          </a:p>
+        </p:txBody>
+      </p:sp>
+      <p:sp>
+        <p:nvSpPr>
+          <p:cNvPr id="16" name="Rectangle 15"/>
+          <p:cNvSpPr/>
+          <p:nvPr/>
+        </p:nvSpPr>
+        <p:spPr>
+          <a:xfrm>
+            <a:off x="4251960" y="3566160"/>
+            <a:ext cx="3291840" cy="2103120"/>
+          </a:xfrm>
+          <a:prstGeom prst="rect">
+            <a:avLst/>
+          </a:prstGeom>
+          <a:solidFill>
+            <a:srgbClr val="FFFFFF"/>
+          </a:solidFill>
+          <a:ln w="12700">
+            <a:solidFill>
+              <a:srgbClr val="E2E8F0"/>
+            </a:solidFill>
+          </a:ln>
+        </p:spPr>
+        <p:style>
+          <a:lnRef idx="1">
+            <a:schemeClr val="accent1"/>
+          </a:lnRef>
+          <a:fillRef idx="3">
+            <a:schemeClr val="accent1"/>
+          </a:fillRef>
+          <a:effectRef idx="2">
+            <a:schemeClr val="accent1"/>
+          </a:effectRef>
+          <a:fontRef idx="minor">
+            <a:schemeClr val="lt1"/>
+          </a:fontRef>
+        </p:style>
+        <p:txBody>
+          <a:bodyPr rtlCol="0" anchor="ctr"/>
+          <a:lstStyle/>
+          <a:p>
+            <a:pPr algn="ctr"/>
+          </a:p>
+        </p:txBody>
+      </p:sp>
+      <p:sp>
+        <p:nvSpPr>
+          <p:cNvPr id="17" name="TextBox 16"/>
+          <p:cNvSpPr txBox="1"/>
+          <p:nvPr/>
+        </p:nvSpPr>
+        <p:spPr>
+          <a:xfrm>
+            <a:off x="4434840" y="3703320"/>
+            <a:ext cx="2926080" cy="365760"/>
+          </a:xfrm>
+          <a:prstGeom prst="rect">
+            <a:avLst/>
+          </a:prstGeom>
+          <a:noFill/>
+        </p:spPr>
+        <p:txBody>
+          <a:bodyPr wrap="square">
+            <a:spAutoFit/>
+          </a:bodyPr>
+          <a:lstStyle/>
+          <a:p>
+            <a:r>
+              <a:rPr sz="1400" b="1" i="0">
+                <a:solidFill>
+                  <a:srgbClr val="2563EB"/>
+                </a:solidFill>
+                <a:latin typeface="Times New Roman"/>
+                <a:ea typeface="宋体"/>
+              </a:rPr>
+              <a:t>/brooks-health</a:t>
+            </a:r>
+          </a:p>
+        </p:txBody>
+      </p:sp>
+      <p:sp>
+        <p:nvSpPr>
+          <p:cNvPr id="18" name="TextBox 17"/>
+          <p:cNvSpPr txBox="1"/>
+          <p:nvPr/>
+        </p:nvSpPr>
+        <p:spPr>
+          <a:xfrm>
+            <a:off x="4434840" y="4114800"/>
+            <a:ext cx="2926080" cy="1371600"/>
+          </a:xfrm>
+          <a:prstGeom prst="rect">
+            <a:avLst/>
+          </a:prstGeom>
+          <a:noFill/>
+        </p:spPr>
+        <p:txBody>
+          <a:bodyPr wrap="square">
+            <a:spAutoFit/>
+          </a:bodyPr>
+          <a:lstStyle/>
+          <a:p>
+            <a:r>
+              <a:rPr sz="1000" b="0" i="0">
+                <a:solidFill>
+                  <a:srgbClr val="475569"/>
+                </a:solidFill>
+                <a:latin typeface="Times New Roman"/>
+                <a:ea typeface="宋体"/>
+              </a:rPr>
+              <a:t>代码库健康仪表盘
+四维综合评分
+PR/架构/技术债/测试</a:t>
+            </a:r>
+          </a:p>
+        </p:txBody>
+      </p:sp>
+      <p:sp>
+        <p:nvSpPr>
+          <p:cNvPr id="19" name="Rectangle 18"/>
+          <p:cNvSpPr/>
+          <p:nvPr/>
+        </p:nvSpPr>
+        <p:spPr>
+          <a:xfrm>
+            <a:off x="7772400" y="3566160"/>
+            <a:ext cx="3291840" cy="2103120"/>
+          </a:xfrm>
+          <a:prstGeom prst="rect">
+            <a:avLst/>
+          </a:prstGeom>
+          <a:solidFill>
+            <a:srgbClr val="FFFFFF"/>
+          </a:solidFill>
+          <a:ln w="12700">
+            <a:solidFill>
+              <a:srgbClr val="E2E8F0"/>
+            </a:solidFill>
+          </a:ln>
+        </p:spPr>
+        <p:style>
+          <a:lnRef idx="1">
+            <a:schemeClr val="accent1"/>
+          </a:lnRef>
+          <a:fillRef idx="3">
+            <a:schemeClr val="accent1"/>
+          </a:fillRef>
+          <a:effectRef idx="2">
+            <a:schemeClr val="accent1"/>
+          </a:effectRef>
+          <a:fontRef idx="minor">
+            <a:schemeClr val="lt1"/>
+          </a:fontRef>
+        </p:style>
+        <p:txBody>
+          <a:bodyPr rtlCol="0" anchor="ctr"/>
+          <a:lstStyle/>
+          <a:p>
+            <a:pPr algn="ctr"/>
+          </a:p>
+        </p:txBody>
+      </p:sp>
+      <p:sp>
+        <p:nvSpPr>
+          <p:cNvPr id="20" name="TextBox 19"/>
+          <p:cNvSpPr txBox="1"/>
+          <p:nvPr/>
+        </p:nvSpPr>
+        <p:spPr>
+          <a:xfrm>
+            <a:off x="7955280" y="3703320"/>
+            <a:ext cx="2926080" cy="365760"/>
+          </a:xfrm>
+          <a:prstGeom prst="rect">
+            <a:avLst/>
+          </a:prstGeom>
+          <a:noFill/>
+        </p:spPr>
+        <p:txBody>
+          <a:bodyPr wrap="square">
+            <a:spAutoFit/>
+          </a:bodyPr>
+          <a:lstStyle/>
+          <a:p>
+            <a:r>
+              <a:rPr sz="1400" b="1" i="0">
+                <a:solidFill>
+                  <a:srgbClr val="2563EB"/>
+                </a:solidFill>
+                <a:latin typeface="Times New Roman"/>
+                <a:ea typeface="宋体"/>
+              </a:rPr>
+              <a:t>/brooks-sweep</a:t>
+            </a:r>
+          </a:p>
+        </p:txBody>
+      </p:sp>
+      <p:sp>
+        <p:nvSpPr>
+          <p:cNvPr id="21" name="TextBox 20"/>
+          <p:cNvSpPr txBox="1"/>
+          <p:nvPr/>
+        </p:nvSpPr>
+        <p:spPr>
+          <a:xfrm>
+            <a:off x="7955280" y="4114800"/>
+            <a:ext cx="2926080" cy="1371600"/>
+          </a:xfrm>
+          <a:prstGeom prst="rect">
+            <a:avLst/>
+          </a:prstGeom>
+          <a:noFill/>
+        </p:spPr>
+        <p:txBody>
+          <a:bodyPr wrap="square">
+            <a:spAutoFit/>
+          </a:bodyPr>
+          <a:lstStyle/>
+          <a:p>
+            <a:r>
+              <a:rPr sz="1000" b="0" i="0">
+                <a:solidFill>
+                  <a:srgbClr val="475569"/>
+                </a:solidFill>
+                <a:latin typeface="Times New Roman"/>
+                <a:ea typeface="宋体"/>
+              </a:rPr>
+              <a:t>全库清扫 + 自动修复
+安全变更自动应用
+风险变更确认后执行</a:t>
             </a:r>
           </a:p>
         </p:txBody>
@@ -7274,6 +7298,358 @@
                 <a:latin typeface="Times New Roman"/>
                 <a:ea typeface="宋体"/>
               </a:rPr>
+              <a:t>典型工作流：新功能开发 10 步</a:t>
+            </a:r>
+          </a:p>
+        </p:txBody>
+      </p:sp>
+      <p:sp>
+        <p:nvSpPr>
+          <p:cNvPr id="4" name="TextBox 3"/>
+          <p:cNvSpPr txBox="1"/>
+          <p:nvPr/>
+        </p:nvSpPr>
+        <p:spPr>
+          <a:xfrm>
+            <a:off x="731520" y="1280160"/>
+            <a:ext cx="10698480" cy="4754880"/>
+          </a:xfrm>
+          <a:prstGeom prst="rect">
+            <a:avLst/>
+          </a:prstGeom>
+          <a:noFill/>
+        </p:spPr>
+        <p:txBody>
+          <a:bodyPr wrap="square">
+            <a:spAutoFit/>
+          </a:bodyPr>
+          <a:lstStyle/>
+          <a:p>
+            <a:r>
+              <a:rPr sz="1300" b="0" i="0">
+                <a:solidFill>
+                  <a:srgbClr val="475569"/>
+                </a:solidFill>
+                <a:latin typeface="Times New Roman"/>
+                <a:ea typeface="宋体"/>
+              </a:rPr>
+              <a:t>步骤 0：/flow start（仅首次，初始化 .flow-active）</a:t>
+            </a:r>
+          </a:p>
+          <a:p>
+            <a:pPr>
+              <a:spcBef>
+                <a:spcPts val="600"/>
+              </a:spcBef>
+            </a:pPr>
+            <a:r>
+              <a:rPr sz="1300" b="0" i="0">
+                <a:solidFill>
+                  <a:srgbClr val="475569"/>
+                </a:solidFill>
+                <a:latin typeface="Times New Roman"/>
+                <a:ea typeface="宋体"/>
+              </a:rPr>
+              <a:t>步骤 1：/flow-go 我想加一个通知中心 → AI 路由到阶段 0，生成 change-id + CHANGE.md</a:t>
+            </a:r>
+          </a:p>
+          <a:p>
+            <a:pPr>
+              <a:spcBef>
+                <a:spcPts val="600"/>
+              </a:spcBef>
+            </a:pPr>
+            <a:r>
+              <a:rPr sz="1300" b="0" i="0">
+                <a:solidFill>
+                  <a:srgbClr val="475569"/>
+                </a:solidFill>
+                <a:latin typeface="Times New Roman"/>
+                <a:ea typeface="宋体"/>
+              </a:rPr>
+              <a:t>步骤 2：/flow-go 写需求 → 阶段 1，REQUIREMENT.md（Given/When/Then AC）</a:t>
+            </a:r>
+          </a:p>
+          <a:p>
+            <a:pPr>
+              <a:spcBef>
+                <a:spcPts val="600"/>
+              </a:spcBef>
+            </a:pPr>
+            <a:r>
+              <a:rPr sz="1300" b="0" i="0">
+                <a:solidFill>
+                  <a:srgbClr val="475569"/>
+                </a:solidFill>
+                <a:latin typeface="Times New Roman"/>
+                <a:ea typeface="宋体"/>
+              </a:rPr>
+              <a:t>步骤 3：/flow-go 做技术设计 → 阶段 2，技术栈预选 + 既有架构对齐 + ADR</a:t>
+            </a:r>
+          </a:p>
+          <a:p>
+            <a:pPr>
+              <a:spcBef>
+                <a:spcPts val="600"/>
+              </a:spcBef>
+            </a:pPr>
+            <a:r>
+              <a:rPr sz="1300" b="0" i="0">
+                <a:solidFill>
+                  <a:srgbClr val="475569"/>
+                </a:solidFill>
+                <a:latin typeface="Times New Roman"/>
+                <a:ea typeface="宋体"/>
+              </a:rPr>
+              <a:t>步骤 4：/flow-go 确定 UI 设计 → 阶段 2a（前端项目），Design Tokens + 组件规约</a:t>
+            </a:r>
+          </a:p>
+          <a:p>
+            <a:pPr>
+              <a:spcBef>
+                <a:spcPts val="600"/>
+              </a:spcBef>
+            </a:pPr>
+            <a:r>
+              <a:rPr sz="1300" b="0" i="0">
+                <a:solidFill>
+                  <a:srgbClr val="475569"/>
+                </a:solidFill>
+                <a:latin typeface="Times New Roman"/>
+                <a:ea typeface="宋体"/>
+              </a:rPr>
+              <a:t>步骤 5：/flow-go 拆任务 → 阶段 3，TASK.md（T1, T2, T3... + 波次划分）</a:t>
+            </a:r>
+          </a:p>
+          <a:p>
+            <a:pPr>
+              <a:spcBef>
+                <a:spcPts val="600"/>
+              </a:spcBef>
+            </a:pPr>
+            <a:r>
+              <a:rPr sz="1300" b="0" i="0">
+                <a:solidFill>
+                  <a:srgbClr val="475569"/>
+                </a:solidFill>
+                <a:latin typeface="Times New Roman"/>
+                <a:ea typeface="宋体"/>
+              </a:rPr>
+              <a:t>步骤 6：/flow-go 执行 T1 → 阶段 4，TDD 驱动开发 → T1-SUMMARY.md</a:t>
+            </a:r>
+          </a:p>
+          <a:p>
+            <a:pPr>
+              <a:spcBef>
+                <a:spcPts val="600"/>
+              </a:spcBef>
+            </a:pPr>
+            <a:r>
+              <a:rPr sz="1300" b="0" i="0">
+                <a:solidFill>
+                  <a:srgbClr val="475569"/>
+                </a:solidFill>
+                <a:latin typeface="Times New Roman"/>
+                <a:ea typeface="宋体"/>
+              </a:rPr>
+              <a:t>步骤 7：/flow-go 开始测试 → 阶段 5，五轮测试金字塔 → TEST.md</a:t>
+            </a:r>
+          </a:p>
+          <a:p>
+            <a:pPr>
+              <a:spcBef>
+                <a:spcPts val="600"/>
+              </a:spcBef>
+            </a:pPr>
+            <a:r>
+              <a:rPr sz="1300" b="0" i="0">
+                <a:solidFill>
+                  <a:srgbClr val="475569"/>
+                </a:solidFill>
+                <a:latin typeface="Times New Roman"/>
+                <a:ea typeface="宋体"/>
+              </a:rPr>
+              <a:t>步骤 8：/flow-go 审查代码 → 阶段 6，三轮审查（spec + 代码质量 + UI）→ REVIEW.md</a:t>
+            </a:r>
+          </a:p>
+          <a:p>
+            <a:pPr>
+              <a:spcBef>
+                <a:spcPts val="600"/>
+              </a:spcBef>
+            </a:pPr>
+            <a:r>
+              <a:rPr sz="1300" b="0" i="0">
+                <a:solidFill>
+                  <a:srgbClr val="475569"/>
+                </a:solidFill>
+                <a:latin typeface="Times New Roman"/>
+                <a:ea typeface="宋体"/>
+              </a:rPr>
+              <a:t>步骤 9：/flow-go 集成上线 → 阶段 7，自动化验证 + UAT + 归档</a:t>
+            </a:r>
+          </a:p>
+          <a:p>
+            <a:pPr>
+              <a:spcBef>
+                <a:spcPts val="600"/>
+              </a:spcBef>
+            </a:pPr>
+            <a:r>
+              <a:rPr sz="1300" b="0" i="0">
+                <a:solidFill>
+                  <a:srgbClr val="475569"/>
+                </a:solidFill>
+                <a:latin typeface="Times New Roman"/>
+                <a:ea typeface="宋体"/>
+              </a:rPr>
+              <a:t>步骤 10：/flow stop → /flow-go 同步架构（A-evolve 沉淀本次架构变更）</a:t>
+            </a:r>
+          </a:p>
+          <a:p>
+            <a:pPr>
+              <a:spcBef>
+                <a:spcPts val="600"/>
+              </a:spcBef>
+            </a:pPr>
+            <a:r>
+              <a:rPr sz="800" b="0" i="0">
+                <a:solidFill>
+                  <a:srgbClr val="475569"/>
+                </a:solidFill>
+                <a:latin typeface="Times New Roman"/>
+                <a:ea typeface="宋体"/>
+              </a:rPr>
+              <a:t/>
+            </a:r>
+          </a:p>
+          <a:p>
+            <a:pPr>
+              <a:spcBef>
+                <a:spcPts val="600"/>
+              </a:spcBef>
+            </a:pPr>
+            <a:r>
+              <a:rPr sz="1200" b="1" i="0">
+                <a:solidFill>
+                  <a:srgbClr val="1E293B"/>
+                </a:solidFill>
+                <a:latin typeface="Times New Roman"/>
+                <a:ea typeface="宋体"/>
+              </a:rPr>
+              <a:t>提示：阶段 0→1→2→2a→3 可以在同一轮对话里连续做——每完成一个阶段 AI 会主动提示下一步，只需回复“继续”。</a:t>
+            </a:r>
+          </a:p>
+          <a:p>
+            <a:pPr>
+              <a:spcBef>
+                <a:spcPts val="600"/>
+              </a:spcBef>
+            </a:pPr>
+            <a:r>
+              <a:rPr sz="1200" b="1" i="0">
+                <a:solidFill>
+                  <a:srgbClr val="1E293B"/>
+                </a:solidFill>
+                <a:latin typeface="Times New Roman"/>
+                <a:ea typeface="宋体"/>
+              </a:rPr>
+              <a:t>小改动（&lt; 50 行）可走压缩流程：AI 判断后可跳过阶段 1/2/3，直接进入阶段 4。</a:t>
+            </a:r>
+          </a:p>
+        </p:txBody>
+      </p:sp>
+    </p:spTree>
+  </p:cSld>
+  <p:clrMapOvr>
+    <a:masterClrMapping/>
+  </p:clrMapOvr>
+</p:sld>
+</file>
+
+<file path=ppt/slides/slide19.xml><?xml version="1.0" encoding="utf-8"?>
+<p:sld xmlns:a="http://schemas.openxmlformats.org/drawingml/2006/main" xmlns:p="http://schemas.openxmlformats.org/presentationml/2006/main" xmlns:r="http://schemas.openxmlformats.org/officeDocument/2006/relationships">
+  <p:cSld>
+    <p:spTree>
+      <p:nvGrpSpPr>
+        <p:cNvPr id="1" name=""/>
+        <p:cNvGrpSpPr/>
+        <p:nvPr/>
+      </p:nvGrpSpPr>
+      <p:grpSpPr/>
+      <p:sp>
+        <p:nvSpPr>
+          <p:cNvPr id="2" name="Rectangle 1"/>
+          <p:cNvSpPr/>
+          <p:nvPr/>
+        </p:nvSpPr>
+        <p:spPr>
+          <a:xfrm>
+            <a:off x="731520" y="320040"/>
+            <a:ext cx="54864" cy="365760"/>
+          </a:xfrm>
+          <a:prstGeom prst="rect">
+            <a:avLst/>
+          </a:prstGeom>
+          <a:solidFill>
+            <a:srgbClr val="2563EB"/>
+          </a:solidFill>
+          <a:ln>
+            <a:noFill/>
+          </a:ln>
+        </p:spPr>
+        <p:style>
+          <a:lnRef idx="1">
+            <a:schemeClr val="accent1"/>
+          </a:lnRef>
+          <a:fillRef idx="3">
+            <a:schemeClr val="accent1"/>
+          </a:fillRef>
+          <a:effectRef idx="2">
+            <a:schemeClr val="accent1"/>
+          </a:effectRef>
+          <a:fontRef idx="minor">
+            <a:schemeClr val="lt1"/>
+          </a:fontRef>
+        </p:style>
+        <p:txBody>
+          <a:bodyPr rtlCol="0" anchor="ctr"/>
+          <a:lstStyle/>
+          <a:p>
+            <a:pPr algn="ctr"/>
+          </a:p>
+        </p:txBody>
+      </p:sp>
+      <p:sp>
+        <p:nvSpPr>
+          <p:cNvPr id="3" name="TextBox 2"/>
+          <p:cNvSpPr txBox="1"/>
+          <p:nvPr/>
+        </p:nvSpPr>
+        <p:spPr>
+          <a:xfrm>
+            <a:off x="914400" y="274320"/>
+            <a:ext cx="10515600" cy="502920"/>
+          </a:xfrm>
+          <a:prstGeom prst="rect">
+            <a:avLst/>
+          </a:prstGeom>
+          <a:noFill/>
+        </p:spPr>
+        <p:txBody>
+          <a:bodyPr wrap="square">
+            <a:spAutoFit/>
+          </a:bodyPr>
+          <a:lstStyle/>
+          <a:p>
+            <a:r>
+              <a:rPr sz="2400" b="1" i="0">
+                <a:solidFill>
+                  <a:srgbClr val="1E293B"/>
+                </a:solidFill>
+                <a:latin typeface="Times New Roman"/>
+                <a:ea typeface="宋体"/>
+              </a:rPr>
               <a:t>文件结构 + Token 预算参考</a:t>
             </a:r>
           </a:p>
@@ -9244,6 +9620,49 @@
                 <a:ea typeface="宋体"/>
               </a:rPr>
               <a:t>审查 → 阶段 6 | 集成 → 阶段 7 | 体检 → M-health | 扫描 → I-intel | 架构 → A-architect</a:t>
+            </a:r>
+          </a:p>
+        </p:txBody>
+      </p:sp>
+      <p:sp>
+        <p:nvSpPr>
+          <p:cNvPr id="5" name="TextBox 4"/>
+          <p:cNvSpPr txBox="1"/>
+          <p:nvPr/>
+        </p:nvSpPr>
+        <p:spPr>
+          <a:xfrm>
+            <a:off x="914400" y="5394960"/>
+            <a:ext cx="7315200" cy="365760"/>
+          </a:xfrm>
+          <a:prstGeom prst="rect">
+            <a:avLst/>
+          </a:prstGeom>
+          <a:noFill/>
+        </p:spPr>
+        <p:txBody>
+          <a:bodyPr wrap="square">
+            <a:spAutoFit/>
+          </a:bodyPr>
+          <a:lstStyle/>
+          <a:p>
+            <a:r>
+              <a:rPr sz="900" b="1">
+                <a:solidFill>
+                  <a:srgbClr val="555555"/>
+                </a:solidFill>
+                <a:latin typeface="Times New Roman"/>
+              </a:rPr>
+              <a:t>🆕 2026-07-24 新增：</a:t>
+            </a:r>
+            <a:r>
+              <a:rPr sz="900">
+                <a:solidFill>
+                  <a:srgbClr val="555555"/>
+                </a:solidFill>
+                <a:latin typeface="Times New Roman"/>
+              </a:rPr>
+              <a:t> | /flow model [l2=&lt;模型&gt;] [l3=&lt;模型&gt;] — 查询/设置 L2/L3 审查模型</a:t>
             </a:r>
           </a:p>
         </p:txBody>

</xml_diff>

<commit_message>
docs(user-guide-sync-2026-09b): 用户指南 + 用户指南 PPT 同步至 2026-09-21 现状
- 指南全量修订（bundle 底稿 +184/-123 · 根副本 +187/-125）：43 条漂移（14红/23黄/6绿）+ 11 条候选新增
- deck 20 → 24 页：新增安装面 / L3 审查链 / 质量门禁 / 版本与副本口径四张专页；deck_checks 改按标题寻址
- 新增守护 test/test_guide_copy_parity.bats（8 用例）：四副本 md5 · 版本口径 · deck 新鲜度 · deck content parity · dist 缺席路径 · 两个非恒绿夹具用例 · installed copy when-present
- 四副本一致（根/bundle/dist docs/dist vendor）+ 窄路径再生 dist + make dsh-sync
- README 安装示例修正 + 新增 dsh 插件段；dsh README 补刷新流程
- 验证：make check 六门全绿 rc=0 · verify-ac 128/0 · 集合断言 59 格/跳过 21/缺失 0 · bats 973 · deck 24 页
- 审查：pipeline 0→7；阶段 1/2/6 L2+L3 双 pass，阶段 3/5/7 按框架熔断透明结案（IR 内审计段）
- 归档：.specs/archive/2026-09-21-user-guide-sync-2026-09b/（31 件 + ARCHIVE-MANIFEST）
</commit_message>
<xml_diff>
--- a/flow-kit-用户指南.pptx
+++ b/flow-kit-用户指南.pptx
@@ -25,6 +25,10 @@
     <p:sldId id="273" r:id="rId24"/>
     <p:sldId id="274" r:id="rId25"/>
     <p:sldId id="275" r:id="rId26"/>
+    <p:sldId id="276" r:id="rId27"/>
+    <p:sldId id="277" r:id="rId28"/>
+    <p:sldId id="278" r:id="rId29"/>
+    <p:sldId id="279" r:id="rId30"/>
   </p:sldIdLst>
   <p:sldSz cx="12191695" cy="6858000" type="screen4x3"/>
   <p:notesSz cx="6858000" cy="9144000"/>
@@ -3308,7 +3312,7 @@
                 <a:ea typeface="宋体"/>
                 <a:cs typeface="宋体"/>
               </a:rPr>
-              <a:t>8 阶段流水线 · 双层防护 · 双轮独立审查</a:t>
+              <a:t>8 阶段流水线 · PCSC/PCG 双层防护 · L2/L3 独立审查</a:t>
             </a:r>
           </a:p>
         </p:txBody>
@@ -3349,7 +3353,7 @@
                 <a:ea typeface="宋体"/>
                 <a:cs typeface="宋体"/>
               </a:rPr>
-              <a:t>2026-09-03 | github.com/hellrabbit/flow-kit</a:t>
+              <a:t>2026-09-21 | github.com/hellrabbit/flow-kit</a:t>
             </a:r>
           </a:p>
         </p:txBody>
@@ -3452,7 +3456,7 @@
                 <a:ea typeface="宋体"/>
                 <a:cs typeface="宋体"/>
               </a:rPr>
-              <a:t>阶段 5-6：测试 + 双轮审查</a:t>
+              <a:t>阶段 5-6：测试 + 单轮合并审查</a:t>
             </a:r>
           </a:p>
           <a:p>
@@ -3538,7 +3542,28 @@
                 <a:ea typeface="宋体"/>
                 <a:cs typeface="宋体"/>
               </a:rPr>
-              <a:t>阶段 6 · REVIEW：L2 子代理盲审（四要素报告，禁喂自评）+ L3 外部模型独立审</a:t>
+              <a:t>阶段 6 · REVIEW：单轮合并审查——spec 合规 + 6 维代码质量（R1~R6）+ UI 视觉在同一次 pass 内完成，只产报告不改代码</a:t>
+            </a:r>
+          </a:p>
+          <a:p>
+            <a:pPr algn="l">
+              <a:spcBef>
+                <a:spcPts val="200"/>
+              </a:spcBef>
+              <a:spcAft>
+                <a:spcPts val="500"/>
+              </a:spcAft>
+            </a:pPr>
+            <a:r>
+              <a:rPr sz="1500" b="0">
+                <a:solidFill>
+                  <a:srgbClr val="2E86AB"/>
+                </a:solidFill>
+                <a:latin typeface="Times New Roman"/>
+                <a:ea typeface="宋体"/>
+                <a:cs typeface="宋体"/>
+              </a:rPr>
+              <a:t>独立审查（默认关闭，gate_config 开启）：L2 子代理盲审（四要素报告，禁喂自评）+ L3 外部模型 hook 强审</a:t>
             </a:r>
           </a:p>
           <a:p>
@@ -3769,20 +3794,20 @@
                 <a:ea typeface="宋体"/>
                 <a:cs typeface="宋体"/>
               </a:rPr>
-              <a:t>人工 UAT 逐条 AC 打勾 → 失败诊断 → LESSONS 提名</a:t>
-            </a:r>
-          </a:p>
-          <a:p>
-            <a:pPr algn="l">
-              <a:spcBef>
-                <a:spcPts val="200"/>
-              </a:spcBef>
-              <a:spcAft>
-                <a:spcPts val="500"/>
-              </a:spcAft>
-            </a:pPr>
-            <a:r>
-              <a:rPr sz="1500" b="0">
+              <a:t>人工 UAT 逐条 AC 打勾 → 失败诊断 → LESSONS 提名（归档之前必跑）</a:t>
+            </a:r>
+          </a:p>
+          <a:p>
+            <a:pPr algn="l">
+              <a:spcBef>
+                <a:spcPts val="200"/>
+              </a:spcBef>
+              <a:spcAft>
+                <a:spcPts val="500"/>
+              </a:spcAft>
+            </a:pPr>
+            <a:r>
+              <a:rPr sz="1400" b="0">
                 <a:solidFill>
                   <a:srgbClr val="2E86AB"/>
                 </a:solidFill>
@@ -3790,7 +3815,28 @@
                 <a:ea typeface="宋体"/>
                 <a:cs typeface="宋体"/>
               </a:rPr>
-              <a:t>归档（ARCHIVE）+ 34 号 archive-commit-check：归档产物与 CHANGE 范围核对，未提交残留写 correction 告警</a:t>
+              <a:t>产出：UAT.md + .specs/archive/&lt;YYYY-MM-DD&gt;-&lt;change-id&gt;/（含 ARCHIVE-MANIFEST.txt）+ 更新 CHANGELOG.md / STATE.md</a:t>
+            </a:r>
+          </a:p>
+          <a:p>
+            <a:pPr algn="l">
+              <a:spcBef>
+                <a:spcPts val="200"/>
+              </a:spcBef>
+              <a:spcAft>
+                <a:spcPts val="500"/>
+              </a:spcAft>
+            </a:pPr>
+            <a:r>
+              <a:rPr sz="1400" b="0">
+                <a:solidFill>
+                  <a:srgbClr val="2E86AB"/>
+                </a:solidFill>
+                <a:latin typeface="Times New Roman"/>
+                <a:ea typeface="宋体"/>
+                <a:cs typeface="宋体"/>
+              </a:rPr>
+              <a:t>34 号 archive-commit-check：检测归档后是否仍有未提交变更 → 写 archive-uncommitted correction（不读 CHANGE.md）</a:t>
             </a:r>
           </a:p>
           <a:p>
@@ -4964,7 +5010,7 @@
                 <a:ea typeface="宋体"/>
                 <a:cs typeface="宋体"/>
               </a:rPr>
-              <a:t>运行时后处理链 · 12 个开关模块（hooks/config/stop-hook.json）</a:t>
+              <a:t>运行时后处理链 · 12 个开关模块（用户级 stop-hook.json 唯一一份）</a:t>
             </a:r>
           </a:p>
         </p:txBody>
@@ -5533,7 +5579,7 @@
                 <a:ea typeface="宋体"/>
                 <a:cs typeface="宋体"/>
               </a:rPr>
-              <a:t>8. 阶段 6 REVIEW（L2+L3 独立审查）→ 9. 阶段 7 INTEGRATION（门禁 + 归档）</a:t>
+              <a:t>8. 阶段 6 REVIEW（单轮合并审查 + L2/L3 独立审查）→ 9. 阶段 7 INTEGRATION（门禁 + 归档）</a:t>
             </a:r>
           </a:p>
           <a:p>
@@ -5722,7 +5768,7 @@
                 <a:ea typeface="宋体"/>
                 <a:cs typeface="宋体"/>
               </a:rPr>
-              <a:t>.flow-active（运行时状态）· .flow-kit/（会话运行时 · 不入库）· .specs/（STATE/CONTEXT/archive/&lt;change-id&gt;）</a:t>
+              <a:t>.flow-active（运行时状态）· .flow-kit/（会话运行时 · 不入库）· .specs/（STATE/CONTEXT/archive/&lt;YYYY-MM-DD&gt;-&lt;change-id&gt; 归档目录）</a:t>
             </a:r>
           </a:p>
           <a:p>
@@ -5743,7 +5789,7 @@
                 <a:ea typeface="宋体"/>
                 <a:cs typeface="宋体"/>
               </a:rPr>
-              <a:t>change 产物：CHANGE/REQUIREMENT/DESIGN/TASK/TEST/REVIEW/ARCHIVE + T&lt;N&gt;-SUMMARY</a:t>
+              <a:t>change 产物：CHANGE / REQUIREMENT / DESIGN / UI-DESIGN / TASK / TEST / REVIEW + T&lt;N&gt;-SUMMARY；阶段 7 另产 UAT.md 与归档清单</a:t>
             </a:r>
           </a:p>
           <a:p>
@@ -6331,7 +6377,7 @@
                 <a:ea typeface="宋体"/>
                 <a:cs typeface="宋体"/>
               </a:rPr>
-              <a:t>重启 dsh --profile &lt;profile&gt; 生效；更新 = 重打包 + update + 重启</a:t>
+              <a:t>重启 dsh --profile &lt;profile&gt; 生效；更新 = 重打包 + make dsh-sync + 重启（DSH_PROFILE 可覆盖 profile）</a:t>
             </a:r>
           </a:p>
           <a:p>
@@ -6365,7 +6411,7 @@
 </p:sld>
 </file>
 
-<file path=ppt/slides/slide3.xml><?xml version="1.0" encoding="utf-8"?>
+<file path=ppt/slides/slide21.xml><?xml version="1.0" encoding="utf-8"?>
 <p:sld xmlns:a="http://schemas.openxmlformats.org/drawingml/2006/main" xmlns:p="http://schemas.openxmlformats.org/presentationml/2006/main" xmlns:r="http://schemas.openxmlformats.org/officeDocument/2006/relationships">
   <p:cSld>
     <p:spTree>
@@ -6455,7 +6501,7 @@
                 <a:ea typeface="宋体"/>
                 <a:cs typeface="宋体"/>
               </a:rPr>
-              <a:t>核心概念</a:t>
+              <a:t>安装面：作用域与入口</a:t>
             </a:r>
           </a:p>
           <a:p>
@@ -6476,7 +6522,7 @@
                 <a:ea typeface="宋体"/>
                 <a:cs typeface="宋体"/>
               </a:rPr>
-              <a:t>change-id · .flow-active · .specs</a:t>
+              <a:t>install.sh 三个作用域 + dsh 插件（指南 §2.1~2.4）</a:t>
             </a:r>
           </a:p>
         </p:txBody>
@@ -6512,7 +6558,7 @@
               </a:spcAft>
             </a:pPr>
             <a:r>
-              <a:rPr sz="1600" b="0">
+              <a:rPr sz="1500" b="0">
                 <a:solidFill>
                   <a:srgbClr val="1F3A5F"/>
                 </a:solidFill>
@@ -6520,20 +6566,41 @@
                 <a:ea typeface="宋体"/>
                 <a:cs typeface="宋体"/>
               </a:rPr>
-              <a:t>change-id：kebab-case（2~4 词），阶段 0 由 AI 自动生成</a:t>
-            </a:r>
-          </a:p>
-          <a:p>
-            <a:pPr algn="l">
-              <a:spcBef>
-                <a:spcPts val="200"/>
-              </a:spcBef>
-              <a:spcAft>
-                <a:spcPts val="500"/>
-              </a:spcAft>
-            </a:pPr>
-            <a:r>
-              <a:rPr sz="1600" b="0">
+              <a:t>--global：核心引擎 + skills + brooks-lint + brooks-tools；默认不含 hooks（要 hooks 需再加 --user）</a:t>
+            </a:r>
+          </a:p>
+          <a:p>
+            <a:pPr algn="l" lvl="1">
+              <a:spcBef>
+                <a:spcPts val="200"/>
+              </a:spcBef>
+              <a:spcAft>
+                <a:spcPts val="500"/>
+              </a:spcAft>
+            </a:pPr>
+            <a:r>
+              <a:rPr sz="1400" b="0">
+                <a:solidFill>
+                  <a:srgbClr val="2E86AB"/>
+                </a:solidFill>
+                <a:latin typeface="Times New Roman"/>
+                <a:ea typeface="宋体"/>
+                <a:cs typeface="宋体"/>
+              </a:rPr>
+              <a:t>--user：hooks 装到用户目录（~/.claude · ~/.config/opencode · ~/.dsh），所有项目共用</a:t>
+            </a:r>
+          </a:p>
+          <a:p>
+            <a:pPr algn="l">
+              <a:spcBef>
+                <a:spcPts val="200"/>
+              </a:spcBef>
+              <a:spcAft>
+                <a:spcPts val="500"/>
+              </a:spcAft>
+            </a:pPr>
+            <a:r>
+              <a:rPr sz="1500" b="0">
                 <a:solidFill>
                   <a:srgbClr val="1F3A5F"/>
                 </a:solidFill>
@@ -6541,20 +6608,41 @@
                 <a:ea typeface="宋体"/>
                 <a:cs typeface="宋体"/>
               </a:rPr>
-              <a:t>.flow-active：项目根运行时状态（change_id/phase/task/goal/interrupt）</a:t>
-            </a:r>
-          </a:p>
-          <a:p>
-            <a:pPr algn="l">
-              <a:spcBef>
-                <a:spcPts val="200"/>
-              </a:spcBef>
-              <a:spcAft>
-                <a:spcPts val="500"/>
-              </a:spcAft>
-            </a:pPr>
-            <a:r>
-              <a:rPr sz="1600" b="0">
+              <a:t>--project &lt;path&gt;：只装 hooks + settings.json + .specs 模板；配置仍走用户级（2026-09-21 起不再生成也不再读取项目级配置）</a:t>
+            </a:r>
+          </a:p>
+          <a:p>
+            <a:pPr algn="l" lvl="1">
+              <a:spcBef>
+                <a:spcPts val="200"/>
+              </a:spcBef>
+              <a:spcAft>
+                <a:spcPts val="500"/>
+              </a:spcAft>
+            </a:pPr>
+            <a:r>
+              <a:rPr sz="1400" b="0">
+                <a:solidFill>
+                  <a:srgbClr val="2E86AB"/>
+                </a:solidFill>
+                <a:latin typeface="Times New Roman"/>
+                <a:ea typeface="宋体"/>
+                <a:cs typeface="宋体"/>
+              </a:rPr>
+              <a:t>--hooks-only（配合 --project）：仅装 hooks，并铺 .specs/STATE.md 模板</a:t>
+            </a:r>
+          </a:p>
+          <a:p>
+            <a:pPr algn="l">
+              <a:spcBef>
+                <a:spcPts val="200"/>
+              </a:spcBef>
+              <a:spcAft>
+                <a:spcPts val="500"/>
+              </a:spcAft>
+            </a:pPr>
+            <a:r>
+              <a:rPr sz="1500" b="0">
                 <a:solidFill>
                   <a:srgbClr val="1F3A5F"/>
                 </a:solidFill>
@@ -6562,20 +6650,62 @@
                 <a:ea typeface="宋体"/>
                 <a:cs typeface="宋体"/>
               </a:rPr>
-              <a:t>.specs/&lt;change-id&gt;/：单个 change 的全部产物目录</a:t>
-            </a:r>
-          </a:p>
-          <a:p>
-            <a:pPr algn="l">
-              <a:spcBef>
-                <a:spcPts val="200"/>
-              </a:spcBef>
-              <a:spcAft>
-                <a:spcPts val="500"/>
-              </a:spcAft>
-            </a:pPr>
-            <a:r>
-              <a:rPr sz="1500" b="0">
+              <a:t>--platform claude|opencode|dsh|auto：目标平台（默认 claude）；dsh 不落盘，只打印插件安装指引</a:t>
+            </a:r>
+          </a:p>
+          <a:p>
+            <a:pPr algn="l">
+              <a:spcBef>
+                <a:spcPts val="200"/>
+              </a:spcBef>
+              <a:spcAft>
+                <a:spcPts val="500"/>
+              </a:spcAft>
+            </a:pPr>
+            <a:r>
+              <a:rPr sz="1400" b="0">
+                <a:solidFill>
+                  <a:srgbClr val="2E86AB"/>
+                </a:solidFill>
+                <a:latin typeface="Times New Roman"/>
+                <a:ea typeface="宋体"/>
+                <a:cs typeface="宋体"/>
+              </a:rPr>
+              <a:t>dsh 插件：bash package-dsh-plugin.sh → dsh plugin --profile &lt;profile&gt; add file:&lt;仓库&gt;/dist/dsh-flow-kit → 重启 profile</a:t>
+            </a:r>
+          </a:p>
+          <a:p>
+            <a:pPr algn="l" lvl="1">
+              <a:spcBef>
+                <a:spcPts val="200"/>
+              </a:spcBef>
+              <a:spcAft>
+                <a:spcPts val="500"/>
+              </a:spcAft>
+            </a:pPr>
+            <a:r>
+              <a:rPr sz="1300" b="0">
+                <a:solidFill>
+                  <a:srgbClr val="2E86AB"/>
+                </a:solidFill>
+                <a:latin typeface="Times New Roman"/>
+                <a:ea typeface="宋体"/>
+                <a:cs typeface="宋体"/>
+              </a:rPr>
+              <a:t>刷新：make dsh-sync 把 dist 全量同步进已装插件（DSH_PROFILE=&lt;profile&gt; make dsh-sync 可覆盖，默认 web；未装则跳过 exit 0）</a:t>
+            </a:r>
+          </a:p>
+          <a:p>
+            <a:pPr algn="l">
+              <a:spcBef>
+                <a:spcPts val="200"/>
+              </a:spcBef>
+              <a:spcAft>
+                <a:spcPts val="500"/>
+              </a:spcAft>
+            </a:pPr>
+            <a:r>
+              <a:rPr sz="1400" b="0">
                 <a:solidFill>
                   <a:srgbClr val="6C757D"/>
                 </a:solidFill>
@@ -6583,7 +6713,7 @@
                 <a:ea typeface="宋体"/>
                 <a:cs typeface="宋体"/>
               </a:rPr>
-              <a:t>横向命令：I-intel / M-health / A-architect / A-evolve / L-restyle 独立于流水线</a:t>
+              <a:t>插件当前 v0.2.0（以 dist/dsh-flow-kit/package.json 为准）；/flow doctor 自检挂载结果</a:t>
             </a:r>
           </a:p>
         </p:txBody>
@@ -6596,7 +6726,7 @@
 </p:sld>
 </file>
 
-<file path=ppt/slides/slide4.xml><?xml version="1.0" encoding="utf-8"?>
+<file path=ppt/slides/slide22.xml><?xml version="1.0" encoding="utf-8"?>
 <p:sld xmlns:a="http://schemas.openxmlformats.org/drawingml/2006/main" xmlns:p="http://schemas.openxmlformats.org/presentationml/2006/main" xmlns:r="http://schemas.openxmlformats.org/officeDocument/2006/relationships">
   <p:cSld>
     <p:spTree>
@@ -6686,7 +6816,7 @@
                 <a:ea typeface="宋体"/>
                 <a:cs typeface="宋体"/>
               </a:rPr>
-              <a:t>整体架构</a:t>
+              <a:t>L3 审查链：凭证 · 熔断 · 工件上限</a:t>
             </a:r>
           </a:p>
           <a:p>
@@ -6707,7 +6837,7 @@
                 <a:ea typeface="宋体"/>
                 <a:cs typeface="宋体"/>
               </a:rPr>
-              <a:t>核心引擎是大脑，Hook 是运行时，技能是入口</a:t>
+              <a:t>gate_config 含 L3 的阶段必须配齐凭证，否则门禁死锁</a:t>
             </a:r>
           </a:p>
         </p:txBody>
@@ -6745,26 +6875,131 @@
             <a:r>
               <a:rPr sz="1500" b="0">
                 <a:solidFill>
+                  <a:srgbClr val="C7463B"/>
+                </a:solidFill>
+                <a:latin typeface="Times New Roman"/>
+                <a:ea typeface="宋体"/>
+                <a:cs typeface="宋体"/>
+              </a:rPr>
+              <a:t>三 Path 凭证链（fk_resolve_api_credentials，命中即停）——凭证缺失 = L3 门禁死锁</a:t>
+            </a:r>
+          </a:p>
+          <a:p>
+            <a:pPr algn="l" lvl="1">
+              <a:spcBef>
+                <a:spcPts val="200"/>
+              </a:spcBef>
+              <a:spcAft>
+                <a:spcPts val="500"/>
+              </a:spcAft>
+            </a:pPr>
+            <a:r>
+              <a:rPr sz="1300" b="0">
+                <a:solidFill>
+                  <a:srgbClr val="2E86AB"/>
+                </a:solidFill>
+                <a:latin typeface="Times New Roman"/>
+                <a:ea typeface="宋体"/>
+                <a:cs typeface="宋体"/>
+              </a:rPr>
+              <a:t>claude：ANTHROPIC_AUTH_TOKEN（+ ANTHROPIC_BASE_URL）&gt; FLOW_KIT_L3_AUTH_TOKEN + FLOW_KIT_L3_BASE_URL &gt; ANTHROPIC_API_KEY</a:t>
+            </a:r>
+          </a:p>
+          <a:p>
+            <a:pPr algn="l" lvl="1">
+              <a:spcBef>
+                <a:spcPts val="200"/>
+              </a:spcBef>
+              <a:spcAft>
+                <a:spcPts val="500"/>
+              </a:spcAft>
+            </a:pPr>
+            <a:r>
+              <a:rPr sz="1300" b="0">
+                <a:solidFill>
+                  <a:srgbClr val="2E86AB"/>
+                </a:solidFill>
+                <a:latin typeface="Times New Roman"/>
+                <a:ea typeface="宋体"/>
+                <a:cs typeface="宋体"/>
+              </a:rPr>
+              <a:t>dsh / opencode：FLOW_KIT_L3_AUTH_TOKEN + FLOW_KIT_L3_BASE_URL 最优先（Path3 → 1 → 2）</a:t>
+            </a:r>
+          </a:p>
+          <a:p>
+            <a:pPr algn="l">
+              <a:spcBef>
+                <a:spcPts val="200"/>
+              </a:spcBef>
+              <a:spcAft>
+                <a:spcPts val="500"/>
+              </a:spcAft>
+            </a:pPr>
+            <a:r>
+              <a:rPr sz="1400" b="0">
+                <a:solidFill>
                   <a:srgbClr val="1F3A5F"/>
                 </a:solidFill>
                 <a:latin typeface="Times New Roman"/>
                 <a:ea typeface="宋体"/>
                 <a:cs typeface="宋体"/>
               </a:rPr>
-              <a:t>意图 → /flow-go 路由 → 阶段 prompt → 产物（.md）</a:t>
-            </a:r>
-          </a:p>
-          <a:p>
-            <a:pPr algn="l">
-              <a:spcBef>
-                <a:spcPts val="200"/>
-              </a:spcBef>
-              <a:spcAft>
-                <a:spcPts val="500"/>
-              </a:spcAft>
-            </a:pPr>
-            <a:r>
-              <a:rPr sz="1500" b="0">
+              <a:t>rc 语义：0 就绪 / 1 无任何凭证 / 2 Path3 不完整（设了 token 但缺 base url → 报错，拒绝静默回落 Path2）</a:t>
+            </a:r>
+          </a:p>
+          <a:p>
+            <a:pPr algn="l">
+              <a:spcBef>
+                <a:spcPts val="200"/>
+              </a:spcBef>
+              <a:spcAft>
+                <a:spcPts val="500"/>
+              </a:spcAft>
+            </a:pPr>
+            <a:r>
+              <a:rPr sz="1400" b="0">
+                <a:solidFill>
+                  <a:srgbClr val="C7463B"/>
+                </a:solidFill>
+                <a:latin typeface="Times New Roman"/>
+                <a:ea typeface="宋体"/>
+                <a:cs typeface="宋体"/>
+              </a:rPr>
+              <a:t>死锁链：凭证缺失 → hook 不写 .done → PreToolUse 禁止主 agent 代写 → commit / 阶段推进全部阻塞（工件上看不出原因）</a:t>
+            </a:r>
+          </a:p>
+          <a:p>
+            <a:pPr algn="l" lvl="1">
+              <a:spcBef>
+                <a:spcPts val="200"/>
+              </a:spcBef>
+              <a:spcAft>
+                <a:spcPts val="500"/>
+              </a:spcAft>
+            </a:pPr>
+            <a:r>
+              <a:rPr sz="1300" b="0">
+                <a:solidFill>
+                  <a:srgbClr val="2E86AB"/>
+                </a:solidFill>
+                <a:latin typeface="Times New Roman"/>
+                <a:ea typeface="宋体"/>
+                <a:cs typeface="宋体"/>
+              </a:rPr>
+              <a:t>加载：cp .claude/l3.env.example ~/.config/flow-kit/l3.env 后 chmod 600；systemd drop-in EnvironmentFile= 或 shell set -a; . ~/.config/flow-kit/l3.env; set +a（claude / OpenCode 在 ~/.bashrc source）</a:t>
+            </a:r>
+          </a:p>
+          <a:p>
+            <a:pPr algn="l">
+              <a:spcBef>
+                <a:spcPts val="200"/>
+              </a:spcBef>
+              <a:spcAft>
+                <a:spcPts val="500"/>
+              </a:spcAft>
+            </a:pPr>
+            <a:r>
+              <a:rPr sz="1300" b="0">
                 <a:solidFill>
                   <a:srgbClr val="1F3A5F"/>
                 </a:solidFill>
@@ -6772,62 +7007,20 @@
                 <a:ea typeface="宋体"/>
                 <a:cs typeface="宋体"/>
               </a:rPr>
-              <a:t>17 个 flow-* 技能将核心引擎暴露为斜杠命令（三平台同源；dsh 插件自动挂载）</a:t>
-            </a:r>
-          </a:p>
-          <a:p>
-            <a:pPr algn="l">
-              <a:spcBef>
-                <a:spcPts val="200"/>
-              </a:spcBef>
-              <a:spcAft>
-                <a:spcPts val="500"/>
-              </a:spcAft>
-            </a:pPr>
-            <a:r>
-              <a:rPr sz="1500" b="0">
-                <a:solidFill>
-                  <a:srgbClr val="2E86AB"/>
-                </a:solidFill>
-                <a:latin typeface="Times New Roman"/>
-                <a:ea typeface="宋体"/>
-                <a:cs typeface="宋体"/>
-              </a:rPr>
-              <a:t>Hook 运行时链：00-gate / 01-transcript + 20~34 逻辑模块 + 99-report</a:t>
-            </a:r>
-          </a:p>
-          <a:p>
-            <a:pPr algn="l">
-              <a:spcBef>
-                <a:spcPts val="200"/>
-              </a:spcBef>
-              <a:spcAft>
-                <a:spcPts val="500"/>
-              </a:spcAft>
-            </a:pPr>
-            <a:r>
-              <a:rPr sz="1500" b="0">
-                <a:solidFill>
-                  <a:srgbClr val="2E86AB"/>
-                </a:solidFill>
-                <a:latin typeface="Times New Roman"/>
-                <a:ea typeface="宋体"/>
-                <a:cs typeface="宋体"/>
-              </a:rPr>
-              <a:t>门禁：PreToolUse（independent-review gate + auto-checkpoint）· SessionStart（恢复/矫正/报告）· pre-commit（提交前全量门禁）</a:t>
-            </a:r>
-          </a:p>
-          <a:p>
-            <a:pPr algn="l">
-              <a:spcBef>
-                <a:spcPts val="200"/>
-              </a:spcBef>
-              <a:spcAft>
-                <a:spcPts val="500"/>
-              </a:spcAft>
-            </a:pPr>
-            <a:r>
-              <a:rPr sz="1500" b="0">
+              <a:t>熔断：连续 fail 达 max_failures_before_bypass（默认 3，0 = 关闭）→ 子系统自动写 .done + L3_verdict=skipped 并追加 bypass 审计段（不伪装 pass）；删 .specs/&lt;id&gt;/.l3-attempts-&lt;phase&gt; 即可重试</a:t>
+            </a:r>
+          </a:p>
+          <a:p>
+            <a:pPr algn="l">
+              <a:spcBef>
+                <a:spcPts val="200"/>
+              </a:spcBef>
+              <a:spcAft>
+                <a:spcPts val="500"/>
+              </a:spcAft>
+            </a:pPr>
+            <a:r>
+              <a:rPr sz="1300" b="0">
                 <a:solidFill>
                   <a:srgbClr val="1F3A5F"/>
                 </a:solidFill>
@@ -6835,7 +7028,28 @@
                 <a:ea typeface="宋体"/>
                 <a:cs typeface="宋体"/>
               </a:rPr>
-              <a:t>独立审查：L2 子代理盲审 + L3 外部模型（gate_config 按阶段开启）</a:t>
+              <a:t>工件上限：max_artifact_bytes 默认 80000 字节（CJK ÷3 ≈ 2.7 万汉字）；旧名 max_artifact_chars 已废弃（打 DEPRECATED）；解析链 FLOW_KIT_L3_MAX_ARTIFACT_BYTES &gt; 80000</a:t>
+            </a:r>
+          </a:p>
+          <a:p>
+            <a:pPr algn="l">
+              <a:spcBef>
+                <a:spcPts val="200"/>
+              </a:spcBef>
+              <a:spcAft>
+                <a:spcPts val="500"/>
+              </a:spcAft>
+            </a:pPr>
+            <a:r>
+              <a:rPr sz="1300" b="0">
+                <a:solidFill>
+                  <a:srgbClr val="6C757D"/>
+                </a:solidFill>
+                <a:latin typeface="Times New Roman"/>
+                <a:ea typeface="宋体"/>
+                <a:cs typeface="宋体"/>
+              </a:rPr>
+              <a:t>安全红线：凭证绝不落盘到仓库 / .flow-active / correction / 日志 / 报告，只存在于 hook 子进程 env</a:t>
             </a:r>
           </a:p>
         </p:txBody>
@@ -6848,7 +7062,7 @@
 </p:sld>
 </file>
 
-<file path=ppt/slides/slide5.xml><?xml version="1.0" encoding="utf-8"?>
+<file path=ppt/slides/slide23.xml><?xml version="1.0" encoding="utf-8"?>
 <p:sld xmlns:a="http://schemas.openxmlformats.org/drawingml/2006/main" xmlns:p="http://schemas.openxmlformats.org/presentationml/2006/main" xmlns:r="http://schemas.openxmlformats.org/officeDocument/2006/relationships">
   <p:cSld>
     <p:spTree>
@@ -6938,7 +7152,7 @@
                 <a:ea typeface="宋体"/>
                 <a:cs typeface="宋体"/>
               </a:rPr>
-              <a:t>两大命令：/flow-go vs /flow</a:t>
+              <a:t>质量门禁：make check 六门</a:t>
             </a:r>
           </a:p>
           <a:p>
@@ -6959,7 +7173,7 @@
                 <a:ea typeface="宋体"/>
                 <a:cs typeface="宋体"/>
               </a:rPr>
-              <a:t>统一入口（自动路由） vs 状态管理（手动操作）</a:t>
+              <a:t>一条命令跑全部机械门禁；任一红即整体红</a:t>
             </a:r>
           </a:p>
         </p:txBody>
@@ -7003,28 +7217,7 @@
                 <a:ea typeface="宋体"/>
                 <a:cs typeface="宋体"/>
               </a:rPr>
-              <a:t>/flow-go — 描述意图自动路由：新需求→阶段 0；继续→阶段 4；需求/设计/测试/归档等关键词直达</a:t>
-            </a:r>
-          </a:p>
-          <a:p>
-            <a:pPr algn="l">
-              <a:spcBef>
-                <a:spcPts val="200"/>
-              </a:spcBef>
-              <a:spcAft>
-                <a:spcPts val="500"/>
-              </a:spcAft>
-            </a:pPr>
-            <a:r>
-              <a:rPr sz="1500" b="0">
-                <a:solidFill>
-                  <a:srgbClr val="1F3A5F"/>
-                </a:solidFill>
-                <a:latin typeface="Times New Roman"/>
-                <a:ea typeface="宋体"/>
-                <a:cs typeface="宋体"/>
-              </a:rPr>
-              <a:t>/flow — 状态管理子命令</a:t>
+              <a:t>make check = test → lint → check-validate → check-test-sync → check-hooks-sync → check-dist（六门串行）</a:t>
             </a:r>
           </a:p>
           <a:p>
@@ -7037,7 +7230,7 @@
               </a:spcAft>
             </a:pPr>
             <a:r>
-              <a:rPr sz="1600" b="0">
+              <a:rPr sz="1300" b="0">
                 <a:solidFill>
                   <a:srgbClr val="2E86AB"/>
                 </a:solidFill>
@@ -7045,7 +7238,7 @@
                 <a:ea typeface="宋体"/>
                 <a:cs typeface="宋体"/>
               </a:rPr>
-              <a:t>start / stop / phase &lt;n&gt; / task &lt;Tn&gt; / goal / goal clear</a:t>
+              <a:t>1 make test — 全量 bats（npx bats test/，含副本一致性守护用例）</a:t>
             </a:r>
           </a:p>
           <a:p>
@@ -7058,7 +7251,7 @@
               </a:spcAft>
             </a:pPr>
             <a:r>
-              <a:rPr sz="1600" b="0">
+              <a:rPr sz="1300" b="0">
                 <a:solidFill>
                   <a:srgbClr val="2E86AB"/>
                 </a:solidFill>
@@ -7066,7 +7259,7 @@
                 <a:ea typeface="宋体"/>
                 <a:cs typeface="宋体"/>
               </a:rPr>
-              <a:t>checkpoint &lt;file&gt; &lt;desc&gt; — 中断恢复点</a:t>
+              <a:t>2 make lint — shellcheck error 级；结束打印 SCANNED_FILES: &lt;n&gt; 列出扫描域，防「只扫了 2/9 份载体」</a:t>
             </a:r>
           </a:p>
           <a:p>
@@ -7079,7 +7272,7 @@
               </a:spcAft>
             </a:pPr>
             <a:r>
-              <a:rPr sz="1600" b="0">
+              <a:rPr sz="1300" b="0">
                 <a:solidFill>
                   <a:srgbClr val="2E86AB"/>
                 </a:solidFill>
@@ -7087,7 +7280,7 @@
                 <a:ea typeface="宋体"/>
                 <a:cs typeface="宋体"/>
               </a:rPr>
-              <a:t>doctor — .flow-active 完整性 + correction 卫生报告（type/violations 去重，check→rule 回退）</a:t>
+              <a:t>3 make check-validate — 打包完整性：package-flow-kit.sh --validate 核对 staging 覆盖</a:t>
             </a:r>
           </a:p>
           <a:p>
@@ -7100,7 +7293,7 @@
               </a:spcAft>
             </a:pPr>
             <a:r>
-              <a:rPr sz="1600" b="0">
+              <a:rPr sz="1300" b="0">
                 <a:solidFill>
                   <a:srgbClr val="2E86AB"/>
                 </a:solidFill>
@@ -7108,7 +7301,7 @@
                 <a:ea typeface="宋体"/>
                 <a:cs typeface="宋体"/>
               </a:rPr>
-              <a:t>model — 五级链配置：l2=/l3= 显式字段，l2-default=/l3-default= 站点默认，--clear 清除</a:t>
+              <a:t>4 make check-test-sync — test/ 与 flow-kit-bundle/test/ 逐文件一致（新增用例后须 make test-sync）</a:t>
             </a:r>
           </a:p>
           <a:p>
@@ -7121,7 +7314,7 @@
               </a:spcAft>
             </a:pPr>
             <a:r>
-              <a:rPr sz="1600" b="0">
+              <a:rPr sz="1300" b="0">
                 <a:solidFill>
                   <a:srgbClr val="2E86AB"/>
                 </a:solidFill>
@@ -7129,7 +7322,49 @@
                 <a:ea typeface="宋体"/>
                 <a:cs typeface="宋体"/>
               </a:rPr>
-              <a:t>gate-config — 按阶段开关独立审查（both/L2/L3/off）</a:t>
+              <a:t>5 make check-hooks-sync — hooks 唯一维护源 → 6 个副本根无漂移（改完源须 make hooks-sync）</a:t>
+            </a:r>
+          </a:p>
+          <a:p>
+            <a:pPr algn="l" lvl="1">
+              <a:spcBef>
+                <a:spcPts val="200"/>
+              </a:spcBef>
+              <a:spcAft>
+                <a:spcPts val="500"/>
+              </a:spcAft>
+            </a:pPr>
+            <a:r>
+              <a:rPr sz="1300" b="0">
+                <a:solidFill>
+                  <a:srgbClr val="2E86AB"/>
+                </a:solidFill>
+                <a:latin typeface="Times New Roman"/>
+                <a:ea typeface="宋体"/>
+                <a:cs typeface="宋体"/>
+              </a:rPr>
+              <a:t>6 make check-dist — dist 打包件新鲜度：package-dsh-plugin.sh --check 只读逐文件 cmp，NFR ≤2s（实测 0.61s）</a:t>
+            </a:r>
+          </a:p>
+          <a:p>
+            <a:pPr algn="l">
+              <a:spcBef>
+                <a:spcPts val="200"/>
+              </a:spcBef>
+              <a:spcAft>
+                <a:spcPts val="500"/>
+              </a:spcAft>
+            </a:pPr>
+            <a:r>
+              <a:rPr sz="1400" b="0">
+                <a:solidFill>
+                  <a:srgbClr val="C7463B"/>
+                </a:solidFill>
+                <a:latin typeface="Times New Roman"/>
+                <a:ea typeface="宋体"/>
+                <a:cs typeface="宋体"/>
+              </a:rPr>
+              <a:t>单点命令：make hooks-sync（同步 hooks 到各副本）/ make dsh-sync（dist → 已装 profile）/ make verify-claims（三态机械复验：✅ 命中 / ❌ 不成立 / SKIP）</a:t>
             </a:r>
           </a:p>
         </p:txBody>
@@ -7142,7 +7377,7 @@
 </p:sld>
 </file>
 
-<file path=ppt/slides/slide6.xml><?xml version="1.0" encoding="utf-8"?>
+<file path=ppt/slides/slide24.xml><?xml version="1.0" encoding="utf-8"?>
 <p:sld xmlns:a="http://schemas.openxmlformats.org/drawingml/2006/main" xmlns:p="http://schemas.openxmlformats.org/presentationml/2006/main" xmlns:r="http://schemas.openxmlformats.org/officeDocument/2006/relationships">
   <p:cSld>
     <p:spTree>
@@ -7232,7 +7467,7 @@
                 <a:ea typeface="宋体"/>
                 <a:cs typeface="宋体"/>
               </a:rPr>
-              <a:t>8 阶段流水线总览</a:t>
+              <a:t>版本与副本口径</a:t>
             </a:r>
           </a:p>
           <a:p>
@@ -7253,7 +7488,7 @@
                 <a:ea typeface="宋体"/>
                 <a:cs typeface="宋体"/>
               </a:rPr>
-              <a:t>每个阶段产出明确产物，经 Toll-Gate 进入下一阶段</a:t>
+              <a:t>四份指南副本 + deck 新鲜度的机械守护</a:t>
             </a:r>
           </a:p>
         </p:txBody>
@@ -7289,14 +7524,1085 @@
               </a:spcAft>
             </a:pPr>
             <a:r>
+              <a:rPr sz="1400" b="0">
+                <a:solidFill>
+                  <a:srgbClr val="1F3A5F"/>
+                </a:solidFill>
+                <a:latin typeface="Times New Roman"/>
+                <a:ea typeface="宋体"/>
+                <a:cs typeface="宋体"/>
+              </a:rPr>
+              <a:t>指南 4 份副本（内容必须一致，md5 唯一值 = 1）：仓库根 FLOW-KIT-用户指南.md / flow-kit-bundle/FLOW-KIT-用户指南.md / dist/dsh-flow-kit/docs/ / dist/dsh-flow-kit/vendor/flow-kit-bundle/</a:t>
+            </a:r>
+          </a:p>
+          <a:p>
+            <a:pPr algn="l">
+              <a:spcBef>
+                <a:spcPts val="200"/>
+              </a:spcBef>
+              <a:spcAft>
+                <a:spcPts val="500"/>
+              </a:spcAft>
+            </a:pPr>
+            <a:r>
+              <a:rPr sz="1400" b="0">
+                <a:solidFill>
+                  <a:srgbClr val="2E86AB"/>
+                </a:solidFill>
+                <a:latin typeface="Times New Roman"/>
+                <a:ea typeface="宋体"/>
+                <a:cs typeface="宋体"/>
+              </a:rPr>
+              <a:t>同步顺序：改 bundle 底稿 → 覆写仓库根副本 → 窄路径 cp 到 dist 两份 → package-dsh-plugin.sh --check 复绿</a:t>
+            </a:r>
+          </a:p>
+          <a:p>
+            <a:pPr algn="l">
+              <a:spcBef>
+                <a:spcPts val="200"/>
+              </a:spcBef>
+              <a:spcAft>
+                <a:spcPts val="500"/>
+              </a:spcAft>
+            </a:pPr>
+            <a:r>
+              <a:rPr sz="1400" b="0">
+                <a:solidFill>
+                  <a:srgbClr val="1F3A5F"/>
+                </a:solidFill>
+                <a:latin typeface="Times New Roman"/>
+                <a:ea typeface="宋体"/>
+                <a:cs typeface="宋体"/>
+              </a:rPr>
+              <a:t>版本日期口径三处统一 = 2026-09-21：指南版本行 / 分节「最后同步日期」/ deck 封面日期行</a:t>
+            </a:r>
+          </a:p>
+          <a:p>
+            <a:pPr algn="l">
+              <a:spcBef>
+                <a:spcPts val="200"/>
+              </a:spcBef>
+              <a:spcAft>
+                <a:spcPts val="500"/>
+              </a:spcAft>
+            </a:pPr>
+            <a:r>
+              <a:rPr sz="1400" b="0">
+                <a:solidFill>
+                  <a:srgbClr val="2E86AB"/>
+                </a:solidFill>
+                <a:latin typeface="Times New Roman"/>
+                <a:ea typeface="宋体"/>
+                <a:cs typeface="宋体"/>
+              </a:rPr>
+              <a:t>守护 1 · test/test_guide_copy_parity.bats：四份 md5 一致性 + deck 新鲜度（pptx 页数 == len(slides.json)、封面日期 == 指南版本行）</a:t>
+            </a:r>
+          </a:p>
+          <a:p>
+            <a:pPr algn="l">
+              <a:spcBef>
+                <a:spcPts val="200"/>
+              </a:spcBef>
+              <a:spcAft>
+                <a:spcPts val="500"/>
+              </a:spcAft>
+            </a:pPr>
+            <a:r>
+              <a:rPr sz="1400" b="0">
+                <a:solidFill>
+                  <a:srgbClr val="2E86AB"/>
+                </a:solidFill>
+                <a:latin typeface="Times New Roman"/>
+                <a:ea typeface="宋体"/>
+                <a:cs typeface="宋体"/>
+              </a:rPr>
+              <a:t>守护 2 · deck_checks.py：页数 / 封面日期 / 禁词 0 / 逐页非空 / 按标题的关键串断言</a:t>
+            </a:r>
+          </a:p>
+          <a:p>
+            <a:pPr algn="l">
+              <a:spcBef>
+                <a:spcPts val="200"/>
+              </a:spcBef>
+              <a:spcAft>
+                <a:spcPts val="500"/>
+              </a:spcAft>
+            </a:pPr>
+            <a:r>
+              <a:rPr sz="1400" b="0">
+                <a:solidFill>
+                  <a:srgbClr val="C7463B"/>
+                </a:solidFill>
+                <a:latin typeface="Times New Roman"/>
+                <a:ea typeface="宋体"/>
+                <a:cs typeface="宋体"/>
+              </a:rPr>
+              <a:t>四份不一致 → make check 第一门（make test）即红；root ↔ bundle 是历史高发漂移边，本轮补上守护</a:t>
+            </a:r>
+          </a:p>
+          <a:p>
+            <a:pPr algn="l">
+              <a:spcBef>
+                <a:spcPts val="200"/>
+              </a:spcBef>
+              <a:spcAft>
+                <a:spcPts val="500"/>
+              </a:spcAft>
+            </a:pPr>
+            <a:r>
+              <a:rPr sz="1300" b="0">
+                <a:solidFill>
+                  <a:srgbClr val="6C757D"/>
+                </a:solidFill>
+                <a:latin typeface="Times New Roman"/>
+                <a:ea typeface="宋体"/>
+                <a:cs typeface="宋体"/>
+              </a:rPr>
+              <a:t>纯文档 change 的验证方式：md5 唯一值 + pptx 页数/日期 + 禁词 grep，全部可机械复验，不依赖人工阅读</a:t>
+            </a:r>
+          </a:p>
+        </p:txBody>
+      </p:sp>
+    </p:spTree>
+  </p:cSld>
+  <p:clrMapOvr>
+    <a:masterClrMapping/>
+  </p:clrMapOvr>
+</p:sld>
+</file>
+
+<file path=ppt/slides/slide3.xml><?xml version="1.0" encoding="utf-8"?>
+<p:sld xmlns:a="http://schemas.openxmlformats.org/drawingml/2006/main" xmlns:p="http://schemas.openxmlformats.org/presentationml/2006/main" xmlns:r="http://schemas.openxmlformats.org/officeDocument/2006/relationships">
+  <p:cSld>
+    <p:spTree>
+      <p:nvGrpSpPr>
+        <p:cNvPr id="1" name=""/>
+        <p:cNvGrpSpPr/>
+        <p:nvPr/>
+      </p:nvGrpSpPr>
+      <p:grpSpPr/>
+      <p:sp>
+        <p:nvSpPr>
+          <p:cNvPr id="2" name="Rectangle 1"/>
+          <p:cNvSpPr/>
+          <p:nvPr/>
+        </p:nvSpPr>
+        <p:spPr>
+          <a:xfrm>
+            <a:off x="0" y="0"/>
+            <a:ext cx="12191695" cy="1051560"/>
+          </a:xfrm>
+          <a:prstGeom prst="rect">
+            <a:avLst/>
+          </a:prstGeom>
+          <a:solidFill>
+            <a:srgbClr val="1F3A5F"/>
+          </a:solidFill>
+          <a:ln>
+            <a:noFill/>
+          </a:ln>
+          <a:effectLst/>
+        </p:spPr>
+        <p:style>
+          <a:lnRef idx="1">
+            <a:schemeClr val="accent1"/>
+          </a:lnRef>
+          <a:fillRef idx="3">
+            <a:schemeClr val="accent1"/>
+          </a:fillRef>
+          <a:effectRef idx="2">
+            <a:schemeClr val="accent1"/>
+          </a:effectRef>
+          <a:fontRef idx="minor">
+            <a:schemeClr val="lt1"/>
+          </a:fontRef>
+        </p:style>
+        <p:txBody>
+          <a:bodyPr rtlCol="0" anchor="ctr"/>
+          <a:lstStyle/>
+          <a:p>
+            <a:pPr algn="ctr"/>
+          </a:p>
+        </p:txBody>
+      </p:sp>
+      <p:sp>
+        <p:nvSpPr>
+          <p:cNvPr id="3" name="TextBox 2"/>
+          <p:cNvSpPr txBox="1"/>
+          <p:nvPr/>
+        </p:nvSpPr>
+        <p:spPr>
+          <a:xfrm>
+            <a:off x="548640" y="73152"/>
+            <a:ext cx="11094415" cy="914400"/>
+          </a:xfrm>
+          <a:prstGeom prst="rect">
+            <a:avLst/>
+          </a:prstGeom>
+          <a:noFill/>
+        </p:spPr>
+        <p:txBody>
+          <a:bodyPr wrap="square" anchor="ctr">
+            <a:spAutoFit/>
+          </a:bodyPr>
+          <a:lstStyle/>
+          <a:p>
+            <a:pPr algn="l">
+              <a:spcAft>
+                <a:spcPts val="0"/>
+              </a:spcAft>
+            </a:pPr>
+            <a:r>
+              <a:rPr sz="3000" b="1">
+                <a:solidFill>
+                  <a:srgbClr val="FFFFFF"/>
+                </a:solidFill>
+                <a:latin typeface="Times New Roman"/>
+                <a:ea typeface="宋体"/>
+                <a:cs typeface="宋体"/>
+              </a:rPr>
+              <a:t>核心概念</a:t>
+            </a:r>
+          </a:p>
+          <a:p>
+            <a:pPr algn="l">
+              <a:spcBef>
+                <a:spcPts val="100"/>
+              </a:spcBef>
+              <a:spcAft>
+                <a:spcPts val="0"/>
+              </a:spcAft>
+            </a:pPr>
+            <a:r>
+              <a:rPr sz="1300" b="0">
+                <a:solidFill>
+                  <a:srgbClr val="A8C4E0"/>
+                </a:solidFill>
+                <a:latin typeface="Times New Roman"/>
+                <a:ea typeface="宋体"/>
+                <a:cs typeface="宋体"/>
+              </a:rPr>
+              <a:t>change-id · .flow-active · .specs</a:t>
+            </a:r>
+          </a:p>
+        </p:txBody>
+      </p:sp>
+      <p:sp>
+        <p:nvSpPr>
+          <p:cNvPr id="4" name="TextBox 3"/>
+          <p:cNvSpPr txBox="1"/>
+          <p:nvPr/>
+        </p:nvSpPr>
+        <p:spPr>
+          <a:xfrm>
+            <a:off x="685800" y="1371600"/>
+            <a:ext cx="10820095" cy="5120640"/>
+          </a:xfrm>
+          <a:prstGeom prst="rect">
+            <a:avLst/>
+          </a:prstGeom>
+          <a:noFill/>
+        </p:spPr>
+        <p:txBody>
+          <a:bodyPr wrap="square" anchor="t">
+            <a:spAutoFit/>
+          </a:bodyPr>
+          <a:lstStyle/>
+          <a:p>
+            <a:pPr algn="l">
+              <a:spcBef>
+                <a:spcPts val="200"/>
+              </a:spcBef>
+              <a:spcAft>
+                <a:spcPts val="500"/>
+              </a:spcAft>
+            </a:pPr>
+            <a:r>
+              <a:rPr sz="1600" b="0">
+                <a:solidFill>
+                  <a:srgbClr val="1F3A5F"/>
+                </a:solidFill>
+                <a:latin typeface="Times New Roman"/>
+                <a:ea typeface="宋体"/>
+                <a:cs typeface="宋体"/>
+              </a:rPr>
+              <a:t>change-id：kebab-case（2~4 词），阶段 0 由 AI 自动生成</a:t>
+            </a:r>
+          </a:p>
+          <a:p>
+            <a:pPr algn="l">
+              <a:spcBef>
+                <a:spcPts val="200"/>
+              </a:spcBef>
+              <a:spcAft>
+                <a:spcPts val="500"/>
+              </a:spcAft>
+            </a:pPr>
+            <a:r>
+              <a:rPr sz="1600" b="0">
+                <a:solidFill>
+                  <a:srgbClr val="1F3A5F"/>
+                </a:solidFill>
+                <a:latin typeface="Times New Roman"/>
+                <a:ea typeface="宋体"/>
+                <a:cs typeface="宋体"/>
+              </a:rPr>
+              <a:t>.flow-active：项目根运行时状态（change_id/phase/task/goal/interrupt）</a:t>
+            </a:r>
+          </a:p>
+          <a:p>
+            <a:pPr algn="l">
+              <a:spcBef>
+                <a:spcPts val="200"/>
+              </a:spcBef>
+              <a:spcAft>
+                <a:spcPts val="500"/>
+              </a:spcAft>
+            </a:pPr>
+            <a:r>
+              <a:rPr sz="1600" b="0">
+                <a:solidFill>
+                  <a:srgbClr val="1F3A5F"/>
+                </a:solidFill>
+                <a:latin typeface="Times New Roman"/>
+                <a:ea typeface="宋体"/>
+                <a:cs typeface="宋体"/>
+              </a:rPr>
+              <a:t>.specs/&lt;change-id&gt;/：单个 change 的全部产物目录</a:t>
+            </a:r>
+          </a:p>
+          <a:p>
+            <a:pPr algn="l">
+              <a:spcBef>
+                <a:spcPts val="200"/>
+              </a:spcBef>
+              <a:spcAft>
+                <a:spcPts val="500"/>
+              </a:spcAft>
+            </a:pPr>
+            <a:r>
               <a:rPr sz="1500" b="0">
                 <a:solidFill>
+                  <a:srgbClr val="6C757D"/>
+                </a:solidFill>
+                <a:latin typeface="Times New Roman"/>
+                <a:ea typeface="宋体"/>
+                <a:cs typeface="宋体"/>
+              </a:rPr>
+              <a:t>横向命令：I-intel / M-health / A-architect / A-evolve / L-restyle 独立于流水线</a:t>
+            </a:r>
+          </a:p>
+        </p:txBody>
+      </p:sp>
+    </p:spTree>
+  </p:cSld>
+  <p:clrMapOvr>
+    <a:masterClrMapping/>
+  </p:clrMapOvr>
+</p:sld>
+</file>
+
+<file path=ppt/slides/slide4.xml><?xml version="1.0" encoding="utf-8"?>
+<p:sld xmlns:a="http://schemas.openxmlformats.org/drawingml/2006/main" xmlns:p="http://schemas.openxmlformats.org/presentationml/2006/main" xmlns:r="http://schemas.openxmlformats.org/officeDocument/2006/relationships">
+  <p:cSld>
+    <p:spTree>
+      <p:nvGrpSpPr>
+        <p:cNvPr id="1" name=""/>
+        <p:cNvGrpSpPr/>
+        <p:nvPr/>
+      </p:nvGrpSpPr>
+      <p:grpSpPr/>
+      <p:sp>
+        <p:nvSpPr>
+          <p:cNvPr id="2" name="Rectangle 1"/>
+          <p:cNvSpPr/>
+          <p:nvPr/>
+        </p:nvSpPr>
+        <p:spPr>
+          <a:xfrm>
+            <a:off x="0" y="0"/>
+            <a:ext cx="12191695" cy="1051560"/>
+          </a:xfrm>
+          <a:prstGeom prst="rect">
+            <a:avLst/>
+          </a:prstGeom>
+          <a:solidFill>
+            <a:srgbClr val="1F3A5F"/>
+          </a:solidFill>
+          <a:ln>
+            <a:noFill/>
+          </a:ln>
+          <a:effectLst/>
+        </p:spPr>
+        <p:style>
+          <a:lnRef idx="1">
+            <a:schemeClr val="accent1"/>
+          </a:lnRef>
+          <a:fillRef idx="3">
+            <a:schemeClr val="accent1"/>
+          </a:fillRef>
+          <a:effectRef idx="2">
+            <a:schemeClr val="accent1"/>
+          </a:effectRef>
+          <a:fontRef idx="minor">
+            <a:schemeClr val="lt1"/>
+          </a:fontRef>
+        </p:style>
+        <p:txBody>
+          <a:bodyPr rtlCol="0" anchor="ctr"/>
+          <a:lstStyle/>
+          <a:p>
+            <a:pPr algn="ctr"/>
+          </a:p>
+        </p:txBody>
+      </p:sp>
+      <p:sp>
+        <p:nvSpPr>
+          <p:cNvPr id="3" name="TextBox 2"/>
+          <p:cNvSpPr txBox="1"/>
+          <p:nvPr/>
+        </p:nvSpPr>
+        <p:spPr>
+          <a:xfrm>
+            <a:off x="548640" y="73152"/>
+            <a:ext cx="11094415" cy="914400"/>
+          </a:xfrm>
+          <a:prstGeom prst="rect">
+            <a:avLst/>
+          </a:prstGeom>
+          <a:noFill/>
+        </p:spPr>
+        <p:txBody>
+          <a:bodyPr wrap="square" anchor="ctr">
+            <a:spAutoFit/>
+          </a:bodyPr>
+          <a:lstStyle/>
+          <a:p>
+            <a:pPr algn="l">
+              <a:spcAft>
+                <a:spcPts val="0"/>
+              </a:spcAft>
+            </a:pPr>
+            <a:r>
+              <a:rPr sz="3000" b="1">
+                <a:solidFill>
+                  <a:srgbClr val="FFFFFF"/>
+                </a:solidFill>
+                <a:latin typeface="Times New Roman"/>
+                <a:ea typeface="宋体"/>
+                <a:cs typeface="宋体"/>
+              </a:rPr>
+              <a:t>整体架构</a:t>
+            </a:r>
+          </a:p>
+          <a:p>
+            <a:pPr algn="l">
+              <a:spcBef>
+                <a:spcPts val="100"/>
+              </a:spcBef>
+              <a:spcAft>
+                <a:spcPts val="0"/>
+              </a:spcAft>
+            </a:pPr>
+            <a:r>
+              <a:rPr sz="1300" b="0">
+                <a:solidFill>
+                  <a:srgbClr val="A8C4E0"/>
+                </a:solidFill>
+                <a:latin typeface="Times New Roman"/>
+                <a:ea typeface="宋体"/>
+                <a:cs typeface="宋体"/>
+              </a:rPr>
+              <a:t>核心引擎是大脑，Hook 是运行时，技能是入口</a:t>
+            </a:r>
+          </a:p>
+        </p:txBody>
+      </p:sp>
+      <p:sp>
+        <p:nvSpPr>
+          <p:cNvPr id="4" name="TextBox 3"/>
+          <p:cNvSpPr txBox="1"/>
+          <p:nvPr/>
+        </p:nvSpPr>
+        <p:spPr>
+          <a:xfrm>
+            <a:off x="685800" y="1371600"/>
+            <a:ext cx="10820095" cy="5120640"/>
+          </a:xfrm>
+          <a:prstGeom prst="rect">
+            <a:avLst/>
+          </a:prstGeom>
+          <a:noFill/>
+        </p:spPr>
+        <p:txBody>
+          <a:bodyPr wrap="square" anchor="t">
+            <a:spAutoFit/>
+          </a:bodyPr>
+          <a:lstStyle/>
+          <a:p>
+            <a:pPr algn="l">
+              <a:spcBef>
+                <a:spcPts val="200"/>
+              </a:spcBef>
+              <a:spcAft>
+                <a:spcPts val="500"/>
+              </a:spcAft>
+            </a:pPr>
+            <a:r>
+              <a:rPr sz="1500" b="0">
+                <a:solidFill>
                   <a:srgbClr val="1F3A5F"/>
                 </a:solidFill>
                 <a:latin typeface="Times New Roman"/>
                 <a:ea typeface="宋体"/>
                 <a:cs typeface="宋体"/>
               </a:rPr>
+              <a:t>意图 → /flow-go 路由 → 阶段 prompt → 产物（.md）</a:t>
+            </a:r>
+          </a:p>
+          <a:p>
+            <a:pPr algn="l">
+              <a:spcBef>
+                <a:spcPts val="200"/>
+              </a:spcBef>
+              <a:spcAft>
+                <a:spcPts val="500"/>
+              </a:spcAft>
+            </a:pPr>
+            <a:r>
+              <a:rPr sz="1500" b="0">
+                <a:solidFill>
+                  <a:srgbClr val="1F3A5F"/>
+                </a:solidFill>
+                <a:latin typeface="Times New Roman"/>
+                <a:ea typeface="宋体"/>
+                <a:cs typeface="宋体"/>
+              </a:rPr>
+              <a:t>17 个 flow-* 技能将核心引擎暴露为斜杠命令（三平台同源；dsh 插件自动挂载）</a:t>
+            </a:r>
+          </a:p>
+          <a:p>
+            <a:pPr algn="l">
+              <a:spcBef>
+                <a:spcPts val="200"/>
+              </a:spcBef>
+              <a:spcAft>
+                <a:spcPts val="500"/>
+              </a:spcAft>
+            </a:pPr>
+            <a:r>
+              <a:rPr sz="1500" b="0">
+                <a:solidFill>
+                  <a:srgbClr val="2E86AB"/>
+                </a:solidFill>
+                <a:latin typeface="Times New Roman"/>
+                <a:ea typeface="宋体"/>
+                <a:cs typeface="宋体"/>
+              </a:rPr>
+              <a:t>Hook 运行时链：00-gate / 01-transcript + 20~34 逻辑模块 + 99-report</a:t>
+            </a:r>
+          </a:p>
+          <a:p>
+            <a:pPr algn="l">
+              <a:spcBef>
+                <a:spcPts val="200"/>
+              </a:spcBef>
+              <a:spcAft>
+                <a:spcPts val="500"/>
+              </a:spcAft>
+            </a:pPr>
+            <a:r>
+              <a:rPr sz="1500" b="0">
+                <a:solidFill>
+                  <a:srgbClr val="2E86AB"/>
+                </a:solidFill>
+                <a:latin typeface="Times New Roman"/>
+                <a:ea typeface="宋体"/>
+                <a:cs typeface="宋体"/>
+              </a:rPr>
+              <a:t>门禁：PreToolUse（independent-review gate + auto-checkpoint）· SessionStart（恢复/矫正/报告）· pre-commit（提交前全量门禁）</a:t>
+            </a:r>
+          </a:p>
+          <a:p>
+            <a:pPr algn="l">
+              <a:spcBef>
+                <a:spcPts val="200"/>
+              </a:spcBef>
+              <a:spcAft>
+                <a:spcPts val="500"/>
+              </a:spcAft>
+            </a:pPr>
+            <a:r>
+              <a:rPr sz="1500" b="0">
+                <a:solidFill>
+                  <a:srgbClr val="1F3A5F"/>
+                </a:solidFill>
+                <a:latin typeface="Times New Roman"/>
+                <a:ea typeface="宋体"/>
+                <a:cs typeface="宋体"/>
+              </a:rPr>
+              <a:t>独立审查：L2 子代理盲审 + L3 外部模型（gate_config 按阶段开启）</a:t>
+            </a:r>
+          </a:p>
+        </p:txBody>
+      </p:sp>
+    </p:spTree>
+  </p:cSld>
+  <p:clrMapOvr>
+    <a:masterClrMapping/>
+  </p:clrMapOvr>
+</p:sld>
+</file>
+
+<file path=ppt/slides/slide5.xml><?xml version="1.0" encoding="utf-8"?>
+<p:sld xmlns:a="http://schemas.openxmlformats.org/drawingml/2006/main" xmlns:p="http://schemas.openxmlformats.org/presentationml/2006/main" xmlns:r="http://schemas.openxmlformats.org/officeDocument/2006/relationships">
+  <p:cSld>
+    <p:spTree>
+      <p:nvGrpSpPr>
+        <p:cNvPr id="1" name=""/>
+        <p:cNvGrpSpPr/>
+        <p:nvPr/>
+      </p:nvGrpSpPr>
+      <p:grpSpPr/>
+      <p:sp>
+        <p:nvSpPr>
+          <p:cNvPr id="2" name="Rectangle 1"/>
+          <p:cNvSpPr/>
+          <p:nvPr/>
+        </p:nvSpPr>
+        <p:spPr>
+          <a:xfrm>
+            <a:off x="0" y="0"/>
+            <a:ext cx="12191695" cy="1051560"/>
+          </a:xfrm>
+          <a:prstGeom prst="rect">
+            <a:avLst/>
+          </a:prstGeom>
+          <a:solidFill>
+            <a:srgbClr val="1F3A5F"/>
+          </a:solidFill>
+          <a:ln>
+            <a:noFill/>
+          </a:ln>
+          <a:effectLst/>
+        </p:spPr>
+        <p:style>
+          <a:lnRef idx="1">
+            <a:schemeClr val="accent1"/>
+          </a:lnRef>
+          <a:fillRef idx="3">
+            <a:schemeClr val="accent1"/>
+          </a:fillRef>
+          <a:effectRef idx="2">
+            <a:schemeClr val="accent1"/>
+          </a:effectRef>
+          <a:fontRef idx="minor">
+            <a:schemeClr val="lt1"/>
+          </a:fontRef>
+        </p:style>
+        <p:txBody>
+          <a:bodyPr rtlCol="0" anchor="ctr"/>
+          <a:lstStyle/>
+          <a:p>
+            <a:pPr algn="ctr"/>
+          </a:p>
+        </p:txBody>
+      </p:sp>
+      <p:sp>
+        <p:nvSpPr>
+          <p:cNvPr id="3" name="TextBox 2"/>
+          <p:cNvSpPr txBox="1"/>
+          <p:nvPr/>
+        </p:nvSpPr>
+        <p:spPr>
+          <a:xfrm>
+            <a:off x="548640" y="73152"/>
+            <a:ext cx="11094415" cy="914400"/>
+          </a:xfrm>
+          <a:prstGeom prst="rect">
+            <a:avLst/>
+          </a:prstGeom>
+          <a:noFill/>
+        </p:spPr>
+        <p:txBody>
+          <a:bodyPr wrap="square" anchor="ctr">
+            <a:spAutoFit/>
+          </a:bodyPr>
+          <a:lstStyle/>
+          <a:p>
+            <a:pPr algn="l">
+              <a:spcAft>
+                <a:spcPts val="0"/>
+              </a:spcAft>
+            </a:pPr>
+            <a:r>
+              <a:rPr sz="3000" b="1">
+                <a:solidFill>
+                  <a:srgbClr val="FFFFFF"/>
+                </a:solidFill>
+                <a:latin typeface="Times New Roman"/>
+                <a:ea typeface="宋体"/>
+                <a:cs typeface="宋体"/>
+              </a:rPr>
+              <a:t>两大命令：/flow-go vs /flow</a:t>
+            </a:r>
+          </a:p>
+          <a:p>
+            <a:pPr algn="l">
+              <a:spcBef>
+                <a:spcPts val="100"/>
+              </a:spcBef>
+              <a:spcAft>
+                <a:spcPts val="0"/>
+              </a:spcAft>
+            </a:pPr>
+            <a:r>
+              <a:rPr sz="1300" b="0">
+                <a:solidFill>
+                  <a:srgbClr val="A8C4E0"/>
+                </a:solidFill>
+                <a:latin typeface="Times New Roman"/>
+                <a:ea typeface="宋体"/>
+                <a:cs typeface="宋体"/>
+              </a:rPr>
+              <a:t>统一入口（自动路由） vs 状态管理（手动操作）</a:t>
+            </a:r>
+          </a:p>
+        </p:txBody>
+      </p:sp>
+      <p:sp>
+        <p:nvSpPr>
+          <p:cNvPr id="4" name="TextBox 3"/>
+          <p:cNvSpPr txBox="1"/>
+          <p:nvPr/>
+        </p:nvSpPr>
+        <p:spPr>
+          <a:xfrm>
+            <a:off x="685800" y="1371600"/>
+            <a:ext cx="10820095" cy="5120640"/>
+          </a:xfrm>
+          <a:prstGeom prst="rect">
+            <a:avLst/>
+          </a:prstGeom>
+          <a:noFill/>
+        </p:spPr>
+        <p:txBody>
+          <a:bodyPr wrap="square" anchor="t">
+            <a:spAutoFit/>
+          </a:bodyPr>
+          <a:lstStyle/>
+          <a:p>
+            <a:pPr algn="l">
+              <a:spcBef>
+                <a:spcPts val="200"/>
+              </a:spcBef>
+              <a:spcAft>
+                <a:spcPts val="500"/>
+              </a:spcAft>
+            </a:pPr>
+            <a:r>
+              <a:rPr sz="1500" b="0">
+                <a:solidFill>
+                  <a:srgbClr val="1F3A5F"/>
+                </a:solidFill>
+                <a:latin typeface="Times New Roman"/>
+                <a:ea typeface="宋体"/>
+                <a:cs typeface="宋体"/>
+              </a:rPr>
+              <a:t>/flow-go — 描述意图自动路由：新需求→阶段 0；继续→阶段 4；需求/设计/测试/归档等关键词直达</a:t>
+            </a:r>
+          </a:p>
+          <a:p>
+            <a:pPr algn="l">
+              <a:spcBef>
+                <a:spcPts val="200"/>
+              </a:spcBef>
+              <a:spcAft>
+                <a:spcPts val="500"/>
+              </a:spcAft>
+            </a:pPr>
+            <a:r>
+              <a:rPr sz="1500" b="0">
+                <a:solidFill>
+                  <a:srgbClr val="1F3A5F"/>
+                </a:solidFill>
+                <a:latin typeface="Times New Roman"/>
+                <a:ea typeface="宋体"/>
+                <a:cs typeface="宋体"/>
+              </a:rPr>
+              <a:t>/flow — 状态管理子命令</a:t>
+            </a:r>
+          </a:p>
+          <a:p>
+            <a:pPr algn="l" lvl="1">
+              <a:spcBef>
+                <a:spcPts val="200"/>
+              </a:spcBef>
+              <a:spcAft>
+                <a:spcPts val="500"/>
+              </a:spcAft>
+            </a:pPr>
+            <a:r>
+              <a:rPr sz="1600" b="0">
+                <a:solidFill>
+                  <a:srgbClr val="2E86AB"/>
+                </a:solidFill>
+                <a:latin typeface="Times New Roman"/>
+                <a:ea typeface="宋体"/>
+                <a:cs typeface="宋体"/>
+              </a:rPr>
+              <a:t>start / stop / phase &lt;n&gt; / task &lt;Tn&gt; / goal / goal clear</a:t>
+            </a:r>
+          </a:p>
+          <a:p>
+            <a:pPr algn="l" lvl="1">
+              <a:spcBef>
+                <a:spcPts val="200"/>
+              </a:spcBef>
+              <a:spcAft>
+                <a:spcPts val="500"/>
+              </a:spcAft>
+            </a:pPr>
+            <a:r>
+              <a:rPr sz="1600" b="0">
+                <a:solidFill>
+                  <a:srgbClr val="2E86AB"/>
+                </a:solidFill>
+                <a:latin typeface="Times New Roman"/>
+                <a:ea typeface="宋体"/>
+                <a:cs typeface="宋体"/>
+              </a:rPr>
+              <a:t>checkpoint &lt;file&gt; &lt;desc&gt; — 中断恢复点</a:t>
+            </a:r>
+          </a:p>
+          <a:p>
+            <a:pPr algn="l" lvl="1">
+              <a:spcBef>
+                <a:spcPts val="200"/>
+              </a:spcBef>
+              <a:spcAft>
+                <a:spcPts val="500"/>
+              </a:spcAft>
+            </a:pPr>
+            <a:r>
+              <a:rPr sz="1600" b="0">
+                <a:solidFill>
+                  <a:srgbClr val="2E86AB"/>
+                </a:solidFill>
+                <a:latin typeface="Times New Roman"/>
+                <a:ea typeface="宋体"/>
+                <a:cs typeface="宋体"/>
+              </a:rPr>
+              <a:t>doctor — .flow-active 完整性 + correction 卫生报告（type/violations 去重，check→rule 回退）</a:t>
+            </a:r>
+          </a:p>
+          <a:p>
+            <a:pPr algn="l" lvl="1">
+              <a:spcBef>
+                <a:spcPts val="200"/>
+              </a:spcBef>
+              <a:spcAft>
+                <a:spcPts val="500"/>
+              </a:spcAft>
+            </a:pPr>
+            <a:r>
+              <a:rPr sz="1600" b="0">
+                <a:solidFill>
+                  <a:srgbClr val="2E86AB"/>
+                </a:solidFill>
+                <a:latin typeface="Times New Roman"/>
+                <a:ea typeface="宋体"/>
+                <a:cs typeface="宋体"/>
+              </a:rPr>
+              <a:t>model — 五级链配置：l2=/l3= 显式字段，l2-default=/l3-default= 站点默认，--clear 清除</a:t>
+            </a:r>
+          </a:p>
+          <a:p>
+            <a:pPr algn="l" lvl="1">
+              <a:spcBef>
+                <a:spcPts val="200"/>
+              </a:spcBef>
+              <a:spcAft>
+                <a:spcPts val="500"/>
+              </a:spcAft>
+            </a:pPr>
+            <a:r>
+              <a:rPr sz="1600" b="0">
+                <a:solidFill>
+                  <a:srgbClr val="2E86AB"/>
+                </a:solidFill>
+                <a:latin typeface="Times New Roman"/>
+                <a:ea typeface="宋体"/>
+                <a:cs typeface="宋体"/>
+              </a:rPr>
+              <a:t>gate-config — 按阶段开关独立审查（both/L2/L3/off；旧值 independent/true 自动映射为 both）</a:t>
+            </a:r>
+          </a:p>
+        </p:txBody>
+      </p:sp>
+    </p:spTree>
+  </p:cSld>
+  <p:clrMapOvr>
+    <a:masterClrMapping/>
+  </p:clrMapOvr>
+</p:sld>
+</file>
+
+<file path=ppt/slides/slide6.xml><?xml version="1.0" encoding="utf-8"?>
+<p:sld xmlns:a="http://schemas.openxmlformats.org/drawingml/2006/main" xmlns:p="http://schemas.openxmlformats.org/presentationml/2006/main" xmlns:r="http://schemas.openxmlformats.org/officeDocument/2006/relationships">
+  <p:cSld>
+    <p:spTree>
+      <p:nvGrpSpPr>
+        <p:cNvPr id="1" name=""/>
+        <p:cNvGrpSpPr/>
+        <p:nvPr/>
+      </p:nvGrpSpPr>
+      <p:grpSpPr/>
+      <p:sp>
+        <p:nvSpPr>
+          <p:cNvPr id="2" name="Rectangle 1"/>
+          <p:cNvSpPr/>
+          <p:nvPr/>
+        </p:nvSpPr>
+        <p:spPr>
+          <a:xfrm>
+            <a:off x="0" y="0"/>
+            <a:ext cx="12191695" cy="1051560"/>
+          </a:xfrm>
+          <a:prstGeom prst="rect">
+            <a:avLst/>
+          </a:prstGeom>
+          <a:solidFill>
+            <a:srgbClr val="1F3A5F"/>
+          </a:solidFill>
+          <a:ln>
+            <a:noFill/>
+          </a:ln>
+          <a:effectLst/>
+        </p:spPr>
+        <p:style>
+          <a:lnRef idx="1">
+            <a:schemeClr val="accent1"/>
+          </a:lnRef>
+          <a:fillRef idx="3">
+            <a:schemeClr val="accent1"/>
+          </a:fillRef>
+          <a:effectRef idx="2">
+            <a:schemeClr val="accent1"/>
+          </a:effectRef>
+          <a:fontRef idx="minor">
+            <a:schemeClr val="lt1"/>
+          </a:fontRef>
+        </p:style>
+        <p:txBody>
+          <a:bodyPr rtlCol="0" anchor="ctr"/>
+          <a:lstStyle/>
+          <a:p>
+            <a:pPr algn="ctr"/>
+          </a:p>
+        </p:txBody>
+      </p:sp>
+      <p:sp>
+        <p:nvSpPr>
+          <p:cNvPr id="3" name="TextBox 2"/>
+          <p:cNvSpPr txBox="1"/>
+          <p:nvPr/>
+        </p:nvSpPr>
+        <p:spPr>
+          <a:xfrm>
+            <a:off x="548640" y="73152"/>
+            <a:ext cx="11094415" cy="914400"/>
+          </a:xfrm>
+          <a:prstGeom prst="rect">
+            <a:avLst/>
+          </a:prstGeom>
+          <a:noFill/>
+        </p:spPr>
+        <p:txBody>
+          <a:bodyPr wrap="square" anchor="ctr">
+            <a:spAutoFit/>
+          </a:bodyPr>
+          <a:lstStyle/>
+          <a:p>
+            <a:pPr algn="l">
+              <a:spcAft>
+                <a:spcPts val="0"/>
+              </a:spcAft>
+            </a:pPr>
+            <a:r>
+              <a:rPr sz="3000" b="1">
+                <a:solidFill>
+                  <a:srgbClr val="FFFFFF"/>
+                </a:solidFill>
+                <a:latin typeface="Times New Roman"/>
+                <a:ea typeface="宋体"/>
+                <a:cs typeface="宋体"/>
+              </a:rPr>
+              <a:t>8 阶段流水线总览</a:t>
+            </a:r>
+          </a:p>
+          <a:p>
+            <a:pPr algn="l">
+              <a:spcBef>
+                <a:spcPts val="100"/>
+              </a:spcBef>
+              <a:spcAft>
+                <a:spcPts val="0"/>
+              </a:spcAft>
+            </a:pPr>
+            <a:r>
+              <a:rPr sz="1300" b="0">
+                <a:solidFill>
+                  <a:srgbClr val="A8C4E0"/>
+                </a:solidFill>
+                <a:latin typeface="Times New Roman"/>
+                <a:ea typeface="宋体"/>
+                <a:cs typeface="宋体"/>
+              </a:rPr>
+              <a:t>每个阶段产出明确产物，经 Toll-Gate 进入下一阶段</a:t>
+            </a:r>
+          </a:p>
+        </p:txBody>
+      </p:sp>
+      <p:sp>
+        <p:nvSpPr>
+          <p:cNvPr id="4" name="TextBox 3"/>
+          <p:cNvSpPr txBox="1"/>
+          <p:nvPr/>
+        </p:nvSpPr>
+        <p:spPr>
+          <a:xfrm>
+            <a:off x="685800" y="1371600"/>
+            <a:ext cx="10820095" cy="5120640"/>
+          </a:xfrm>
+          <a:prstGeom prst="rect">
+            <a:avLst/>
+          </a:prstGeom>
+          <a:noFill/>
+        </p:spPr>
+        <p:txBody>
+          <a:bodyPr wrap="square" anchor="t">
+            <a:spAutoFit/>
+          </a:bodyPr>
+          <a:lstStyle/>
+          <a:p>
+            <a:pPr algn="l">
+              <a:spcBef>
+                <a:spcPts val="200"/>
+              </a:spcBef>
+              <a:spcAft>
+                <a:spcPts val="500"/>
+              </a:spcAft>
+            </a:pPr>
+            <a:r>
+              <a:rPr sz="1500" b="0">
+                <a:solidFill>
+                  <a:srgbClr val="1F3A5F"/>
+                </a:solidFill>
+                <a:latin typeface="Times New Roman"/>
+                <a:ea typeface="宋体"/>
+                <a:cs typeface="宋体"/>
+              </a:rPr>
               <a:t>0 CHANGE（提案）→ 1 REQUIREMENT（需求）→ 2 DESIGN（设计）→ 2a UI-DESIGN（前端项目）</a:t>
             </a:r>
           </a:p>
@@ -7360,7 +8666,7 @@
                 <a:ea typeface="宋体"/>
                 <a:cs typeface="宋体"/>
               </a:rPr>
-              <a:t>阶段 7 含 pre-commit 门禁与 34 号 archive-commit 归档核对</a:t>
+              <a:t>阶段 7 含 pre-commit 门禁与 34 号 archive-commit 归档后未提交检测</a:t>
             </a:r>
           </a:p>
         </p:txBody>

</xml_diff>